<commit_message>
slides(2-2-Modeling-1): author's PowerPoint edits
Opened and edited in PowerPoint (lastModifiedBy: James C Davis, 12:42Z).
Content changes on slides 1, 17, 27, 29, 30, 32: the closing teaser
rewritten, PROPERTY label on 17, the 50 ms latency terms on 27, model and
representation definitions on 29, the interpretation-vs-realization
clauses on 30, and the two closing questions on 32.

Also a full PowerPoint re-save: 167 parts rewritten, slide-number field
caches recomputed from the build-time placeholder.

Co-Authored-By: Claude Opus 5 <noreply@anthropic.com>
</commit_message>
<xml_diff>
--- a/course/lectures/act-2-delegation-and-control/02-modeling/2-2-Modeling-1-Purposeful-Reduction.pptx
+++ b/course/lectures/act-2-delegation-and-control/02-modeling/2-2-Modeling-1-Purposeful-Reduction.pptx
@@ -5,41 +5,41 @@
     <p:sldMasterId id="2147483708" r:id="rId1"/>
   </p:sldMasterIdLst>
   <p:notesMasterIdLst>
-    <p:notesMasterId r:id="rId43"/>
+    <p:notesMasterId r:id="rId34"/>
   </p:notesMasterIdLst>
   <p:sldIdLst>
-    <p:sldId id="701" r:id="rId48"/>
-    <p:sldId id="702" r:id="rId49"/>
-    <p:sldId id="703" r:id="rId50"/>
-    <p:sldId id="704" r:id="rId51"/>
-    <p:sldId id="705" r:id="rId52"/>
-    <p:sldId id="706" r:id="rId53"/>
-    <p:sldId id="707" r:id="rId54"/>
-    <p:sldId id="708" r:id="rId55"/>
-    <p:sldId id="709" r:id="rId56"/>
-    <p:sldId id="710" r:id="rId57"/>
-    <p:sldId id="711" r:id="rId58"/>
-    <p:sldId id="712" r:id="rId59"/>
-    <p:sldId id="713" r:id="rId60"/>
-    <p:sldId id="714" r:id="rId61"/>
-    <p:sldId id="715" r:id="rId62"/>
-    <p:sldId id="716" r:id="rId63"/>
-    <p:sldId id="717" r:id="rId64"/>
-    <p:sldId id="718" r:id="rId65"/>
-    <p:sldId id="719" r:id="rId66"/>
-    <p:sldId id="720" r:id="rId67"/>
-    <p:sldId id="721" r:id="rId68"/>
-    <p:sldId id="722" r:id="rId69"/>
-    <p:sldId id="723" r:id="rId70"/>
-    <p:sldId id="724" r:id="rId71"/>
-    <p:sldId id="725" r:id="rId72"/>
-    <p:sldId id="726" r:id="rId73"/>
-    <p:sldId id="727" r:id="rId74"/>
-    <p:sldId id="728" r:id="rId75"/>
-    <p:sldId id="729" r:id="rId76"/>
-    <p:sldId id="730" r:id="rId77"/>
-    <p:sldId id="731" r:id="rId78"/>
-    <p:sldId id="732" r:id="rId79"/>
+    <p:sldId id="701" r:id="rId2"/>
+    <p:sldId id="702" r:id="rId3"/>
+    <p:sldId id="703" r:id="rId4"/>
+    <p:sldId id="704" r:id="rId5"/>
+    <p:sldId id="705" r:id="rId6"/>
+    <p:sldId id="706" r:id="rId7"/>
+    <p:sldId id="707" r:id="rId8"/>
+    <p:sldId id="708" r:id="rId9"/>
+    <p:sldId id="709" r:id="rId10"/>
+    <p:sldId id="710" r:id="rId11"/>
+    <p:sldId id="711" r:id="rId12"/>
+    <p:sldId id="712" r:id="rId13"/>
+    <p:sldId id="713" r:id="rId14"/>
+    <p:sldId id="714" r:id="rId15"/>
+    <p:sldId id="715" r:id="rId16"/>
+    <p:sldId id="716" r:id="rId17"/>
+    <p:sldId id="717" r:id="rId18"/>
+    <p:sldId id="718" r:id="rId19"/>
+    <p:sldId id="719" r:id="rId20"/>
+    <p:sldId id="720" r:id="rId21"/>
+    <p:sldId id="721" r:id="rId22"/>
+    <p:sldId id="722" r:id="rId23"/>
+    <p:sldId id="723" r:id="rId24"/>
+    <p:sldId id="724" r:id="rId25"/>
+    <p:sldId id="725" r:id="rId26"/>
+    <p:sldId id="726" r:id="rId27"/>
+    <p:sldId id="727" r:id="rId28"/>
+    <p:sldId id="728" r:id="rId29"/>
+    <p:sldId id="729" r:id="rId30"/>
+    <p:sldId id="730" r:id="rId31"/>
+    <p:sldId id="731" r:id="rId32"/>
+    <p:sldId id="732" r:id="rId33"/>
   </p:sldIdLst>
   <p:sldSz cx="9144000" cy="6858000" type="screen4x3"/>
   <p:notesSz cx="6858000" cy="9144000"/>
@@ -230,7 +230,7 @@
           </a:lstStyle>
           <a:p>
             <a:fld id="{27E8B4C4-0720-F64E-9EEE-9472CF165DC6}" type="datetimeFigureOut">
-              <a:t>9/29/26</a:t>
+              <a:t>9/30/26</a:t>
             </a:fld>
             <a:endParaRPr lang="en-US"/>
           </a:p>
@@ -4823,7 +4823,7 @@
             </a:r>
             <a:r>
               <a:rPr lang="en-US" b="1" u="none" dirty="0"/>
-              <a:t xml:space="preserve">		Details</a:t>
+              <a:t>		Details</a:t>
             </a:r>
           </a:p>
           <a:p>
@@ -5000,7 +5000,7 @@
             </a:r>
             <a:r>
               <a:rPr lang="en-US" b="1" u="none" dirty="0"/>
-              <a:t xml:space="preserve">		Details</a:t>
+              <a:t>		Details</a:t>
             </a:r>
           </a:p>
           <a:p>
@@ -5960,6 +5960,13 @@
             <a:noFill/>
           </a:ln>
         </p:spPr>
+        <p:txBody>
+          <a:bodyPr/>
+          <a:lstStyle/>
+          <a:p>
+            <a:endParaRPr lang="en-US"/>
+          </a:p>
+        </p:txBody>
       </p:sp>
       <p:sp>
         <p:nvSpPr>
@@ -5982,6 +5989,13 @@
             <a:noFill/>
           </a:ln>
         </p:spPr>
+        <p:txBody>
+          <a:bodyPr/>
+          <a:lstStyle/>
+          <a:p>
+            <a:endParaRPr lang="en-US"/>
+          </a:p>
+        </p:txBody>
       </p:sp>
       <p:sp>
         <p:nvSpPr>
@@ -6004,6 +6018,13 @@
             <a:noFill/>
           </a:ln>
         </p:spPr>
+        <p:txBody>
+          <a:bodyPr/>
+          <a:lstStyle/>
+          <a:p>
+            <a:endParaRPr lang="en-US"/>
+          </a:p>
+        </p:txBody>
       </p:sp>
       <p:sp>
         <p:nvSpPr>
@@ -6026,6 +6047,13 @@
             <a:noFill/>
           </a:ln>
         </p:spPr>
+        <p:txBody>
+          <a:bodyPr/>
+          <a:lstStyle/>
+          <a:p>
+            <a:endParaRPr lang="en-US"/>
+          </a:p>
+        </p:txBody>
       </p:sp>
       <p:sp>
         <p:nvSpPr>
@@ -6048,6 +6076,13 @@
             <a:noFill/>
           </a:ln>
         </p:spPr>
+        <p:txBody>
+          <a:bodyPr/>
+          <a:lstStyle/>
+          <a:p>
+            <a:endParaRPr lang="en-US"/>
+          </a:p>
+        </p:txBody>
       </p:sp>
       <p:sp>
         <p:nvSpPr>
@@ -6070,6 +6105,13 @@
             <a:noFill/>
           </a:ln>
         </p:spPr>
+        <p:txBody>
+          <a:bodyPr/>
+          <a:lstStyle/>
+          <a:p>
+            <a:endParaRPr lang="en-US"/>
+          </a:p>
+        </p:txBody>
       </p:sp>
       <p:sp>
         <p:nvSpPr>
@@ -6092,6 +6134,13 @@
             <a:noFill/>
           </a:ln>
         </p:spPr>
+        <p:txBody>
+          <a:bodyPr/>
+          <a:lstStyle/>
+          <a:p>
+            <a:endParaRPr lang="en-US"/>
+          </a:p>
+        </p:txBody>
       </p:sp>
       <p:sp>
         <p:nvSpPr>
@@ -6114,6 +6163,13 @@
             <a:noFill/>
           </a:ln>
         </p:spPr>
+        <p:txBody>
+          <a:bodyPr/>
+          <a:lstStyle/>
+          <a:p>
+            <a:endParaRPr lang="en-US"/>
+          </a:p>
+        </p:txBody>
       </p:sp>
       <p:sp>
         <p:nvSpPr>
@@ -6136,6 +6192,13 @@
             <a:noFill/>
           </a:ln>
         </p:spPr>
+        <p:txBody>
+          <a:bodyPr/>
+          <a:lstStyle/>
+          <a:p>
+            <a:endParaRPr lang="en-US"/>
+          </a:p>
+        </p:txBody>
       </p:sp>
       <p:sp>
         <p:nvSpPr>
@@ -6158,6 +6221,13 @@
             <a:noFill/>
           </a:ln>
         </p:spPr>
+        <p:txBody>
+          <a:bodyPr/>
+          <a:lstStyle/>
+          <a:p>
+            <a:endParaRPr lang="en-US"/>
+          </a:p>
+        </p:txBody>
       </p:sp>
       <p:sp>
         <p:nvSpPr>
@@ -6180,6 +6250,13 @@
             <a:noFill/>
           </a:ln>
         </p:spPr>
+        <p:txBody>
+          <a:bodyPr/>
+          <a:lstStyle/>
+          <a:p>
+            <a:endParaRPr lang="en-US"/>
+          </a:p>
+        </p:txBody>
       </p:sp>
       <p:sp>
         <p:nvSpPr>
@@ -6202,6 +6279,13 @@
             <a:noFill/>
           </a:ln>
         </p:spPr>
+        <p:txBody>
+          <a:bodyPr/>
+          <a:lstStyle/>
+          <a:p>
+            <a:endParaRPr lang="en-US"/>
+          </a:p>
+        </p:txBody>
       </p:sp>
       <p:cxnSp>
         <p:nvCxnSpPr>
@@ -6246,6 +6330,13 @@
             <a:noFill/>
           </a:ln>
         </p:spPr>
+        <p:txBody>
+          <a:bodyPr/>
+          <a:lstStyle/>
+          <a:p>
+            <a:endParaRPr lang="en-US"/>
+          </a:p>
+        </p:txBody>
       </p:sp>
       <p:sp>
         <p:nvSpPr>
@@ -6268,6 +6359,13 @@
             <a:noFill/>
           </a:ln>
         </p:spPr>
+        <p:txBody>
+          <a:bodyPr/>
+          <a:lstStyle/>
+          <a:p>
+            <a:endParaRPr lang="en-US"/>
+          </a:p>
+        </p:txBody>
       </p:sp>
       <p:sp>
         <p:nvSpPr>
@@ -6290,6 +6388,13 @@
             <a:noFill/>
           </a:ln>
         </p:spPr>
+        <p:txBody>
+          <a:bodyPr/>
+          <a:lstStyle/>
+          <a:p>
+            <a:endParaRPr lang="en-US"/>
+          </a:p>
+        </p:txBody>
       </p:sp>
       <p:sp>
         <p:nvSpPr>
@@ -6312,6 +6417,13 @@
             <a:noFill/>
           </a:ln>
         </p:spPr>
+        <p:txBody>
+          <a:bodyPr/>
+          <a:lstStyle/>
+          <a:p>
+            <a:endParaRPr lang="en-US"/>
+          </a:p>
+        </p:txBody>
       </p:sp>
       <p:sp>
         <p:nvSpPr>
@@ -6345,7 +6457,39 @@
                   <a:srgbClr val="555960"/>
                 </a:solidFill>
               </a:rPr>
-              <a:t>Lecture 1 of 2: one model, one question.</a:t>
+              <a:t>Lecture 1 </a:t>
+            </a:r>
+            <a:r>
+              <a:rPr lang="en-US" sz="2000" dirty="0">
+                <a:solidFill>
+                  <a:srgbClr val="555960"/>
+                </a:solidFill>
+              </a:rPr>
+              <a:t>(today)</a:t>
+            </a:r>
+            <a:r>
+              <a:rPr lang="en-US" sz="2000" b="0" i="0" dirty="0">
+                <a:solidFill>
+                  <a:srgbClr val="555960"/>
+                </a:solidFill>
+              </a:rPr>
+              <a:t>: </a:t>
+            </a:r>
+            <a:r>
+              <a:rPr lang="en-US" sz="2000" dirty="0">
+                <a:solidFill>
+                  <a:srgbClr val="555960"/>
+                </a:solidFill>
+              </a:rPr>
+              <a:t>O</a:t>
+            </a:r>
+            <a:r>
+              <a:rPr lang="en-US" sz="2000" b="0" i="0" dirty="0">
+                <a:solidFill>
+                  <a:srgbClr val="555960"/>
+                </a:solidFill>
+              </a:rPr>
+              <a:t>ne model, one question.</a:t>
             </a:r>
           </a:p>
           <a:p>
@@ -6361,7 +6505,7 @@
                   <a:srgbClr val="555960"/>
                 </a:solidFill>
               </a:rPr>
-              <a:t>Lecture 2 turns to systems of many models.</a:t>
+              <a:t>Lecture 2: Modeling larger systems</a:t>
             </a:r>
           </a:p>
         </p:txBody>
@@ -6432,7 +6576,7 @@
           <a:p>
             <a:fld id="{B7EB45DA-9A0D-DC49-8E02-F30A5DDC21C3}" type="slidenum">
               <a:rPr lang="en-US" smtClean="0"/>
-              <a:t>1</a:t>
+              <a:t>10</a:t>
             </a:fld>
             <a:endParaRPr lang="en-US"/>
           </a:p>
@@ -6926,7 +7070,7 @@
           <a:p>
             <a:fld id="{B7EB45DA-9A0D-DC49-8E02-F30A5DDC21C3}" type="slidenum">
               <a:rPr lang="en-US" smtClean="0"/>
-              <a:t>1</a:t>
+              <a:t>11</a:t>
             </a:fld>
             <a:endParaRPr lang="en-US"/>
           </a:p>
@@ -8441,7 +8585,7 @@
           <a:p>
             <a:fld id="{B7EB45DA-9A0D-DC49-8E02-F30A5DDC21C3}" type="slidenum">
               <a:rPr lang="en-US" smtClean="0"/>
-              <a:t>1</a:t>
+              <a:t>12</a:t>
             </a:fld>
             <a:endParaRPr lang="en-US"/>
           </a:p>
@@ -9547,7 +9691,7 @@
           <a:p>
             <a:fld id="{B7EB45DA-9A0D-DC49-8E02-F30A5DDC21C3}" type="slidenum">
               <a:rPr lang="en-US" smtClean="0"/>
-              <a:t>1</a:t>
+              <a:t>13</a:t>
             </a:fld>
             <a:endParaRPr lang="en-US"/>
           </a:p>
@@ -9916,7 +10060,7 @@
           <a:p>
             <a:fld id="{B7EB45DA-9A0D-DC49-8E02-F30A5DDC21C3}" type="slidenum">
               <a:rPr lang="en-US" smtClean="0"/>
-              <a:t>1</a:t>
+              <a:t>14</a:t>
             </a:fld>
             <a:endParaRPr lang="en-US"/>
           </a:p>
@@ -10288,7 +10432,7 @@
           <a:p>
             <a:fld id="{B7EB45DA-9A0D-DC49-8E02-F30A5DDC21C3}" type="slidenum">
               <a:rPr lang="en-US" smtClean="0"/>
-              <a:t>1</a:t>
+              <a:t>15</a:t>
             </a:fld>
             <a:endParaRPr lang="en-US"/>
           </a:p>
@@ -10623,6 +10767,7 @@
               </a:spcAft>
               <a:buNone/>
             </a:pPr>
+            <a:endParaRPr/>
           </a:p>
         </p:txBody>
       </p:sp>
@@ -10657,6 +10802,7 @@
               </a:spcAft>
               <a:buNone/>
             </a:pPr>
+            <a:endParaRPr/>
           </a:p>
         </p:txBody>
       </p:sp>
@@ -10691,6 +10837,7 @@
               </a:spcAft>
               <a:buNone/>
             </a:pPr>
+            <a:endParaRPr/>
           </a:p>
         </p:txBody>
       </p:sp>
@@ -11007,7 +11154,7 @@
           <a:p>
             <a:fld id="{B7EB45DA-9A0D-DC49-8E02-F30A5DDC21C3}" type="slidenum">
               <a:rPr lang="en-US" smtClean="0"/>
-              <a:t>1</a:t>
+              <a:t>16</a:t>
             </a:fld>
             <a:endParaRPr lang="en-US"/>
           </a:p>
@@ -11452,6 +11599,7 @@
               </a:spcAft>
               <a:buNone/>
             </a:pPr>
+            <a:endParaRPr/>
           </a:p>
         </p:txBody>
       </p:sp>
@@ -11791,7 +11939,7 @@
           <a:p>
             <a:fld id="{B7EB45DA-9A0D-DC49-8E02-F30A5DDC21C3}" type="slidenum">
               <a:rPr lang="en-US" smtClean="0"/>
-              <a:t>1</a:t>
+              <a:t>17</a:t>
             </a:fld>
             <a:endParaRPr lang="en-US"/>
           </a:p>
@@ -12528,7 +12676,7 @@
                   <a:srgbClr val="8E6F3E"/>
                 </a:solidFill>
               </a:rPr>
-              <a:t xml:space="preserve">PROPERTY:  </a:t>
+              <a:t>PROPERTY:  </a:t>
             </a:r>
             <a:r>
               <a:rPr lang="en-US" sz="2200" b="1" dirty="0">
@@ -12649,7 +12797,7 @@
           <a:p>
             <a:fld id="{B7EB45DA-9A0D-DC49-8E02-F30A5DDC21C3}" type="slidenum">
               <a:rPr lang="en-US" smtClean="0"/>
-              <a:t>1</a:t>
+              <a:t>18</a:t>
             </a:fld>
             <a:endParaRPr lang="en-US"/>
           </a:p>
@@ -13465,7 +13613,7 @@
           <a:p>
             <a:fld id="{B7EB45DA-9A0D-DC49-8E02-F30A5DDC21C3}" type="slidenum">
               <a:rPr lang="en-US" smtClean="0"/>
-              <a:t>1</a:t>
+              <a:t>19</a:t>
             </a:fld>
             <a:endParaRPr lang="en-US"/>
           </a:p>
@@ -14266,7 +14414,7 @@
           <a:p>
             <a:fld id="{B7EB45DA-9A0D-DC49-8E02-F30A5DDC21C3}" type="slidenum">
               <a:rPr lang="en-US" smtClean="0"/>
-              <a:t>1</a:t>
+              <a:t>2</a:t>
             </a:fld>
             <a:endParaRPr lang="en-US"/>
           </a:p>
@@ -14549,6 +14697,13 @@
             <a:prstDash val="dash"/>
           </a:ln>
         </p:spPr>
+        <p:txBody>
+          <a:bodyPr/>
+          <a:lstStyle/>
+          <a:p>
+            <a:endParaRPr lang="en-US"/>
+          </a:p>
+        </p:txBody>
       </p:sp>
       <p:sp>
         <p:nvSpPr>
@@ -14816,7 +14971,7 @@
           <a:p>
             <a:fld id="{B7EB45DA-9A0D-DC49-8E02-F30A5DDC21C3}" type="slidenum">
               <a:rPr lang="en-US" smtClean="0"/>
-              <a:t>1</a:t>
+              <a:t>20</a:t>
             </a:fld>
             <a:endParaRPr lang="en-US"/>
           </a:p>
@@ -15305,7 +15460,7 @@
           <a:p>
             <a:fld id="{B7EB45DA-9A0D-DC49-8E02-F30A5DDC21C3}" type="slidenum">
               <a:rPr lang="en-US" smtClean="0"/>
-              <a:t>1</a:t>
+              <a:t>21</a:t>
             </a:fld>
             <a:endParaRPr lang="en-US"/>
           </a:p>
@@ -15860,7 +16015,7 @@
           <a:p>
             <a:fld id="{B7EB45DA-9A0D-DC49-8E02-F30A5DDC21C3}" type="slidenum">
               <a:rPr lang="en-US" smtClean="0"/>
-              <a:t>1</a:t>
+              <a:t>22</a:t>
             </a:fld>
             <a:endParaRPr lang="en-US"/>
           </a:p>
@@ -16452,7 +16607,7 @@
           <a:p>
             <a:fld id="{B7EB45DA-9A0D-DC49-8E02-F30A5DDC21C3}" type="slidenum">
               <a:rPr lang="en-US" smtClean="0"/>
-              <a:t>1</a:t>
+              <a:t>23</a:t>
             </a:fld>
             <a:endParaRPr lang="en-US"/>
           </a:p>
@@ -17212,7 +17367,7 @@
           <a:p>
             <a:fld id="{B7EB45DA-9A0D-DC49-8E02-F30A5DDC21C3}" type="slidenum">
               <a:rPr lang="en-US" smtClean="0"/>
-              <a:t>1</a:t>
+              <a:t>24</a:t>
             </a:fld>
             <a:endParaRPr lang="en-US"/>
           </a:p>
@@ -17768,7 +17923,7 @@
           <a:p>
             <a:fld id="{B7EB45DA-9A0D-DC49-8E02-F30A5DDC21C3}" type="slidenum">
               <a:rPr lang="en-US" smtClean="0"/>
-              <a:t>1</a:t>
+              <a:t>25</a:t>
             </a:fld>
             <a:endParaRPr lang="en-US"/>
           </a:p>
@@ -18377,7 +18532,7 @@
           <a:p>
             <a:fld id="{B7EB45DA-9A0D-DC49-8E02-F30A5DDC21C3}" type="slidenum">
               <a:rPr lang="en-US" smtClean="0"/>
-              <a:t>1</a:t>
+              <a:t>26</a:t>
             </a:fld>
             <a:endParaRPr lang="en-US"/>
           </a:p>
@@ -18943,7 +19098,7 @@
           <a:p>
             <a:fld id="{B7EB45DA-9A0D-DC49-8E02-F30A5DDC21C3}" type="slidenum">
               <a:rPr lang="en-US" smtClean="0"/>
-              <a:t>1</a:t>
+              <a:t>27</a:t>
             </a:fld>
             <a:endParaRPr lang="en-US"/>
           </a:p>
@@ -18973,7 +19128,7 @@
           <a:p>
             <a:r>
               <a:rPr lang="en-US" dirty="0"/>
-              <a:t xml:space="preserve">Same controller, new question: </a:t>
+              <a:t>Same controller, new question: </a:t>
             </a:r>
             <a:r>
               <a:rPr lang="en-US" sz="1800" b="1" dirty="0">
@@ -19228,7 +19383,7 @@
                   <a:srgbClr val="5C4826"/>
                 </a:solidFill>
               </a:rPr>
-              <a:t xml:space="preserve"> + T</a:t>
+              <a:t> + T</a:t>
             </a:r>
             <a:r>
               <a:rPr lang="en-US" sz="1400" b="1" baseline="-25000" dirty="0">
@@ -19244,7 +19399,7 @@
                   <a:srgbClr val="5C4826"/>
                 </a:solidFill>
               </a:rPr>
-              <a:t xml:space="preserve"> + T</a:t>
+              <a:t> + T</a:t>
             </a:r>
             <a:r>
               <a:rPr lang="en-US" sz="1400" b="1" baseline="-25000" dirty="0">
@@ -19260,7 +19415,7 @@
                   <a:srgbClr val="5C4826"/>
                 </a:solidFill>
               </a:rPr>
-              <a:t xml:space="preserve"> + T</a:t>
+              <a:t> + T</a:t>
             </a:r>
             <a:r>
               <a:rPr lang="en-US" sz="1400" b="1" baseline="-25000" dirty="0">
@@ -19276,7 +19431,7 @@
                   <a:srgbClr val="5C4826"/>
                 </a:solidFill>
               </a:rPr>
-              <a:t xml:space="preserve"> ≤ 50 ms</a:t>
+              <a:t> ≤ 50 ms</a:t>
             </a:r>
           </a:p>
         </p:txBody>
@@ -19678,7 +19833,7 @@
           <a:p>
             <a:fld id="{B7EB45DA-9A0D-DC49-8E02-F30A5DDC21C3}" type="slidenum">
               <a:rPr lang="en-US" smtClean="0"/>
-              <a:t>1</a:t>
+              <a:t>28</a:t>
             </a:fld>
             <a:endParaRPr lang="en-US"/>
           </a:p>
@@ -19782,7 +19937,7 @@
           <a:p>
             <a:fld id="{B7EB45DA-9A0D-DC49-8E02-F30A5DDC21C3}" type="slidenum">
               <a:rPr lang="en-US" smtClean="0"/>
-              <a:t>1</a:t>
+              <a:t>29</a:t>
             </a:fld>
             <a:endParaRPr lang="en-US"/>
           </a:p>
@@ -19868,7 +20023,7 @@
                   <a:srgbClr val="555960"/>
                 </a:solidFill>
               </a:rPr>
-              <a:t xml:space="preserve"> — a purposeful reduction of some territory that preserves selected properties for engineering questions.</a:t>
+              <a:t> — a purposeful reduction of some territory that preserves selected properties for engineering questions.</a:t>
             </a:r>
           </a:p>
           <a:p>
@@ -19892,7 +20047,7 @@
                   <a:srgbClr val="555960"/>
                 </a:solidFill>
               </a:rPr>
-              <a:t xml:space="preserve"> — a concrete form in which a model is inspected, manipulated, analyzed, or consumed.</a:t>
+              <a:t> — a concrete form in which a model is inspected, manipulated, analyzed, or consumed.</a:t>
             </a:r>
           </a:p>
         </p:txBody>
@@ -20386,7 +20541,7 @@
                   <a:srgbClr val="5C4826"/>
                 </a:solidFill>
               </a:rPr>
-              <a:t xml:space="preserve">  staged: published</a:t>
+              <a:t>  staged: published</a:t>
             </a:r>
           </a:p>
           <a:p>
@@ -20402,7 +20557,7 @@
                   <a:srgbClr val="5C4826"/>
                 </a:solidFill>
               </a:rPr>
-              <a:t xml:space="preserve">  published: recorded</a:t>
+              <a:t>  published: recorded</a:t>
             </a:r>
           </a:p>
           <a:p>
@@ -20565,7 +20720,7 @@
           <a:p>
             <a:fld id="{B7EB45DA-9A0D-DC49-8E02-F30A5DDC21C3}" type="slidenum">
               <a:rPr lang="en-US" smtClean="0"/>
-              <a:t>1</a:t>
+              <a:t>3</a:t>
             </a:fld>
             <a:endParaRPr lang="en-US"/>
           </a:p>
@@ -20594,6 +20749,13 @@
             </a:solidFill>
           </a:ln>
         </p:spPr>
+        <p:txBody>
+          <a:bodyPr/>
+          <a:lstStyle/>
+          <a:p>
+            <a:endParaRPr lang="en-US"/>
+          </a:p>
+        </p:txBody>
       </p:sp>
       <p:sp>
         <p:nvSpPr>
@@ -20655,6 +20817,13 @@
             </a:solidFill>
           </a:ln>
         </p:spPr>
+        <p:txBody>
+          <a:bodyPr/>
+          <a:lstStyle/>
+          <a:p>
+            <a:endParaRPr lang="en-US"/>
+          </a:p>
+        </p:txBody>
       </p:sp>
       <p:sp>
         <p:nvSpPr>
@@ -20679,6 +20848,13 @@
             </a:solidFill>
           </a:ln>
         </p:spPr>
+        <p:txBody>
+          <a:bodyPr/>
+          <a:lstStyle/>
+          <a:p>
+            <a:endParaRPr lang="en-US"/>
+          </a:p>
+        </p:txBody>
       </p:sp>
       <p:sp>
         <p:nvSpPr>
@@ -20703,6 +20879,13 @@
             </a:solidFill>
           </a:ln>
         </p:spPr>
+        <p:txBody>
+          <a:bodyPr/>
+          <a:lstStyle/>
+          <a:p>
+            <a:endParaRPr lang="en-US"/>
+          </a:p>
+        </p:txBody>
       </p:sp>
       <p:sp>
         <p:nvSpPr>
@@ -20727,6 +20910,13 @@
             </a:solidFill>
           </a:ln>
         </p:spPr>
+        <p:txBody>
+          <a:bodyPr/>
+          <a:lstStyle/>
+          <a:p>
+            <a:endParaRPr lang="en-US"/>
+          </a:p>
+        </p:txBody>
       </p:sp>
       <p:sp>
         <p:nvSpPr>
@@ -20751,6 +20941,13 @@
             </a:solidFill>
           </a:ln>
         </p:spPr>
+        <p:txBody>
+          <a:bodyPr/>
+          <a:lstStyle/>
+          <a:p>
+            <a:endParaRPr lang="en-US"/>
+          </a:p>
+        </p:txBody>
       </p:sp>
       <p:sp>
         <p:nvSpPr>
@@ -20775,6 +20972,13 @@
             </a:solidFill>
           </a:ln>
         </p:spPr>
+        <p:txBody>
+          <a:bodyPr/>
+          <a:lstStyle/>
+          <a:p>
+            <a:endParaRPr lang="en-US"/>
+          </a:p>
+        </p:txBody>
       </p:sp>
       <p:sp>
         <p:nvSpPr>
@@ -20797,6 +21001,13 @@
             <a:noFill/>
           </a:ln>
         </p:spPr>
+        <p:txBody>
+          <a:bodyPr/>
+          <a:lstStyle/>
+          <a:p>
+            <a:endParaRPr lang="en-US"/>
+          </a:p>
+        </p:txBody>
       </p:sp>
       <p:sp>
         <p:nvSpPr>
@@ -20819,6 +21030,13 @@
             <a:noFill/>
           </a:ln>
         </p:spPr>
+        <p:txBody>
+          <a:bodyPr/>
+          <a:lstStyle/>
+          <a:p>
+            <a:endParaRPr lang="en-US"/>
+          </a:p>
+        </p:txBody>
       </p:sp>
       <p:sp>
         <p:nvSpPr>
@@ -20841,6 +21059,13 @@
             <a:noFill/>
           </a:ln>
         </p:spPr>
+        <p:txBody>
+          <a:bodyPr/>
+          <a:lstStyle/>
+          <a:p>
+            <a:endParaRPr lang="en-US"/>
+          </a:p>
+        </p:txBody>
       </p:sp>
       <p:sp>
         <p:nvSpPr>
@@ -20865,6 +21090,13 @@
             </a:solidFill>
           </a:ln>
         </p:spPr>
+        <p:txBody>
+          <a:bodyPr/>
+          <a:lstStyle/>
+          <a:p>
+            <a:endParaRPr lang="en-US"/>
+          </a:p>
+        </p:txBody>
       </p:sp>
       <p:sp>
         <p:nvSpPr>
@@ -20889,6 +21121,13 @@
             </a:solidFill>
           </a:ln>
         </p:spPr>
+        <p:txBody>
+          <a:bodyPr/>
+          <a:lstStyle/>
+          <a:p>
+            <a:endParaRPr lang="en-US"/>
+          </a:p>
+        </p:txBody>
       </p:sp>
       <p:sp>
         <p:nvSpPr>
@@ -20913,6 +21152,13 @@
             </a:solidFill>
           </a:ln>
         </p:spPr>
+        <p:txBody>
+          <a:bodyPr/>
+          <a:lstStyle/>
+          <a:p>
+            <a:endParaRPr lang="en-US"/>
+          </a:p>
+        </p:txBody>
       </p:sp>
       <p:sp>
         <p:nvSpPr>
@@ -21337,6 +21583,13 @@
             </a:solidFill>
           </a:ln>
         </p:spPr>
+        <p:txBody>
+          <a:bodyPr/>
+          <a:lstStyle/>
+          <a:p>
+            <a:endParaRPr lang="en-US"/>
+          </a:p>
+        </p:txBody>
       </p:sp>
       <p:sp>
         <p:nvSpPr>
@@ -21400,6 +21653,13 @@
             </a:solidFill>
           </a:ln>
         </p:spPr>
+        <p:txBody>
+          <a:bodyPr/>
+          <a:lstStyle/>
+          <a:p>
+            <a:endParaRPr lang="en-US"/>
+          </a:p>
+        </p:txBody>
       </p:sp>
       <p:sp>
         <p:nvSpPr>
@@ -21463,6 +21723,13 @@
             </a:solidFill>
           </a:ln>
         </p:spPr>
+        <p:txBody>
+          <a:bodyPr/>
+          <a:lstStyle/>
+          <a:p>
+            <a:endParaRPr lang="en-US"/>
+          </a:p>
+        </p:txBody>
       </p:sp>
       <p:sp>
         <p:nvSpPr>
@@ -21487,6 +21754,13 @@
             </a:solidFill>
           </a:ln>
         </p:spPr>
+        <p:txBody>
+          <a:bodyPr/>
+          <a:lstStyle/>
+          <a:p>
+            <a:endParaRPr lang="en-US"/>
+          </a:p>
+        </p:txBody>
       </p:sp>
       <p:sp>
         <p:nvSpPr>
@@ -21511,6 +21785,13 @@
             </a:solidFill>
           </a:ln>
         </p:spPr>
+        <p:txBody>
+          <a:bodyPr/>
+          <a:lstStyle/>
+          <a:p>
+            <a:endParaRPr lang="en-US"/>
+          </a:p>
+        </p:txBody>
       </p:sp>
       <p:sp>
         <p:nvSpPr>
@@ -21535,6 +21816,13 @@
             </a:solidFill>
           </a:ln>
         </p:spPr>
+        <p:txBody>
+          <a:bodyPr/>
+          <a:lstStyle/>
+          <a:p>
+            <a:endParaRPr lang="en-US"/>
+          </a:p>
+        </p:txBody>
       </p:sp>
       <p:sp>
         <p:nvSpPr>
@@ -21559,6 +21847,13 @@
             </a:solidFill>
           </a:ln>
         </p:spPr>
+        <p:txBody>
+          <a:bodyPr/>
+          <a:lstStyle/>
+          <a:p>
+            <a:endParaRPr lang="en-US"/>
+          </a:p>
+        </p:txBody>
       </p:sp>
       <p:cxnSp>
         <p:nvCxnSpPr>
@@ -21671,6 +21966,13 @@
             </a:solidFill>
           </a:ln>
         </p:spPr>
+        <p:txBody>
+          <a:bodyPr/>
+          <a:lstStyle/>
+          <a:p>
+            <a:endParaRPr lang="en-US"/>
+          </a:p>
+        </p:txBody>
       </p:sp>
       <p:sp>
         <p:nvSpPr>
@@ -21695,6 +21997,13 @@
             </a:solidFill>
           </a:ln>
         </p:spPr>
+        <p:txBody>
+          <a:bodyPr/>
+          <a:lstStyle/>
+          <a:p>
+            <a:endParaRPr lang="en-US"/>
+          </a:p>
+        </p:txBody>
       </p:sp>
       <p:sp>
         <p:nvSpPr>
@@ -21719,6 +22028,13 @@
             </a:solidFill>
           </a:ln>
         </p:spPr>
+        <p:txBody>
+          <a:bodyPr/>
+          <a:lstStyle/>
+          <a:p>
+            <a:endParaRPr lang="en-US"/>
+          </a:p>
+        </p:txBody>
       </p:sp>
       <p:cxnSp>
         <p:nvCxnSpPr>
@@ -21872,6 +22188,13 @@
             </a:solidFill>
           </a:ln>
         </p:spPr>
+        <p:txBody>
+          <a:bodyPr/>
+          <a:lstStyle/>
+          <a:p>
+            <a:endParaRPr lang="en-US"/>
+          </a:p>
+        </p:txBody>
       </p:sp>
       <p:sp>
         <p:nvSpPr>
@@ -21896,6 +22219,13 @@
             </a:solidFill>
           </a:ln>
         </p:spPr>
+        <p:txBody>
+          <a:bodyPr/>
+          <a:lstStyle/>
+          <a:p>
+            <a:endParaRPr lang="en-US"/>
+          </a:p>
+        </p:txBody>
       </p:sp>
       <p:sp>
         <p:nvSpPr>
@@ -21920,6 +22250,13 @@
             </a:solidFill>
           </a:ln>
         </p:spPr>
+        <p:txBody>
+          <a:bodyPr/>
+          <a:lstStyle/>
+          <a:p>
+            <a:endParaRPr lang="en-US"/>
+          </a:p>
+        </p:txBody>
       </p:sp>
       <p:cxnSp>
         <p:nvCxnSpPr>
@@ -22048,7 +22385,7 @@
           <a:p>
             <a:fld id="{B7EB45DA-9A0D-DC49-8E02-F30A5DDC21C3}" type="slidenum">
               <a:rPr lang="en-US" smtClean="0"/>
-              <a:t>1</a:t>
+              <a:t>30</a:t>
             </a:fld>
             <a:endParaRPr lang="en-US"/>
           </a:p>
@@ -22462,7 +22799,7 @@
                   <a:srgbClr val="555960"/>
                 </a:solidFill>
               </a:rPr>
-              <a:t xml:space="preserve"> where meaning is consequential.</a:t>
+              <a:t> where meaning is consequential.</a:t>
             </a:r>
           </a:p>
           <a:p>
@@ -22486,7 +22823,7 @@
                   <a:srgbClr val="555960"/>
                 </a:solidFill>
               </a:rPr>
-              <a:t xml:space="preserve"> where it is not.</a:t>
+              <a:t> where it is not.</a:t>
             </a:r>
           </a:p>
         </p:txBody>
@@ -22597,7 +22934,7 @@
           <a:p>
             <a:fld id="{B7EB45DA-9A0D-DC49-8E02-F30A5DDC21C3}" type="slidenum">
               <a:rPr lang="en-US" smtClean="0"/>
-              <a:t>1</a:t>
+              <a:t>31</a:t>
             </a:fld>
             <a:endParaRPr lang="en-US"/>
           </a:p>
@@ -23216,7 +23553,7 @@
             </a:r>
             <a:r>
               <a:rPr lang="en-US" dirty="0"/>
-              <a:t xml:space="preserve"> what must I preserve to answer the engineering question?</a:t>
+              <a:t> what must I preserve to answer the engineering question?</a:t>
             </a:r>
           </a:p>
           <a:p>
@@ -23226,7 +23563,7 @@
             </a:r>
             <a:r>
               <a:rPr lang="en-US" dirty="0"/>
-              <a:t xml:space="preserve"> why am I carrying each distinction that remains?</a:t>
+              <a:t> why am I carrying each distinction that remains?</a:t>
             </a:r>
           </a:p>
         </p:txBody>
@@ -23272,7 +23609,7 @@
           <a:p>
             <a:fld id="{B7EB45DA-9A0D-DC49-8E02-F30A5DDC21C3}" type="slidenum">
               <a:rPr lang="en-US" smtClean="0"/>
-              <a:t>1</a:t>
+              <a:t>32</a:t>
             </a:fld>
             <a:endParaRPr lang="en-US"/>
           </a:p>
@@ -23401,7 +23738,7 @@
                   <a:srgbClr val="5C4826"/>
                 </a:solidFill>
               </a:rPr>
-              <a:t xml:space="preserve">Tomorrow: </a:t>
+              <a:t>Tomorrow: </a:t>
             </a:r>
             <a:r>
               <a:rPr lang="en-US" sz="1800" b="0" i="1" dirty="0">
@@ -23480,7 +23817,7 @@
           <a:p>
             <a:fld id="{B7EB45DA-9A0D-DC49-8E02-F30A5DDC21C3}" type="slidenum">
               <a:rPr lang="en-US" smtClean="0"/>
-              <a:t>1</a:t>
+              <a:t>4</a:t>
             </a:fld>
             <a:endParaRPr lang="en-US"/>
           </a:p>
@@ -23509,6 +23846,13 @@
             </a:solidFill>
           </a:ln>
         </p:spPr>
+        <p:txBody>
+          <a:bodyPr/>
+          <a:lstStyle/>
+          <a:p>
+            <a:endParaRPr lang="en-US"/>
+          </a:p>
+        </p:txBody>
       </p:sp>
       <p:sp>
         <p:nvSpPr>
@@ -23570,6 +23914,13 @@
             </a:solidFill>
           </a:ln>
         </p:spPr>
+        <p:txBody>
+          <a:bodyPr/>
+          <a:lstStyle/>
+          <a:p>
+            <a:endParaRPr lang="en-US"/>
+          </a:p>
+        </p:txBody>
       </p:sp>
       <p:sp>
         <p:nvSpPr>
@@ -23594,6 +23945,13 @@
             </a:solidFill>
           </a:ln>
         </p:spPr>
+        <p:txBody>
+          <a:bodyPr/>
+          <a:lstStyle/>
+          <a:p>
+            <a:endParaRPr lang="en-US"/>
+          </a:p>
+        </p:txBody>
       </p:sp>
       <p:sp>
         <p:nvSpPr>
@@ -23618,6 +23976,13 @@
             </a:solidFill>
           </a:ln>
         </p:spPr>
+        <p:txBody>
+          <a:bodyPr/>
+          <a:lstStyle/>
+          <a:p>
+            <a:endParaRPr lang="en-US"/>
+          </a:p>
+        </p:txBody>
       </p:sp>
       <p:sp>
         <p:nvSpPr>
@@ -23642,6 +24007,13 @@
             </a:solidFill>
           </a:ln>
         </p:spPr>
+        <p:txBody>
+          <a:bodyPr/>
+          <a:lstStyle/>
+          <a:p>
+            <a:endParaRPr lang="en-US"/>
+          </a:p>
+        </p:txBody>
       </p:sp>
       <p:sp>
         <p:nvSpPr>
@@ -23666,6 +24038,13 @@
             </a:solidFill>
           </a:ln>
         </p:spPr>
+        <p:txBody>
+          <a:bodyPr/>
+          <a:lstStyle/>
+          <a:p>
+            <a:endParaRPr lang="en-US"/>
+          </a:p>
+        </p:txBody>
       </p:sp>
       <p:sp>
         <p:nvSpPr>
@@ -23690,6 +24069,13 @@
             </a:solidFill>
           </a:ln>
         </p:spPr>
+        <p:txBody>
+          <a:bodyPr/>
+          <a:lstStyle/>
+          <a:p>
+            <a:endParaRPr lang="en-US"/>
+          </a:p>
+        </p:txBody>
       </p:sp>
       <p:sp>
         <p:nvSpPr>
@@ -23712,6 +24098,13 @@
             <a:noFill/>
           </a:ln>
         </p:spPr>
+        <p:txBody>
+          <a:bodyPr/>
+          <a:lstStyle/>
+          <a:p>
+            <a:endParaRPr lang="en-US"/>
+          </a:p>
+        </p:txBody>
       </p:sp>
       <p:sp>
         <p:nvSpPr>
@@ -23734,6 +24127,13 @@
             <a:noFill/>
           </a:ln>
         </p:spPr>
+        <p:txBody>
+          <a:bodyPr/>
+          <a:lstStyle/>
+          <a:p>
+            <a:endParaRPr lang="en-US"/>
+          </a:p>
+        </p:txBody>
       </p:sp>
       <p:sp>
         <p:nvSpPr>
@@ -23756,6 +24156,13 @@
             <a:noFill/>
           </a:ln>
         </p:spPr>
+        <p:txBody>
+          <a:bodyPr/>
+          <a:lstStyle/>
+          <a:p>
+            <a:endParaRPr lang="en-US"/>
+          </a:p>
+        </p:txBody>
       </p:sp>
       <p:sp>
         <p:nvSpPr>
@@ -23780,6 +24187,13 @@
             </a:solidFill>
           </a:ln>
         </p:spPr>
+        <p:txBody>
+          <a:bodyPr/>
+          <a:lstStyle/>
+          <a:p>
+            <a:endParaRPr lang="en-US"/>
+          </a:p>
+        </p:txBody>
       </p:sp>
       <p:sp>
         <p:nvSpPr>
@@ -23804,6 +24218,13 @@
             </a:solidFill>
           </a:ln>
         </p:spPr>
+        <p:txBody>
+          <a:bodyPr/>
+          <a:lstStyle/>
+          <a:p>
+            <a:endParaRPr lang="en-US"/>
+          </a:p>
+        </p:txBody>
       </p:sp>
       <p:sp>
         <p:nvSpPr>
@@ -23828,6 +24249,13 @@
             </a:solidFill>
           </a:ln>
         </p:spPr>
+        <p:txBody>
+          <a:bodyPr/>
+          <a:lstStyle/>
+          <a:p>
+            <a:endParaRPr lang="en-US"/>
+          </a:p>
+        </p:txBody>
       </p:sp>
       <p:sp>
         <p:nvSpPr>
@@ -24252,6 +24680,13 @@
             </a:solidFill>
           </a:ln>
         </p:spPr>
+        <p:txBody>
+          <a:bodyPr/>
+          <a:lstStyle/>
+          <a:p>
+            <a:endParaRPr lang="en-US"/>
+          </a:p>
+        </p:txBody>
       </p:sp>
       <p:sp>
         <p:nvSpPr>
@@ -24315,6 +24750,13 @@
             </a:solidFill>
           </a:ln>
         </p:spPr>
+        <p:txBody>
+          <a:bodyPr/>
+          <a:lstStyle/>
+          <a:p>
+            <a:endParaRPr lang="en-US"/>
+          </a:p>
+        </p:txBody>
       </p:sp>
       <p:sp>
         <p:nvSpPr>
@@ -24378,6 +24820,13 @@
             </a:solidFill>
           </a:ln>
         </p:spPr>
+        <p:txBody>
+          <a:bodyPr/>
+          <a:lstStyle/>
+          <a:p>
+            <a:endParaRPr lang="en-US"/>
+          </a:p>
+        </p:txBody>
       </p:sp>
       <p:sp>
         <p:nvSpPr>
@@ -24402,6 +24851,13 @@
             </a:solidFill>
           </a:ln>
         </p:spPr>
+        <p:txBody>
+          <a:bodyPr/>
+          <a:lstStyle/>
+          <a:p>
+            <a:endParaRPr lang="en-US"/>
+          </a:p>
+        </p:txBody>
       </p:sp>
       <p:sp>
         <p:nvSpPr>
@@ -24426,6 +24882,13 @@
             </a:solidFill>
           </a:ln>
         </p:spPr>
+        <p:txBody>
+          <a:bodyPr/>
+          <a:lstStyle/>
+          <a:p>
+            <a:endParaRPr lang="en-US"/>
+          </a:p>
+        </p:txBody>
       </p:sp>
       <p:sp>
         <p:nvSpPr>
@@ -24450,6 +24913,13 @@
             </a:solidFill>
           </a:ln>
         </p:spPr>
+        <p:txBody>
+          <a:bodyPr/>
+          <a:lstStyle/>
+          <a:p>
+            <a:endParaRPr lang="en-US"/>
+          </a:p>
+        </p:txBody>
       </p:sp>
       <p:sp>
         <p:nvSpPr>
@@ -24474,6 +24944,13 @@
             </a:solidFill>
           </a:ln>
         </p:spPr>
+        <p:txBody>
+          <a:bodyPr/>
+          <a:lstStyle/>
+          <a:p>
+            <a:endParaRPr lang="en-US"/>
+          </a:p>
+        </p:txBody>
       </p:sp>
       <p:cxnSp>
         <p:nvCxnSpPr>
@@ -24586,6 +25063,13 @@
             </a:solidFill>
           </a:ln>
         </p:spPr>
+        <p:txBody>
+          <a:bodyPr/>
+          <a:lstStyle/>
+          <a:p>
+            <a:endParaRPr lang="en-US"/>
+          </a:p>
+        </p:txBody>
       </p:sp>
       <p:sp>
         <p:nvSpPr>
@@ -24610,6 +25094,13 @@
             </a:solidFill>
           </a:ln>
         </p:spPr>
+        <p:txBody>
+          <a:bodyPr/>
+          <a:lstStyle/>
+          <a:p>
+            <a:endParaRPr lang="en-US"/>
+          </a:p>
+        </p:txBody>
       </p:sp>
       <p:sp>
         <p:nvSpPr>
@@ -24634,6 +25125,13 @@
             </a:solidFill>
           </a:ln>
         </p:spPr>
+        <p:txBody>
+          <a:bodyPr/>
+          <a:lstStyle/>
+          <a:p>
+            <a:endParaRPr lang="en-US"/>
+          </a:p>
+        </p:txBody>
       </p:sp>
       <p:cxnSp>
         <p:nvCxnSpPr>
@@ -24787,6 +25285,13 @@
             </a:solidFill>
           </a:ln>
         </p:spPr>
+        <p:txBody>
+          <a:bodyPr/>
+          <a:lstStyle/>
+          <a:p>
+            <a:endParaRPr lang="en-US"/>
+          </a:p>
+        </p:txBody>
       </p:sp>
       <p:sp>
         <p:nvSpPr>
@@ -24811,6 +25316,13 @@
             </a:solidFill>
           </a:ln>
         </p:spPr>
+        <p:txBody>
+          <a:bodyPr/>
+          <a:lstStyle/>
+          <a:p>
+            <a:endParaRPr lang="en-US"/>
+          </a:p>
+        </p:txBody>
       </p:sp>
       <p:sp>
         <p:nvSpPr>
@@ -24835,6 +25347,13 @@
             </a:solidFill>
           </a:ln>
         </p:spPr>
+        <p:txBody>
+          <a:bodyPr/>
+          <a:lstStyle/>
+          <a:p>
+            <a:endParaRPr lang="en-US"/>
+          </a:p>
+        </p:txBody>
       </p:sp>
       <p:cxnSp>
         <p:nvCxnSpPr>
@@ -25074,7 +25593,7 @@
           <a:p>
             <a:fld id="{B7EB45DA-9A0D-DC49-8E02-F30A5DDC21C3}" type="slidenum">
               <a:rPr lang="en-US" smtClean="0"/>
-              <a:t>1</a:t>
+              <a:t>5</a:t>
             </a:fld>
             <a:endParaRPr lang="en-US"/>
           </a:p>
@@ -25213,6 +25732,13 @@
             <a:noFill/>
           </a:ln>
         </p:spPr>
+        <p:txBody>
+          <a:bodyPr/>
+          <a:lstStyle/>
+          <a:p>
+            <a:endParaRPr lang="en-US"/>
+          </a:p>
+        </p:txBody>
       </p:sp>
       <p:sp>
         <p:nvSpPr>
@@ -25235,6 +25761,13 @@
             <a:noFill/>
           </a:ln>
         </p:spPr>
+        <p:txBody>
+          <a:bodyPr/>
+          <a:lstStyle/>
+          <a:p>
+            <a:endParaRPr lang="en-US"/>
+          </a:p>
+        </p:txBody>
       </p:sp>
       <p:sp>
         <p:nvSpPr>
@@ -25257,6 +25790,13 @@
             <a:noFill/>
           </a:ln>
         </p:spPr>
+        <p:txBody>
+          <a:bodyPr/>
+          <a:lstStyle/>
+          <a:p>
+            <a:endParaRPr lang="en-US"/>
+          </a:p>
+        </p:txBody>
       </p:sp>
       <p:sp>
         <p:nvSpPr>
@@ -25279,6 +25819,13 @@
             <a:noFill/>
           </a:ln>
         </p:spPr>
+        <p:txBody>
+          <a:bodyPr/>
+          <a:lstStyle/>
+          <a:p>
+            <a:endParaRPr lang="en-US"/>
+          </a:p>
+        </p:txBody>
       </p:sp>
       <p:sp>
         <p:nvSpPr>
@@ -25301,6 +25848,13 @@
             <a:noFill/>
           </a:ln>
         </p:spPr>
+        <p:txBody>
+          <a:bodyPr/>
+          <a:lstStyle/>
+          <a:p>
+            <a:endParaRPr lang="en-US"/>
+          </a:p>
+        </p:txBody>
       </p:sp>
       <p:sp>
         <p:nvSpPr>
@@ -25323,6 +25877,13 @@
             <a:noFill/>
           </a:ln>
         </p:spPr>
+        <p:txBody>
+          <a:bodyPr/>
+          <a:lstStyle/>
+          <a:p>
+            <a:endParaRPr lang="en-US"/>
+          </a:p>
+        </p:txBody>
       </p:sp>
       <p:sp>
         <p:nvSpPr>
@@ -25345,6 +25906,13 @@
             <a:noFill/>
           </a:ln>
         </p:spPr>
+        <p:txBody>
+          <a:bodyPr/>
+          <a:lstStyle/>
+          <a:p>
+            <a:endParaRPr lang="en-US"/>
+          </a:p>
+        </p:txBody>
       </p:sp>
       <p:sp>
         <p:nvSpPr>
@@ -25367,6 +25935,13 @@
             <a:noFill/>
           </a:ln>
         </p:spPr>
+        <p:txBody>
+          <a:bodyPr/>
+          <a:lstStyle/>
+          <a:p>
+            <a:endParaRPr lang="en-US"/>
+          </a:p>
+        </p:txBody>
       </p:sp>
       <p:sp>
         <p:nvSpPr>
@@ -25389,6 +25964,13 @@
             <a:noFill/>
           </a:ln>
         </p:spPr>
+        <p:txBody>
+          <a:bodyPr/>
+          <a:lstStyle/>
+          <a:p>
+            <a:endParaRPr lang="en-US"/>
+          </a:p>
+        </p:txBody>
       </p:sp>
       <p:sp>
         <p:nvSpPr>
@@ -25411,6 +25993,13 @@
             <a:noFill/>
           </a:ln>
         </p:spPr>
+        <p:txBody>
+          <a:bodyPr/>
+          <a:lstStyle/>
+          <a:p>
+            <a:endParaRPr lang="en-US"/>
+          </a:p>
+        </p:txBody>
       </p:sp>
       <p:sp>
         <p:nvSpPr>
@@ -25433,6 +26022,13 @@
             <a:noFill/>
           </a:ln>
         </p:spPr>
+        <p:txBody>
+          <a:bodyPr/>
+          <a:lstStyle/>
+          <a:p>
+            <a:endParaRPr lang="en-US"/>
+          </a:p>
+        </p:txBody>
       </p:sp>
       <p:sp>
         <p:nvSpPr>
@@ -25455,6 +26051,13 @@
             <a:noFill/>
           </a:ln>
         </p:spPr>
+        <p:txBody>
+          <a:bodyPr/>
+          <a:lstStyle/>
+          <a:p>
+            <a:endParaRPr lang="en-US"/>
+          </a:p>
+        </p:txBody>
       </p:sp>
       <p:cxnSp>
         <p:nvCxnSpPr>
@@ -25499,6 +26102,13 @@
             <a:noFill/>
           </a:ln>
         </p:spPr>
+        <p:txBody>
+          <a:bodyPr/>
+          <a:lstStyle/>
+          <a:p>
+            <a:endParaRPr lang="en-US"/>
+          </a:p>
+        </p:txBody>
       </p:sp>
       <p:sp>
         <p:nvSpPr>
@@ -25521,6 +26131,13 @@
             <a:noFill/>
           </a:ln>
         </p:spPr>
+        <p:txBody>
+          <a:bodyPr/>
+          <a:lstStyle/>
+          <a:p>
+            <a:endParaRPr lang="en-US"/>
+          </a:p>
+        </p:txBody>
       </p:sp>
       <p:sp>
         <p:nvSpPr>
@@ -25543,6 +26160,13 @@
             <a:noFill/>
           </a:ln>
         </p:spPr>
+        <p:txBody>
+          <a:bodyPr/>
+          <a:lstStyle/>
+          <a:p>
+            <a:endParaRPr lang="en-US"/>
+          </a:p>
+        </p:txBody>
       </p:sp>
       <p:sp>
         <p:nvSpPr>
@@ -25565,6 +26189,13 @@
             <a:noFill/>
           </a:ln>
         </p:spPr>
+        <p:txBody>
+          <a:bodyPr/>
+          <a:lstStyle/>
+          <a:p>
+            <a:endParaRPr lang="en-US"/>
+          </a:p>
+        </p:txBody>
       </p:sp>
       <p:sp>
         <p:nvSpPr>
@@ -25758,7 +26389,7 @@
           <a:p>
             <a:fld id="{B7EB45DA-9A0D-DC49-8E02-F30A5DDC21C3}" type="slidenum">
               <a:rPr lang="en-US" smtClean="0"/>
-              <a:t>1</a:t>
+              <a:t>6</a:t>
             </a:fld>
             <a:endParaRPr lang="en-US"/>
           </a:p>
@@ -26127,7 +26758,7 @@
           <a:p>
             <a:fld id="{B7EB45DA-9A0D-DC49-8E02-F30A5DDC21C3}" type="slidenum">
               <a:rPr lang="en-US" smtClean="0"/>
-              <a:t>1</a:t>
+              <a:t>7</a:t>
             </a:fld>
             <a:endParaRPr lang="en-US"/>
           </a:p>
@@ -26324,6 +26955,13 @@
             <a:noFill/>
           </a:ln>
         </p:spPr>
+        <p:txBody>
+          <a:bodyPr/>
+          <a:lstStyle/>
+          <a:p>
+            <a:endParaRPr lang="en-US"/>
+          </a:p>
+        </p:txBody>
       </p:sp>
       <p:sp>
         <p:nvSpPr>
@@ -26346,6 +26984,13 @@
             <a:noFill/>
           </a:ln>
         </p:spPr>
+        <p:txBody>
+          <a:bodyPr/>
+          <a:lstStyle/>
+          <a:p>
+            <a:endParaRPr lang="en-US"/>
+          </a:p>
+        </p:txBody>
       </p:sp>
       <p:sp>
         <p:nvSpPr>
@@ -26368,6 +27013,13 @@
             <a:noFill/>
           </a:ln>
         </p:spPr>
+        <p:txBody>
+          <a:bodyPr/>
+          <a:lstStyle/>
+          <a:p>
+            <a:endParaRPr lang="en-US"/>
+          </a:p>
+        </p:txBody>
       </p:sp>
       <p:cxnSp>
         <p:nvCxnSpPr>
@@ -28531,7 +29183,7 @@
           <a:p>
             <a:fld id="{B7EB45DA-9A0D-DC49-8E02-F30A5DDC21C3}" type="slidenum">
               <a:rPr lang="en-US" smtClean="0"/>
-              <a:t>1</a:t>
+              <a:t>8</a:t>
             </a:fld>
             <a:endParaRPr lang="en-US"/>
           </a:p>
@@ -29782,7 +30434,7 @@
           <a:p>
             <a:fld id="{B7EB45DA-9A0D-DC49-8E02-F30A5DDC21C3}" type="slidenum">
               <a:rPr lang="en-US" smtClean="0"/>
-              <a:t>1</a:t>
+              <a:t>9</a:t>
             </a:fld>
             <a:endParaRPr lang="en-US"/>
           </a:p>

</xml_diff>

<commit_message>
slides(2-2-Modeling-1): cover art — the model is a reduction of the territory
The dark rectangle read as an unrelated artifact. The model row now reuses
a subset of the EXACT territory shapes — same square, circle and bar, same
fill and scale, fewer of them — so a reader can point at the model and find
each piece above it. That recognisability is the figure's argument.

A second arrow converges from a requirement check mark, adding the other
direction without explaining it; the lecture does that. Labels TERRITORY /
MODEL / OBLIGATION, the chapter's own vocabulary.

Applied on top of the Elmore logo swap, not instead of it.

Co-Authored-By: Claude Opus 5 <noreply@anthropic.com>
</commit_message>
<xml_diff>
--- a/course/lectures/act-2-delegation-and-control/02-modeling/2-2-Modeling-1-Purposeful-Reduction.pptx
+++ b/course/lectures/act-2-delegation-and-control/02-modeling/2-2-Modeling-1-Purposeful-Reduction.pptx
@@ -5970,7 +5970,7 @@
         </p:nvSpPr>
         <p:spPr>
           <a:xfrm>
-            <a:off x="2880360" y="4114800"/>
+            <a:off x="2331720" y="4050792"/>
             <a:ext cx="182880" cy="182880"/>
           </a:xfrm>
           <a:prstGeom prst="rect">
@@ -5999,7 +5999,7 @@
         </p:nvSpPr>
         <p:spPr>
           <a:xfrm>
-            <a:off x="3108960" y="4343400"/>
+            <a:off x="2560320" y="4279392"/>
             <a:ext cx="137160" cy="137160"/>
           </a:xfrm>
           <a:prstGeom prst="ellipse">
@@ -6028,8 +6028,8 @@
         </p:nvSpPr>
         <p:spPr>
           <a:xfrm>
-            <a:off x="3017520" y="4617720"/>
-            <a:ext cx="160020" cy="114300"/>
+            <a:off x="2434590" y="4576572"/>
+            <a:ext cx="228600" cy="68580"/>
           </a:xfrm>
           <a:prstGeom prst="rect">
             <a:avLst/>
@@ -6057,7 +6057,7 @@
         </p:nvSpPr>
         <p:spPr>
           <a:xfrm>
-            <a:off x="3291840" y="4087368"/>
+            <a:off x="2743200" y="4023360"/>
             <a:ext cx="205740" cy="137160"/>
           </a:xfrm>
           <a:prstGeom prst="rect">
@@ -6086,7 +6086,7 @@
         </p:nvSpPr>
         <p:spPr>
           <a:xfrm>
-            <a:off x="3383280" y="4480560"/>
+            <a:off x="2834640" y="4416552"/>
             <a:ext cx="182880" cy="182880"/>
           </a:xfrm>
           <a:prstGeom prst="ellipse">
@@ -6115,7 +6115,7 @@
         </p:nvSpPr>
         <p:spPr>
           <a:xfrm>
-            <a:off x="3566160" y="4114800"/>
+            <a:off x="3017520" y="4050792"/>
             <a:ext cx="137160" cy="205740"/>
           </a:xfrm>
           <a:prstGeom prst="rect">
@@ -6144,7 +6144,7 @@
         </p:nvSpPr>
         <p:spPr>
           <a:xfrm>
-            <a:off x="3703320" y="4526280"/>
+            <a:off x="3154680" y="4462272"/>
             <a:ext cx="114300" cy="114300"/>
           </a:xfrm>
           <a:prstGeom prst="ellipse">
@@ -6173,7 +6173,7 @@
         </p:nvSpPr>
         <p:spPr>
           <a:xfrm>
-            <a:off x="3794760" y="4297680"/>
+            <a:off x="3246120" y="4233672"/>
             <a:ext cx="160020" cy="160020"/>
           </a:xfrm>
           <a:prstGeom prst="rect">
@@ -6202,7 +6202,7 @@
         </p:nvSpPr>
         <p:spPr>
           <a:xfrm>
-            <a:off x="3931920" y="4087368"/>
+            <a:off x="3383280" y="4023360"/>
             <a:ext cx="137160" cy="137160"/>
           </a:xfrm>
           <a:prstGeom prst="rect">
@@ -6231,7 +6231,7 @@
         </p:nvSpPr>
         <p:spPr>
           <a:xfrm>
-            <a:off x="4023360" y="4526280"/>
+            <a:off x="3474720" y="4462272"/>
             <a:ext cx="137160" cy="137160"/>
           </a:xfrm>
           <a:prstGeom prst="ellipse">
@@ -6260,7 +6260,7 @@
         </p:nvSpPr>
         <p:spPr>
           <a:xfrm>
-            <a:off x="4160520" y="4343400"/>
+            <a:off x="3611880" y="4279392"/>
             <a:ext cx="114300" cy="114300"/>
           </a:xfrm>
           <a:prstGeom prst="rect">
@@ -6289,7 +6289,7 @@
         </p:nvSpPr>
         <p:spPr>
           <a:xfrm>
-            <a:off x="4297680" y="4160520"/>
+            <a:off x="3749040" y="4096512"/>
             <a:ext cx="91440" cy="91440"/>
           </a:xfrm>
           <a:prstGeom prst="ellipse">
@@ -6318,7 +6318,7 @@
         </p:nvCxnSpPr>
         <p:spPr>
           <a:xfrm>
-            <a:off x="4754880" y="4407408"/>
+            <a:off x="4097655" y="4345686"/>
             <a:ext cx="548640" cy="0"/>
           </a:xfrm>
           <a:prstGeom prst="straightConnector1">
@@ -6334,20 +6334,20 @@
       </p:cxnSp>
       <p:sp>
         <p:nvSpPr>
-          <p:cNvPr id="213" name="MdlM"/>
-          <p:cNvSpPr/>
-          <p:nvPr/>
-        </p:nvSpPr>
-        <p:spPr>
-          <a:xfrm>
-            <a:off x="5440680" y="4224528"/>
-            <a:ext cx="731520" cy="365760"/>
-          </a:xfrm>
-          <a:prstGeom prst="rect">
-            <a:avLst/>
-          </a:prstGeom>
-          <a:solidFill>
-            <a:srgbClr val="555960"/>
+          <p:cNvPr id="220" name="MS0"/>
+          <p:cNvSpPr/>
+          <p:nvPr/>
+        </p:nvSpPr>
+        <p:spPr>
+          <a:xfrm>
+            <a:off x="4903470" y="4254246"/>
+            <a:ext cx="182880" cy="182880"/>
+          </a:xfrm>
+          <a:prstGeom prst="rect">
+            <a:avLst/>
+          </a:prstGeom>
+          <a:solidFill>
+            <a:srgbClr val="C9B991"/>
           </a:solidFill>
           <a:ln>
             <a:noFill/>
@@ -6363,20 +6363,20 @@
       </p:sp>
       <p:sp>
         <p:nvSpPr>
-          <p:cNvPr id="214" name="KM0"/>
-          <p:cNvSpPr/>
-          <p:nvPr/>
-        </p:nvSpPr>
-        <p:spPr>
-          <a:xfrm>
-            <a:off x="5577840" y="4315968"/>
-            <a:ext cx="457200" cy="27432"/>
-          </a:xfrm>
-          <a:prstGeom prst="rect">
-            <a:avLst/>
-          </a:prstGeom>
-          <a:solidFill>
-            <a:srgbClr val="FFFFFF"/>
+          <p:cNvPr id="221" name="MS1"/>
+          <p:cNvSpPr/>
+          <p:nvPr/>
+        </p:nvSpPr>
+        <p:spPr>
+          <a:xfrm>
+            <a:off x="5177790" y="4254246"/>
+            <a:ext cx="182880" cy="182880"/>
+          </a:xfrm>
+          <a:prstGeom prst="ellipse">
+            <a:avLst/>
+          </a:prstGeom>
+          <a:solidFill>
+            <a:srgbClr val="C9B991"/>
           </a:solidFill>
           <a:ln>
             <a:noFill/>
@@ -6392,20 +6392,20 @@
       </p:sp>
       <p:sp>
         <p:nvSpPr>
-          <p:cNvPr id="215" name="KM1"/>
-          <p:cNvSpPr/>
-          <p:nvPr/>
-        </p:nvSpPr>
-        <p:spPr>
-          <a:xfrm>
-            <a:off x="5577840" y="4389120"/>
-            <a:ext cx="457200" cy="27432"/>
-          </a:xfrm>
-          <a:prstGeom prst="rect">
-            <a:avLst/>
-          </a:prstGeom>
-          <a:solidFill>
-            <a:srgbClr val="FFFFFF"/>
+          <p:cNvPr id="222" name="MS2"/>
+          <p:cNvSpPr/>
+          <p:nvPr/>
+        </p:nvSpPr>
+        <p:spPr>
+          <a:xfrm>
+            <a:off x="5452110" y="4311396"/>
+            <a:ext cx="228600" cy="68580"/>
+          </a:xfrm>
+          <a:prstGeom prst="rect">
+            <a:avLst/>
+          </a:prstGeom>
+          <a:solidFill>
+            <a:srgbClr val="C9B991"/>
           </a:solidFill>
           <a:ln>
             <a:noFill/>
@@ -6419,32 +6419,192 @@
           </a:p>
         </p:txBody>
       </p:sp>
-      <p:sp>
-        <p:nvSpPr>
-          <p:cNvPr id="216" name="KM2"/>
-          <p:cNvSpPr/>
-          <p:nvPr/>
-        </p:nvSpPr>
-        <p:spPr>
-          <a:xfrm>
-            <a:off x="5577840" y="4462272"/>
-            <a:ext cx="457200" cy="27432"/>
-          </a:xfrm>
-          <a:prstGeom prst="rect">
-            <a:avLst/>
-          </a:prstGeom>
-          <a:solidFill>
-            <a:srgbClr val="FFFFFF"/>
-          </a:solidFill>
+      <p:cxnSp>
+        <p:nvCxnSpPr>
+          <p:cNvPr id="223" name="RAr2"/>
+          <p:cNvCxnSpPr/>
+          <p:nvPr/>
+        </p:nvCxnSpPr>
+        <p:spPr>
+          <a:xfrm>
+            <a:off x="5829840" y="4345686"/>
+            <a:ext cx="548640" cy="0"/>
+          </a:xfrm>
+          <a:prstGeom prst="straightConnector1">
+            <a:avLst/>
+          </a:prstGeom>
+          <a:ln w="28575">
+            <a:solidFill>
+              <a:srgbClr val="8E6F3E"/>
+            </a:solidFill>
+            <a:headEnd type="triangle" w="med" len="med"/>
+          </a:ln>
+        </p:spPr>
+      </p:cxnSp>
+      <p:sp>
+        <p:nvSpPr>
+          <p:cNvPr id="224" name="ReqIcon"/>
+          <p:cNvSpPr/>
+          <p:nvPr/>
+        </p:nvSpPr>
+        <p:spPr>
+          <a:xfrm>
+            <a:off x="6515640" y="4185666"/>
+            <a:ext cx="320040" cy="320040"/>
+          </a:xfrm>
+          <a:custGeom>
+            <a:avLst/>
+            <a:gdLst/>
+            <a:ahLst/>
+            <a:cxnLst/>
+            <a:rect l="0" t="0" r="320040" b="320040"/>
+            <a:pathLst>
+              <a:path w="320040" h="320040" fill="none">
+                <a:moveTo>
+                  <a:pt x="48006" y="176022"/>
+                </a:moveTo>
+                <a:lnTo>
+                  <a:pt x="128016" y="264033"/>
+                </a:lnTo>
+                <a:lnTo>
+                  <a:pt x="272034" y="64008"/>
+                </a:lnTo>
+              </a:path>
+            </a:pathLst>
+          </a:custGeom>
+          <a:noFill/>
+          <a:ln w="57150" cap="rnd">
+            <a:solidFill>
+              <a:srgbClr val="8E6F3E"/>
+            </a:solidFill>
+            <a:round/>
+          </a:ln>
+        </p:spPr>
+        <p:txBody>
+          <a:bodyPr/>
+          <a:lstStyle/>
+          <a:p>
+            <a:endParaRPr lang="en-US"/>
+          </a:p>
+        </p:txBody>
+      </p:sp>
+      <p:sp>
+        <p:nvSpPr>
+          <p:cNvPr id="225" name="LblTerritory"/>
+          <p:cNvSpPr txBox="1"/>
+          <p:nvPr/>
+        </p:nvSpPr>
+        <p:spPr>
+          <a:xfrm>
+            <a:off x="2400300" y="4699000"/>
+            <a:ext cx="1371600" cy="240000"/>
+          </a:xfrm>
+          <a:prstGeom prst="rect">
+            <a:avLst/>
+          </a:prstGeom>
+          <a:noFill/>
           <a:ln>
             <a:noFill/>
           </a:ln>
         </p:spPr>
         <p:txBody>
-          <a:bodyPr/>
-          <a:lstStyle/>
-          <a:p>
-            <a:endParaRPr lang="en-US"/>
+          <a:bodyPr wrap="square" lIns="0" tIns="0" rIns="0" bIns="0" anchor="t"/>
+          <a:lstStyle/>
+          <a:p>
+            <a:pPr algn="ctr">
+              <a:spcAft>
+                <a:spcPts val="0"/>
+              </a:spcAft>
+              <a:buNone/>
+            </a:pPr>
+            <a:r>
+              <a:rPr lang="en-US" sz="1400" b="1" dirty="0">
+                <a:solidFill>
+                  <a:srgbClr val="8E6F3E"/>
+                </a:solidFill>
+              </a:rPr>
+              <a:t>TERRITORY</a:t>
+            </a:r>
+          </a:p>
+        </p:txBody>
+      </p:sp>
+      <p:sp>
+        <p:nvSpPr>
+          <p:cNvPr id="226" name="LblModel"/>
+          <p:cNvSpPr txBox="1"/>
+          <p:nvPr/>
+        </p:nvSpPr>
+        <p:spPr>
+          <a:xfrm>
+            <a:off x="4606290" y="4699000"/>
+            <a:ext cx="1371600" cy="240000"/>
+          </a:xfrm>
+          <a:prstGeom prst="rect">
+            <a:avLst/>
+          </a:prstGeom>
+          <a:noFill/>
+          <a:ln>
+            <a:noFill/>
+          </a:ln>
+        </p:spPr>
+        <p:txBody>
+          <a:bodyPr wrap="square" lIns="0" tIns="0" rIns="0" bIns="0" anchor="t"/>
+          <a:lstStyle/>
+          <a:p>
+            <a:pPr algn="ctr">
+              <a:spcAft>
+                <a:spcPts val="0"/>
+              </a:spcAft>
+              <a:buNone/>
+            </a:pPr>
+            <a:r>
+              <a:rPr lang="en-US" sz="1400" b="1" dirty="0">
+                <a:solidFill>
+                  <a:srgbClr val="8E6F3E"/>
+                </a:solidFill>
+              </a:rPr>
+              <a:t>MODEL</a:t>
+            </a:r>
+          </a:p>
+        </p:txBody>
+      </p:sp>
+      <p:sp>
+        <p:nvSpPr>
+          <p:cNvPr id="227" name="LblObligation"/>
+          <p:cNvSpPr txBox="1"/>
+          <p:nvPr/>
+        </p:nvSpPr>
+        <p:spPr>
+          <a:xfrm>
+            <a:off x="5989860" y="4699000"/>
+            <a:ext cx="1371600" cy="240000"/>
+          </a:xfrm>
+          <a:prstGeom prst="rect">
+            <a:avLst/>
+          </a:prstGeom>
+          <a:noFill/>
+          <a:ln>
+            <a:noFill/>
+          </a:ln>
+        </p:spPr>
+        <p:txBody>
+          <a:bodyPr wrap="square" lIns="0" tIns="0" rIns="0" bIns="0" anchor="t"/>
+          <a:lstStyle/>
+          <a:p>
+            <a:pPr algn="ctr">
+              <a:spcAft>
+                <a:spcPts val="0"/>
+              </a:spcAft>
+              <a:buNone/>
+            </a:pPr>
+            <a:r>
+              <a:rPr lang="en-US" sz="1400" b="1" dirty="0">
+                <a:solidFill>
+                  <a:srgbClr val="8E6F3E"/>
+                </a:solidFill>
+              </a:rPr>
+              <a:t>OBLIGATION</a:t>
+            </a:r>
           </a:p>
         </p:txBody>
       </p:sp>

</xml_diff>

<commit_message>
slides(2-2-Modeling-1): author edits — drop two redundant lines
Authored in PowerPoint by James C Davis.

- slide 1: remove the "THE MOVE THIS LECTURE TEACHES" kicker
- slide 9: remove "They return at every section break in this unit."

Committed ahead of the overhaul so these land in history before that
rebuild moves the slides they sit on.

Co-Authored-By: Claude Opus 5 <noreply@anthropic.com>
</commit_message>
<xml_diff>
--- a/course/lectures/act-2-delegation-and-control/02-modeling/2-2-Modeling-1-Purposeful-Reduction.pptx
+++ b/course/lectures/act-2-delegation-and-control/02-modeling/2-2-Modeling-1-Purposeful-Reduction.pptx
@@ -5857,7 +5857,7 @@
         </p:nvSpPr>
         <p:spPr>
           <a:xfrm>
-            <a:off x="224028" y="1371600"/>
+            <a:off x="224028" y="1829140"/>
             <a:ext cx="8695944" cy="2148840"/>
           </a:xfrm>
           <a:prstGeom prst="rect">
@@ -5922,391 +5922,6 @@
               </a:rPr>
               <a:t>Prof. Steve France</a:t>
             </a:r>
-          </a:p>
-        </p:txBody>
-      </p:sp>
-      <p:sp>
-        <p:nvSpPr>
-          <p:cNvPr id="101" name="Label"/>
-          <p:cNvSpPr txBox="1"/>
-          <p:nvPr/>
-        </p:nvSpPr>
-        <p:spPr>
-          <a:xfrm>
-            <a:off x="224028" y="3639312"/>
-            <a:ext cx="8695944" cy="301752"/>
-          </a:xfrm>
-          <a:prstGeom prst="rect">
-            <a:avLst/>
-          </a:prstGeom>
-          <a:noFill/>
-          <a:ln>
-            <a:noFill/>
-          </a:ln>
-        </p:spPr>
-        <p:txBody>
-          <a:bodyPr wrap="square" lIns="0" tIns="0" rIns="0" bIns="0" anchor="t"/>
-          <a:lstStyle/>
-          <a:p>
-            <a:pPr algn="ctr">
-              <a:buNone/>
-            </a:pPr>
-            <a:r>
-              <a:rPr lang="en-US" sz="2000" b="1" i="0" dirty="0">
-                <a:solidFill>
-                  <a:srgbClr val="8E6F3E"/>
-                </a:solidFill>
-              </a:rPr>
-              <a:t>THE MOVE THIS LECTURE TEACHES</a:t>
-            </a:r>
-          </a:p>
-        </p:txBody>
-      </p:sp>
-      <p:sp>
-        <p:nvSpPr>
-          <p:cNvPr id="200" name="M0"/>
-          <p:cNvSpPr/>
-          <p:nvPr/>
-        </p:nvSpPr>
-        <p:spPr>
-          <a:xfrm>
-            <a:off x="2331720" y="4050792"/>
-            <a:ext cx="182880" cy="182880"/>
-          </a:xfrm>
-          <a:prstGeom prst="rect">
-            <a:avLst/>
-          </a:prstGeom>
-          <a:solidFill>
-            <a:srgbClr val="C9B991"/>
-          </a:solidFill>
-          <a:ln>
-            <a:noFill/>
-          </a:ln>
-        </p:spPr>
-        <p:txBody>
-          <a:bodyPr/>
-          <a:lstStyle/>
-          <a:p>
-            <a:endParaRPr lang="en-US"/>
-          </a:p>
-        </p:txBody>
-      </p:sp>
-      <p:sp>
-        <p:nvSpPr>
-          <p:cNvPr id="201" name="M1"/>
-          <p:cNvSpPr/>
-          <p:nvPr/>
-        </p:nvSpPr>
-        <p:spPr>
-          <a:xfrm>
-            <a:off x="2560320" y="4279392"/>
-            <a:ext cx="137160" cy="137160"/>
-          </a:xfrm>
-          <a:prstGeom prst="ellipse">
-            <a:avLst/>
-          </a:prstGeom>
-          <a:solidFill>
-            <a:srgbClr val="C9B991"/>
-          </a:solidFill>
-          <a:ln>
-            <a:noFill/>
-          </a:ln>
-        </p:spPr>
-        <p:txBody>
-          <a:bodyPr/>
-          <a:lstStyle/>
-          <a:p>
-            <a:endParaRPr lang="en-US"/>
-          </a:p>
-        </p:txBody>
-      </p:sp>
-      <p:sp>
-        <p:nvSpPr>
-          <p:cNvPr id="202" name="M2"/>
-          <p:cNvSpPr/>
-          <p:nvPr/>
-        </p:nvSpPr>
-        <p:spPr>
-          <a:xfrm>
-            <a:off x="2434590" y="4576572"/>
-            <a:ext cx="228600" cy="68580"/>
-          </a:xfrm>
-          <a:prstGeom prst="rect">
-            <a:avLst/>
-          </a:prstGeom>
-          <a:solidFill>
-            <a:srgbClr val="C9B991"/>
-          </a:solidFill>
-          <a:ln>
-            <a:noFill/>
-          </a:ln>
-        </p:spPr>
-        <p:txBody>
-          <a:bodyPr/>
-          <a:lstStyle/>
-          <a:p>
-            <a:endParaRPr lang="en-US"/>
-          </a:p>
-        </p:txBody>
-      </p:sp>
-      <p:sp>
-        <p:nvSpPr>
-          <p:cNvPr id="203" name="M3"/>
-          <p:cNvSpPr/>
-          <p:nvPr/>
-        </p:nvSpPr>
-        <p:spPr>
-          <a:xfrm>
-            <a:off x="2743200" y="4023360"/>
-            <a:ext cx="205740" cy="137160"/>
-          </a:xfrm>
-          <a:prstGeom prst="rect">
-            <a:avLst/>
-          </a:prstGeom>
-          <a:solidFill>
-            <a:srgbClr val="C9B991"/>
-          </a:solidFill>
-          <a:ln>
-            <a:noFill/>
-          </a:ln>
-        </p:spPr>
-        <p:txBody>
-          <a:bodyPr/>
-          <a:lstStyle/>
-          <a:p>
-            <a:endParaRPr lang="en-US"/>
-          </a:p>
-        </p:txBody>
-      </p:sp>
-      <p:sp>
-        <p:nvSpPr>
-          <p:cNvPr id="204" name="M4"/>
-          <p:cNvSpPr/>
-          <p:nvPr/>
-        </p:nvSpPr>
-        <p:spPr>
-          <a:xfrm>
-            <a:off x="2834640" y="4416552"/>
-            <a:ext cx="182880" cy="182880"/>
-          </a:xfrm>
-          <a:prstGeom prst="ellipse">
-            <a:avLst/>
-          </a:prstGeom>
-          <a:solidFill>
-            <a:srgbClr val="C9B991"/>
-          </a:solidFill>
-          <a:ln>
-            <a:noFill/>
-          </a:ln>
-        </p:spPr>
-        <p:txBody>
-          <a:bodyPr/>
-          <a:lstStyle/>
-          <a:p>
-            <a:endParaRPr lang="en-US"/>
-          </a:p>
-        </p:txBody>
-      </p:sp>
-      <p:sp>
-        <p:nvSpPr>
-          <p:cNvPr id="205" name="M5"/>
-          <p:cNvSpPr/>
-          <p:nvPr/>
-        </p:nvSpPr>
-        <p:spPr>
-          <a:xfrm>
-            <a:off x="3017520" y="4050792"/>
-            <a:ext cx="137160" cy="205740"/>
-          </a:xfrm>
-          <a:prstGeom prst="rect">
-            <a:avLst/>
-          </a:prstGeom>
-          <a:solidFill>
-            <a:srgbClr val="C9B991"/>
-          </a:solidFill>
-          <a:ln>
-            <a:noFill/>
-          </a:ln>
-        </p:spPr>
-        <p:txBody>
-          <a:bodyPr/>
-          <a:lstStyle/>
-          <a:p>
-            <a:endParaRPr lang="en-US"/>
-          </a:p>
-        </p:txBody>
-      </p:sp>
-      <p:sp>
-        <p:nvSpPr>
-          <p:cNvPr id="206" name="M6"/>
-          <p:cNvSpPr/>
-          <p:nvPr/>
-        </p:nvSpPr>
-        <p:spPr>
-          <a:xfrm>
-            <a:off x="3154680" y="4462272"/>
-            <a:ext cx="114300" cy="114300"/>
-          </a:xfrm>
-          <a:prstGeom prst="ellipse">
-            <a:avLst/>
-          </a:prstGeom>
-          <a:solidFill>
-            <a:srgbClr val="C9B991"/>
-          </a:solidFill>
-          <a:ln>
-            <a:noFill/>
-          </a:ln>
-        </p:spPr>
-        <p:txBody>
-          <a:bodyPr/>
-          <a:lstStyle/>
-          <a:p>
-            <a:endParaRPr lang="en-US"/>
-          </a:p>
-        </p:txBody>
-      </p:sp>
-      <p:sp>
-        <p:nvSpPr>
-          <p:cNvPr id="207" name="M7"/>
-          <p:cNvSpPr/>
-          <p:nvPr/>
-        </p:nvSpPr>
-        <p:spPr>
-          <a:xfrm>
-            <a:off x="3246120" y="4233672"/>
-            <a:ext cx="160020" cy="160020"/>
-          </a:xfrm>
-          <a:prstGeom prst="rect">
-            <a:avLst/>
-          </a:prstGeom>
-          <a:solidFill>
-            <a:srgbClr val="C9B991"/>
-          </a:solidFill>
-          <a:ln>
-            <a:noFill/>
-          </a:ln>
-        </p:spPr>
-        <p:txBody>
-          <a:bodyPr/>
-          <a:lstStyle/>
-          <a:p>
-            <a:endParaRPr lang="en-US"/>
-          </a:p>
-        </p:txBody>
-      </p:sp>
-      <p:sp>
-        <p:nvSpPr>
-          <p:cNvPr id="208" name="M8"/>
-          <p:cNvSpPr/>
-          <p:nvPr/>
-        </p:nvSpPr>
-        <p:spPr>
-          <a:xfrm>
-            <a:off x="3383280" y="4023360"/>
-            <a:ext cx="137160" cy="137160"/>
-          </a:xfrm>
-          <a:prstGeom prst="rect">
-            <a:avLst/>
-          </a:prstGeom>
-          <a:solidFill>
-            <a:srgbClr val="C9B991"/>
-          </a:solidFill>
-          <a:ln>
-            <a:noFill/>
-          </a:ln>
-        </p:spPr>
-        <p:txBody>
-          <a:bodyPr/>
-          <a:lstStyle/>
-          <a:p>
-            <a:endParaRPr lang="en-US"/>
-          </a:p>
-        </p:txBody>
-      </p:sp>
-      <p:sp>
-        <p:nvSpPr>
-          <p:cNvPr id="209" name="M9"/>
-          <p:cNvSpPr/>
-          <p:nvPr/>
-        </p:nvSpPr>
-        <p:spPr>
-          <a:xfrm>
-            <a:off x="3474720" y="4462272"/>
-            <a:ext cx="137160" cy="137160"/>
-          </a:xfrm>
-          <a:prstGeom prst="ellipse">
-            <a:avLst/>
-          </a:prstGeom>
-          <a:solidFill>
-            <a:srgbClr val="C9B991"/>
-          </a:solidFill>
-          <a:ln>
-            <a:noFill/>
-          </a:ln>
-        </p:spPr>
-        <p:txBody>
-          <a:bodyPr/>
-          <a:lstStyle/>
-          <a:p>
-            <a:endParaRPr lang="en-US"/>
-          </a:p>
-        </p:txBody>
-      </p:sp>
-      <p:sp>
-        <p:nvSpPr>
-          <p:cNvPr id="210" name="M10"/>
-          <p:cNvSpPr/>
-          <p:nvPr/>
-        </p:nvSpPr>
-        <p:spPr>
-          <a:xfrm>
-            <a:off x="3611880" y="4279392"/>
-            <a:ext cx="114300" cy="114300"/>
-          </a:xfrm>
-          <a:prstGeom prst="rect">
-            <a:avLst/>
-          </a:prstGeom>
-          <a:solidFill>
-            <a:srgbClr val="C9B991"/>
-          </a:solidFill>
-          <a:ln>
-            <a:noFill/>
-          </a:ln>
-        </p:spPr>
-        <p:txBody>
-          <a:bodyPr/>
-          <a:lstStyle/>
-          <a:p>
-            <a:endParaRPr lang="en-US"/>
-          </a:p>
-        </p:txBody>
-      </p:sp>
-      <p:sp>
-        <p:nvSpPr>
-          <p:cNvPr id="211" name="M11"/>
-          <p:cNvSpPr/>
-          <p:nvPr/>
-        </p:nvSpPr>
-        <p:spPr>
-          <a:xfrm>
-            <a:off x="3749040" y="4096512"/>
-            <a:ext cx="91440" cy="91440"/>
-          </a:xfrm>
-          <a:prstGeom prst="ellipse">
-            <a:avLst/>
-          </a:prstGeom>
-          <a:solidFill>
-            <a:srgbClr val="C9B991"/>
-          </a:solidFill>
-          <a:ln>
-            <a:noFill/>
-          </a:ln>
-        </p:spPr>
-        <p:txBody>
-          <a:bodyPr/>
-          <a:lstStyle/>
-          <a:p>
-            <a:endParaRPr lang="en-US"/>
           </a:p>
         </p:txBody>
       </p:sp>
@@ -6318,13 +5933,13 @@
         </p:nvCxnSpPr>
         <p:spPr>
           <a:xfrm>
-            <a:off x="4097655" y="4345686"/>
+            <a:off x="2903015" y="3963221"/>
             <a:ext cx="548640" cy="0"/>
           </a:xfrm>
           <a:prstGeom prst="straightConnector1">
             <a:avLst/>
           </a:prstGeom>
-          <a:ln w="28575">
+          <a:ln w="57150">
             <a:solidFill>
               <a:srgbClr val="8E6F3E"/>
             </a:solidFill>
@@ -6332,93 +5947,6 @@
           </a:ln>
         </p:spPr>
       </p:cxnSp>
-      <p:sp>
-        <p:nvSpPr>
-          <p:cNvPr id="220" name="MS0"/>
-          <p:cNvSpPr/>
-          <p:nvPr/>
-        </p:nvSpPr>
-        <p:spPr>
-          <a:xfrm>
-            <a:off x="4903470" y="4254246"/>
-            <a:ext cx="182880" cy="182880"/>
-          </a:xfrm>
-          <a:prstGeom prst="rect">
-            <a:avLst/>
-          </a:prstGeom>
-          <a:solidFill>
-            <a:srgbClr val="C9B991"/>
-          </a:solidFill>
-          <a:ln>
-            <a:noFill/>
-          </a:ln>
-        </p:spPr>
-        <p:txBody>
-          <a:bodyPr/>
-          <a:lstStyle/>
-          <a:p>
-            <a:endParaRPr lang="en-US"/>
-          </a:p>
-        </p:txBody>
-      </p:sp>
-      <p:sp>
-        <p:nvSpPr>
-          <p:cNvPr id="221" name="MS1"/>
-          <p:cNvSpPr/>
-          <p:nvPr/>
-        </p:nvSpPr>
-        <p:spPr>
-          <a:xfrm>
-            <a:off x="5177790" y="4254246"/>
-            <a:ext cx="182880" cy="182880"/>
-          </a:xfrm>
-          <a:prstGeom prst="ellipse">
-            <a:avLst/>
-          </a:prstGeom>
-          <a:solidFill>
-            <a:srgbClr val="C9B991"/>
-          </a:solidFill>
-          <a:ln>
-            <a:noFill/>
-          </a:ln>
-        </p:spPr>
-        <p:txBody>
-          <a:bodyPr/>
-          <a:lstStyle/>
-          <a:p>
-            <a:endParaRPr lang="en-US"/>
-          </a:p>
-        </p:txBody>
-      </p:sp>
-      <p:sp>
-        <p:nvSpPr>
-          <p:cNvPr id="222" name="MS2"/>
-          <p:cNvSpPr/>
-          <p:nvPr/>
-        </p:nvSpPr>
-        <p:spPr>
-          <a:xfrm>
-            <a:off x="5452110" y="4311396"/>
-            <a:ext cx="228600" cy="68580"/>
-          </a:xfrm>
-          <a:prstGeom prst="rect">
-            <a:avLst/>
-          </a:prstGeom>
-          <a:solidFill>
-            <a:srgbClr val="C9B991"/>
-          </a:solidFill>
-          <a:ln>
-            <a:noFill/>
-          </a:ln>
-        </p:spPr>
-        <p:txBody>
-          <a:bodyPr/>
-          <a:lstStyle/>
-          <a:p>
-            <a:endParaRPr lang="en-US"/>
-          </a:p>
-        </p:txBody>
-      </p:sp>
       <p:cxnSp>
         <p:nvCxnSpPr>
           <p:cNvPr id="223" name="RAr2"/>
@@ -6427,13 +5955,13 @@
         </p:nvCxnSpPr>
         <p:spPr>
           <a:xfrm>
-            <a:off x="5829840" y="4345686"/>
+            <a:off x="5615862" y="3963221"/>
             <a:ext cx="548640" cy="0"/>
           </a:xfrm>
           <a:prstGeom prst="straightConnector1">
             <a:avLst/>
           </a:prstGeom>
-          <a:ln w="28575">
+          <a:ln w="57150">
             <a:solidFill>
               <a:srgbClr val="8E6F3E"/>
             </a:solidFill>
@@ -6441,173 +5969,262 @@
           </a:ln>
         </p:spPr>
       </p:cxnSp>
-      <p:sp>
-        <p:nvSpPr>
-          <p:cNvPr id="224" name="ReqIcon"/>
-          <p:cNvSpPr/>
-          <p:nvPr/>
-        </p:nvSpPr>
-        <p:spPr>
-          <a:xfrm>
-            <a:off x="6515640" y="4185666"/>
-            <a:ext cx="320040" cy="320040"/>
-          </a:xfrm>
-          <a:custGeom>
-            <a:avLst/>
-            <a:gdLst/>
-            <a:ahLst/>
-            <a:cxnLst/>
-            <a:rect l="0" t="0" r="320040" b="320040"/>
-            <a:pathLst>
-              <a:path w="320040" h="320040" fill="none">
-                <a:moveTo>
-                  <a:pt x="48006" y="176022"/>
-                </a:moveTo>
-                <a:lnTo>
-                  <a:pt x="128016" y="264033"/>
-                </a:lnTo>
-                <a:lnTo>
-                  <a:pt x="272034" y="64008"/>
-                </a:lnTo>
-              </a:path>
-            </a:pathLst>
-          </a:custGeom>
-          <a:noFill/>
-          <a:ln w="57150" cap="rnd">
-            <a:solidFill>
-              <a:srgbClr val="8E6F3E"/>
-            </a:solidFill>
-            <a:round/>
-          </a:ln>
-        </p:spPr>
-        <p:txBody>
-          <a:bodyPr/>
-          <a:lstStyle/>
-          <a:p>
-            <a:endParaRPr lang="en-US"/>
-          </a:p>
-        </p:txBody>
-      </p:sp>
-      <p:sp>
-        <p:nvSpPr>
-          <p:cNvPr id="225" name="LblTerritory"/>
-          <p:cNvSpPr txBox="1"/>
-          <p:nvPr/>
-        </p:nvSpPr>
-        <p:spPr>
-          <a:xfrm>
-            <a:off x="2400300" y="4699000"/>
-            <a:ext cx="1371600" cy="240000"/>
-          </a:xfrm>
-          <a:prstGeom prst="rect">
-            <a:avLst/>
-          </a:prstGeom>
-          <a:noFill/>
-          <a:ln>
+      <p:grpSp>
+        <p:nvGrpSpPr>
+          <p:cNvPr id="17" name="Group 16">
+            <a:extLst>
+              <a:ext uri="{FF2B5EF4-FFF2-40B4-BE49-F238E27FC236}">
+                <a16:creationId xmlns:a16="http://schemas.microsoft.com/office/drawing/2014/main" id="{AC5098E7-4E8B-C248-A6EB-785537FE5FB8}"/>
+              </a:ext>
+            </a:extLst>
+          </p:cNvPr>
+          <p:cNvGrpSpPr/>
+          <p:nvPr/>
+        </p:nvGrpSpPr>
+        <p:grpSpPr>
+          <a:xfrm>
+            <a:off x="3928755" y="3870568"/>
+            <a:ext cx="1371600" cy="684754"/>
+            <a:chOff x="4606290" y="4254246"/>
+            <a:chExt cx="1371600" cy="684754"/>
+          </a:xfrm>
+        </p:grpSpPr>
+        <p:sp>
+          <p:nvSpPr>
+            <p:cNvPr id="220" name="MS0"/>
+            <p:cNvSpPr/>
+            <p:nvPr/>
+          </p:nvSpPr>
+          <p:spPr>
+            <a:xfrm>
+              <a:off x="4903470" y="4254246"/>
+              <a:ext cx="182880" cy="182880"/>
+            </a:xfrm>
+            <a:prstGeom prst="rect">
+              <a:avLst/>
+            </a:prstGeom>
+            <a:solidFill>
+              <a:srgbClr val="C9B991"/>
+            </a:solidFill>
+            <a:ln>
+              <a:noFill/>
+            </a:ln>
+          </p:spPr>
+          <p:txBody>
+            <a:bodyPr/>
+            <a:lstStyle/>
+            <a:p>
+              <a:endParaRPr lang="en-US"/>
+            </a:p>
+          </p:txBody>
+        </p:sp>
+        <p:sp>
+          <p:nvSpPr>
+            <p:cNvPr id="221" name="MS1"/>
+            <p:cNvSpPr/>
+            <p:nvPr/>
+          </p:nvSpPr>
+          <p:spPr>
+            <a:xfrm>
+              <a:off x="5177790" y="4254246"/>
+              <a:ext cx="182880" cy="182880"/>
+            </a:xfrm>
+            <a:prstGeom prst="ellipse">
+              <a:avLst/>
+            </a:prstGeom>
+            <a:solidFill>
+              <a:srgbClr val="C9B991"/>
+            </a:solidFill>
+            <a:ln>
+              <a:noFill/>
+            </a:ln>
+          </p:spPr>
+          <p:txBody>
+            <a:bodyPr/>
+            <a:lstStyle/>
+            <a:p>
+              <a:endParaRPr lang="en-US"/>
+            </a:p>
+          </p:txBody>
+        </p:sp>
+        <p:sp>
+          <p:nvSpPr>
+            <p:cNvPr id="222" name="MS2"/>
+            <p:cNvSpPr/>
+            <p:nvPr/>
+          </p:nvSpPr>
+          <p:spPr>
+            <a:xfrm>
+              <a:off x="5452110" y="4311396"/>
+              <a:ext cx="228600" cy="68580"/>
+            </a:xfrm>
+            <a:prstGeom prst="rect">
+              <a:avLst/>
+            </a:prstGeom>
+            <a:solidFill>
+              <a:srgbClr val="C9B991"/>
+            </a:solidFill>
+            <a:ln>
+              <a:noFill/>
+            </a:ln>
+          </p:spPr>
+          <p:txBody>
+            <a:bodyPr/>
+            <a:lstStyle/>
+            <a:p>
+              <a:endParaRPr lang="en-US"/>
+            </a:p>
+          </p:txBody>
+        </p:sp>
+        <p:sp>
+          <p:nvSpPr>
+            <p:cNvPr id="226" name="LblModel"/>
+            <p:cNvSpPr txBox="1"/>
+            <p:nvPr/>
+          </p:nvSpPr>
+          <p:spPr>
+            <a:xfrm>
+              <a:off x="4606290" y="4699000"/>
+              <a:ext cx="1371600" cy="240000"/>
+            </a:xfrm>
+            <a:prstGeom prst="rect">
+              <a:avLst/>
+            </a:prstGeom>
             <a:noFill/>
-          </a:ln>
-        </p:spPr>
-        <p:txBody>
-          <a:bodyPr wrap="square" lIns="0" tIns="0" rIns="0" bIns="0" anchor="t"/>
-          <a:lstStyle/>
-          <a:p>
-            <a:pPr algn="ctr">
-              <a:spcAft>
-                <a:spcPts val="0"/>
-              </a:spcAft>
-              <a:buNone/>
-            </a:pPr>
-            <a:r>
-              <a:rPr lang="en-US" sz="1400" b="1" dirty="0">
-                <a:solidFill>
-                  <a:srgbClr val="8E6F3E"/>
-                </a:solidFill>
-              </a:rPr>
-              <a:t>TERRITORY</a:t>
-            </a:r>
-          </a:p>
-        </p:txBody>
-      </p:sp>
-      <p:sp>
-        <p:nvSpPr>
-          <p:cNvPr id="226" name="LblModel"/>
-          <p:cNvSpPr txBox="1"/>
-          <p:nvPr/>
-        </p:nvSpPr>
-        <p:spPr>
-          <a:xfrm>
-            <a:off x="4606290" y="4699000"/>
-            <a:ext cx="1371600" cy="240000"/>
-          </a:xfrm>
-          <a:prstGeom prst="rect">
-            <a:avLst/>
-          </a:prstGeom>
-          <a:noFill/>
-          <a:ln>
+            <a:ln>
+              <a:noFill/>
+            </a:ln>
+          </p:spPr>
+          <p:txBody>
+            <a:bodyPr wrap="square" lIns="0" tIns="0" rIns="0" bIns="0" anchor="t"/>
+            <a:lstStyle/>
+            <a:p>
+              <a:pPr algn="ctr">
+                <a:spcAft>
+                  <a:spcPts val="0"/>
+                </a:spcAft>
+                <a:buNone/>
+              </a:pPr>
+              <a:r>
+                <a:rPr lang="en-US" sz="1400" b="1" dirty="0">
+                  <a:solidFill>
+                    <a:srgbClr val="8E6F3E"/>
+                  </a:solidFill>
+                </a:rPr>
+                <a:t>MODEL</a:t>
+              </a:r>
+            </a:p>
+          </p:txBody>
+        </p:sp>
+      </p:grpSp>
+      <p:grpSp>
+        <p:nvGrpSpPr>
+          <p:cNvPr id="18" name="Group 17">
+            <a:extLst>
+              <a:ext uri="{FF2B5EF4-FFF2-40B4-BE49-F238E27FC236}">
+                <a16:creationId xmlns:a16="http://schemas.microsoft.com/office/drawing/2014/main" id="{DD69ACE2-8677-E377-1F0F-4C6678A1F180}"/>
+              </a:ext>
+            </a:extLst>
+          </p:cNvPr>
+          <p:cNvGrpSpPr/>
+          <p:nvPr/>
+        </p:nvGrpSpPr>
+        <p:grpSpPr>
+          <a:xfrm>
+            <a:off x="1262400" y="3757776"/>
+            <a:ext cx="1371600" cy="753334"/>
+            <a:chOff x="2146730" y="4130536"/>
+            <a:chExt cx="1371600" cy="753334"/>
+          </a:xfrm>
+        </p:grpSpPr>
+        <p:sp>
+          <p:nvSpPr>
+            <p:cNvPr id="224" name="ReqIcon"/>
+            <p:cNvSpPr/>
+            <p:nvPr/>
+          </p:nvSpPr>
+          <p:spPr>
+            <a:xfrm>
+              <a:off x="2672510" y="4130536"/>
+              <a:ext cx="320040" cy="320040"/>
+            </a:xfrm>
+            <a:custGeom>
+              <a:avLst/>
+              <a:gdLst/>
+              <a:ahLst/>
+              <a:cxnLst/>
+              <a:rect l="0" t="0" r="320040" b="320040"/>
+              <a:pathLst>
+                <a:path w="320040" h="320040" fill="none">
+                  <a:moveTo>
+                    <a:pt x="48006" y="176022"/>
+                  </a:moveTo>
+                  <a:lnTo>
+                    <a:pt x="128016" y="264033"/>
+                  </a:lnTo>
+                  <a:lnTo>
+                    <a:pt x="272034" y="64008"/>
+                  </a:lnTo>
+                </a:path>
+              </a:pathLst>
+            </a:custGeom>
             <a:noFill/>
-          </a:ln>
-        </p:spPr>
-        <p:txBody>
-          <a:bodyPr wrap="square" lIns="0" tIns="0" rIns="0" bIns="0" anchor="t"/>
-          <a:lstStyle/>
-          <a:p>
-            <a:pPr algn="ctr">
-              <a:spcAft>
-                <a:spcPts val="0"/>
-              </a:spcAft>
-              <a:buNone/>
-            </a:pPr>
-            <a:r>
-              <a:rPr lang="en-US" sz="1400" b="1" dirty="0">
-                <a:solidFill>
-                  <a:srgbClr val="8E6F3E"/>
-                </a:solidFill>
-              </a:rPr>
-              <a:t>MODEL</a:t>
-            </a:r>
-          </a:p>
-        </p:txBody>
-      </p:sp>
-      <p:sp>
-        <p:nvSpPr>
-          <p:cNvPr id="227" name="LblObligation"/>
-          <p:cNvSpPr txBox="1"/>
-          <p:nvPr/>
-        </p:nvSpPr>
-        <p:spPr>
-          <a:xfrm>
-            <a:off x="5989860" y="4699000"/>
-            <a:ext cx="1371600" cy="240000"/>
-          </a:xfrm>
-          <a:prstGeom prst="rect">
-            <a:avLst/>
-          </a:prstGeom>
-          <a:noFill/>
-          <a:ln>
+            <a:ln w="57150" cap="rnd">
+              <a:solidFill>
+                <a:srgbClr val="8E6F3E"/>
+              </a:solidFill>
+              <a:round/>
+            </a:ln>
+          </p:spPr>
+          <p:txBody>
+            <a:bodyPr/>
+            <a:lstStyle/>
+            <a:p>
+              <a:endParaRPr lang="en-US"/>
+            </a:p>
+          </p:txBody>
+        </p:sp>
+        <p:sp>
+          <p:nvSpPr>
+            <p:cNvPr id="227" name="LblObligation"/>
+            <p:cNvSpPr txBox="1"/>
+            <p:nvPr/>
+          </p:nvSpPr>
+          <p:spPr>
+            <a:xfrm>
+              <a:off x="2146730" y="4643870"/>
+              <a:ext cx="1371600" cy="240000"/>
+            </a:xfrm>
+            <a:prstGeom prst="rect">
+              <a:avLst/>
+            </a:prstGeom>
             <a:noFill/>
-          </a:ln>
-        </p:spPr>
-        <p:txBody>
-          <a:bodyPr wrap="square" lIns="0" tIns="0" rIns="0" bIns="0" anchor="t"/>
-          <a:lstStyle/>
-          <a:p>
-            <a:pPr algn="ctr">
-              <a:spcAft>
-                <a:spcPts val="0"/>
-              </a:spcAft>
-              <a:buNone/>
-            </a:pPr>
-            <a:r>
-              <a:rPr lang="en-US" sz="1400" b="1" dirty="0">
-                <a:solidFill>
-                  <a:srgbClr val="8E6F3E"/>
-                </a:solidFill>
-              </a:rPr>
-              <a:t>OBLIGATION</a:t>
-            </a:r>
-          </a:p>
-        </p:txBody>
-      </p:sp>
+            <a:ln>
+              <a:noFill/>
+            </a:ln>
+          </p:spPr>
+          <p:txBody>
+            <a:bodyPr wrap="square" lIns="0" tIns="0" rIns="0" bIns="0" anchor="t"/>
+            <a:lstStyle/>
+            <a:p>
+              <a:pPr algn="ctr">
+                <a:spcAft>
+                  <a:spcPts val="0"/>
+                </a:spcAft>
+                <a:buNone/>
+              </a:pPr>
+              <a:r>
+                <a:rPr lang="en-US" sz="1400" b="1" dirty="0">
+                  <a:solidFill>
+                    <a:srgbClr val="8E6F3E"/>
+                  </a:solidFill>
+                </a:rPr>
+                <a:t>OBLIGATION</a:t>
+              </a:r>
+            </a:p>
+          </p:txBody>
+        </p:sp>
+      </p:grpSp>
       <p:sp>
         <p:nvSpPr>
           <p:cNvPr id="109" name="TwoLines"/>
@@ -6693,6 +6310,493 @@
           </a:p>
         </p:txBody>
       </p:sp>
+      <p:grpSp>
+        <p:nvGrpSpPr>
+          <p:cNvPr id="19" name="Group 18">
+            <a:extLst>
+              <a:ext uri="{FF2B5EF4-FFF2-40B4-BE49-F238E27FC236}">
+                <a16:creationId xmlns:a16="http://schemas.microsoft.com/office/drawing/2014/main" id="{6F3A5A9A-02FE-680C-23F4-3B3CEC707CD7}"/>
+              </a:ext>
+            </a:extLst>
+          </p:cNvPr>
+          <p:cNvGrpSpPr/>
+          <p:nvPr/>
+        </p:nvGrpSpPr>
+        <p:grpSpPr>
+          <a:xfrm>
+            <a:off x="6732270" y="3639682"/>
+            <a:ext cx="1508760" cy="915640"/>
+            <a:chOff x="6691685" y="4023360"/>
+            <a:chExt cx="1508760" cy="915640"/>
+          </a:xfrm>
+        </p:grpSpPr>
+        <p:sp>
+          <p:nvSpPr>
+            <p:cNvPr id="4" name="M0">
+              <a:extLst>
+                <a:ext uri="{FF2B5EF4-FFF2-40B4-BE49-F238E27FC236}">
+                  <a16:creationId xmlns:a16="http://schemas.microsoft.com/office/drawing/2014/main" id="{E193AD8B-3A76-AD0C-5D1D-311D7DD87F69}"/>
+                </a:ext>
+              </a:extLst>
+            </p:cNvPr>
+            <p:cNvSpPr/>
+            <p:nvPr/>
+          </p:nvSpPr>
+          <p:spPr>
+            <a:xfrm>
+              <a:off x="6691685" y="4050792"/>
+              <a:ext cx="182880" cy="182880"/>
+            </a:xfrm>
+            <a:prstGeom prst="rect">
+              <a:avLst/>
+            </a:prstGeom>
+            <a:solidFill>
+              <a:srgbClr val="C9B991"/>
+            </a:solidFill>
+            <a:ln>
+              <a:noFill/>
+            </a:ln>
+          </p:spPr>
+          <p:txBody>
+            <a:bodyPr/>
+            <a:lstStyle/>
+            <a:p>
+              <a:endParaRPr lang="en-US"/>
+            </a:p>
+          </p:txBody>
+        </p:sp>
+        <p:sp>
+          <p:nvSpPr>
+            <p:cNvPr id="5" name="M1">
+              <a:extLst>
+                <a:ext uri="{FF2B5EF4-FFF2-40B4-BE49-F238E27FC236}">
+                  <a16:creationId xmlns:a16="http://schemas.microsoft.com/office/drawing/2014/main" id="{0DC84FBB-88D2-3F25-9332-9C5D93E6ED90}"/>
+                </a:ext>
+              </a:extLst>
+            </p:cNvPr>
+            <p:cNvSpPr/>
+            <p:nvPr/>
+          </p:nvSpPr>
+          <p:spPr>
+            <a:xfrm>
+              <a:off x="6920285" y="4279392"/>
+              <a:ext cx="137160" cy="137160"/>
+            </a:xfrm>
+            <a:prstGeom prst="ellipse">
+              <a:avLst/>
+            </a:prstGeom>
+            <a:solidFill>
+              <a:srgbClr val="C9B991"/>
+            </a:solidFill>
+            <a:ln>
+              <a:noFill/>
+            </a:ln>
+          </p:spPr>
+          <p:txBody>
+            <a:bodyPr/>
+            <a:lstStyle/>
+            <a:p>
+              <a:endParaRPr lang="en-US"/>
+            </a:p>
+          </p:txBody>
+        </p:sp>
+        <p:sp>
+          <p:nvSpPr>
+            <p:cNvPr id="6" name="M2">
+              <a:extLst>
+                <a:ext uri="{FF2B5EF4-FFF2-40B4-BE49-F238E27FC236}">
+                  <a16:creationId xmlns:a16="http://schemas.microsoft.com/office/drawing/2014/main" id="{8DA0E25E-2504-8971-F95B-6AD925DBEA12}"/>
+                </a:ext>
+              </a:extLst>
+            </p:cNvPr>
+            <p:cNvSpPr/>
+            <p:nvPr/>
+          </p:nvSpPr>
+          <p:spPr>
+            <a:xfrm>
+              <a:off x="6794555" y="4576572"/>
+              <a:ext cx="228600" cy="68580"/>
+            </a:xfrm>
+            <a:prstGeom prst="rect">
+              <a:avLst/>
+            </a:prstGeom>
+            <a:solidFill>
+              <a:srgbClr val="C9B991"/>
+            </a:solidFill>
+            <a:ln>
+              <a:noFill/>
+            </a:ln>
+          </p:spPr>
+          <p:txBody>
+            <a:bodyPr/>
+            <a:lstStyle/>
+            <a:p>
+              <a:endParaRPr lang="en-US"/>
+            </a:p>
+          </p:txBody>
+        </p:sp>
+        <p:sp>
+          <p:nvSpPr>
+            <p:cNvPr id="7" name="M3">
+              <a:extLst>
+                <a:ext uri="{FF2B5EF4-FFF2-40B4-BE49-F238E27FC236}">
+                  <a16:creationId xmlns:a16="http://schemas.microsoft.com/office/drawing/2014/main" id="{1EACDCAA-95F5-D55D-4A87-F9995EFD0504}"/>
+                </a:ext>
+              </a:extLst>
+            </p:cNvPr>
+            <p:cNvSpPr/>
+            <p:nvPr/>
+          </p:nvSpPr>
+          <p:spPr>
+            <a:xfrm>
+              <a:off x="7103165" y="4023360"/>
+              <a:ext cx="205740" cy="137160"/>
+            </a:xfrm>
+            <a:prstGeom prst="rect">
+              <a:avLst/>
+            </a:prstGeom>
+            <a:solidFill>
+              <a:srgbClr val="C9B991"/>
+            </a:solidFill>
+            <a:ln>
+              <a:noFill/>
+            </a:ln>
+          </p:spPr>
+          <p:txBody>
+            <a:bodyPr/>
+            <a:lstStyle/>
+            <a:p>
+              <a:endParaRPr lang="en-US"/>
+            </a:p>
+          </p:txBody>
+        </p:sp>
+        <p:sp>
+          <p:nvSpPr>
+            <p:cNvPr id="8" name="M4">
+              <a:extLst>
+                <a:ext uri="{FF2B5EF4-FFF2-40B4-BE49-F238E27FC236}">
+                  <a16:creationId xmlns:a16="http://schemas.microsoft.com/office/drawing/2014/main" id="{09EF95A2-2E68-EF3F-7FF4-9A978E1E2A29}"/>
+                </a:ext>
+              </a:extLst>
+            </p:cNvPr>
+            <p:cNvSpPr/>
+            <p:nvPr/>
+          </p:nvSpPr>
+          <p:spPr>
+            <a:xfrm>
+              <a:off x="7194605" y="4416552"/>
+              <a:ext cx="182880" cy="182880"/>
+            </a:xfrm>
+            <a:prstGeom prst="ellipse">
+              <a:avLst/>
+            </a:prstGeom>
+            <a:solidFill>
+              <a:srgbClr val="C9B991"/>
+            </a:solidFill>
+            <a:ln>
+              <a:noFill/>
+            </a:ln>
+          </p:spPr>
+          <p:txBody>
+            <a:bodyPr/>
+            <a:lstStyle/>
+            <a:p>
+              <a:endParaRPr lang="en-US"/>
+            </a:p>
+          </p:txBody>
+        </p:sp>
+        <p:sp>
+          <p:nvSpPr>
+            <p:cNvPr id="9" name="M5">
+              <a:extLst>
+                <a:ext uri="{FF2B5EF4-FFF2-40B4-BE49-F238E27FC236}">
+                  <a16:creationId xmlns:a16="http://schemas.microsoft.com/office/drawing/2014/main" id="{F53C05BC-A0C0-1BBB-EFC3-2FB3993E0BF7}"/>
+                </a:ext>
+              </a:extLst>
+            </p:cNvPr>
+            <p:cNvSpPr/>
+            <p:nvPr/>
+          </p:nvSpPr>
+          <p:spPr>
+            <a:xfrm>
+              <a:off x="7377485" y="4050792"/>
+              <a:ext cx="137160" cy="205740"/>
+            </a:xfrm>
+            <a:prstGeom prst="rect">
+              <a:avLst/>
+            </a:prstGeom>
+            <a:solidFill>
+              <a:srgbClr val="C9B991"/>
+            </a:solidFill>
+            <a:ln>
+              <a:noFill/>
+            </a:ln>
+          </p:spPr>
+          <p:txBody>
+            <a:bodyPr/>
+            <a:lstStyle/>
+            <a:p>
+              <a:endParaRPr lang="en-US"/>
+            </a:p>
+          </p:txBody>
+        </p:sp>
+        <p:sp>
+          <p:nvSpPr>
+            <p:cNvPr id="10" name="M6">
+              <a:extLst>
+                <a:ext uri="{FF2B5EF4-FFF2-40B4-BE49-F238E27FC236}">
+                  <a16:creationId xmlns:a16="http://schemas.microsoft.com/office/drawing/2014/main" id="{79FA4EDC-A64A-D907-D600-8253B15D50DD}"/>
+                </a:ext>
+              </a:extLst>
+            </p:cNvPr>
+            <p:cNvSpPr/>
+            <p:nvPr/>
+          </p:nvSpPr>
+          <p:spPr>
+            <a:xfrm>
+              <a:off x="7514645" y="4462272"/>
+              <a:ext cx="114300" cy="114300"/>
+            </a:xfrm>
+            <a:prstGeom prst="ellipse">
+              <a:avLst/>
+            </a:prstGeom>
+            <a:solidFill>
+              <a:srgbClr val="C9B991"/>
+            </a:solidFill>
+            <a:ln>
+              <a:noFill/>
+            </a:ln>
+          </p:spPr>
+          <p:txBody>
+            <a:bodyPr/>
+            <a:lstStyle/>
+            <a:p>
+              <a:endParaRPr lang="en-US"/>
+            </a:p>
+          </p:txBody>
+        </p:sp>
+        <p:sp>
+          <p:nvSpPr>
+            <p:cNvPr id="11" name="M7">
+              <a:extLst>
+                <a:ext uri="{FF2B5EF4-FFF2-40B4-BE49-F238E27FC236}">
+                  <a16:creationId xmlns:a16="http://schemas.microsoft.com/office/drawing/2014/main" id="{CF75CA27-268A-39A9-6383-319BA9C46270}"/>
+                </a:ext>
+              </a:extLst>
+            </p:cNvPr>
+            <p:cNvSpPr/>
+            <p:nvPr/>
+          </p:nvSpPr>
+          <p:spPr>
+            <a:xfrm>
+              <a:off x="7606085" y="4233672"/>
+              <a:ext cx="160020" cy="160020"/>
+            </a:xfrm>
+            <a:prstGeom prst="rect">
+              <a:avLst/>
+            </a:prstGeom>
+            <a:solidFill>
+              <a:srgbClr val="C9B991"/>
+            </a:solidFill>
+            <a:ln>
+              <a:noFill/>
+            </a:ln>
+          </p:spPr>
+          <p:txBody>
+            <a:bodyPr/>
+            <a:lstStyle/>
+            <a:p>
+              <a:endParaRPr lang="en-US"/>
+            </a:p>
+          </p:txBody>
+        </p:sp>
+        <p:sp>
+          <p:nvSpPr>
+            <p:cNvPr id="12" name="M8">
+              <a:extLst>
+                <a:ext uri="{FF2B5EF4-FFF2-40B4-BE49-F238E27FC236}">
+                  <a16:creationId xmlns:a16="http://schemas.microsoft.com/office/drawing/2014/main" id="{4A5BECD4-2388-9AD4-0481-7AB90168AA17}"/>
+                </a:ext>
+              </a:extLst>
+            </p:cNvPr>
+            <p:cNvSpPr/>
+            <p:nvPr/>
+          </p:nvSpPr>
+          <p:spPr>
+            <a:xfrm>
+              <a:off x="7743245" y="4023360"/>
+              <a:ext cx="137160" cy="137160"/>
+            </a:xfrm>
+            <a:prstGeom prst="rect">
+              <a:avLst/>
+            </a:prstGeom>
+            <a:solidFill>
+              <a:srgbClr val="C9B991"/>
+            </a:solidFill>
+            <a:ln>
+              <a:noFill/>
+            </a:ln>
+          </p:spPr>
+          <p:txBody>
+            <a:bodyPr/>
+            <a:lstStyle/>
+            <a:p>
+              <a:endParaRPr lang="en-US"/>
+            </a:p>
+          </p:txBody>
+        </p:sp>
+        <p:sp>
+          <p:nvSpPr>
+            <p:cNvPr id="13" name="M9">
+              <a:extLst>
+                <a:ext uri="{FF2B5EF4-FFF2-40B4-BE49-F238E27FC236}">
+                  <a16:creationId xmlns:a16="http://schemas.microsoft.com/office/drawing/2014/main" id="{B0E6D59E-D285-754B-0E11-9D054B7C88D4}"/>
+                </a:ext>
+              </a:extLst>
+            </p:cNvPr>
+            <p:cNvSpPr/>
+            <p:nvPr/>
+          </p:nvSpPr>
+          <p:spPr>
+            <a:xfrm>
+              <a:off x="7834685" y="4462272"/>
+              <a:ext cx="137160" cy="137160"/>
+            </a:xfrm>
+            <a:prstGeom prst="ellipse">
+              <a:avLst/>
+            </a:prstGeom>
+            <a:solidFill>
+              <a:srgbClr val="C9B991"/>
+            </a:solidFill>
+            <a:ln>
+              <a:noFill/>
+            </a:ln>
+          </p:spPr>
+          <p:txBody>
+            <a:bodyPr/>
+            <a:lstStyle/>
+            <a:p>
+              <a:endParaRPr lang="en-US"/>
+            </a:p>
+          </p:txBody>
+        </p:sp>
+        <p:sp>
+          <p:nvSpPr>
+            <p:cNvPr id="14" name="M10">
+              <a:extLst>
+                <a:ext uri="{FF2B5EF4-FFF2-40B4-BE49-F238E27FC236}">
+                  <a16:creationId xmlns:a16="http://schemas.microsoft.com/office/drawing/2014/main" id="{A2233ED2-5254-3491-BD9F-5B1D4BF7FC6A}"/>
+                </a:ext>
+              </a:extLst>
+            </p:cNvPr>
+            <p:cNvSpPr/>
+            <p:nvPr/>
+          </p:nvSpPr>
+          <p:spPr>
+            <a:xfrm>
+              <a:off x="7971845" y="4279392"/>
+              <a:ext cx="114300" cy="114300"/>
+            </a:xfrm>
+            <a:prstGeom prst="rect">
+              <a:avLst/>
+            </a:prstGeom>
+            <a:solidFill>
+              <a:srgbClr val="C9B991"/>
+            </a:solidFill>
+            <a:ln>
+              <a:noFill/>
+            </a:ln>
+          </p:spPr>
+          <p:txBody>
+            <a:bodyPr/>
+            <a:lstStyle/>
+            <a:p>
+              <a:endParaRPr lang="en-US"/>
+            </a:p>
+          </p:txBody>
+        </p:sp>
+        <p:sp>
+          <p:nvSpPr>
+            <p:cNvPr id="15" name="M11">
+              <a:extLst>
+                <a:ext uri="{FF2B5EF4-FFF2-40B4-BE49-F238E27FC236}">
+                  <a16:creationId xmlns:a16="http://schemas.microsoft.com/office/drawing/2014/main" id="{BA4AA580-D524-D7D5-3646-1FB9EED67736}"/>
+                </a:ext>
+              </a:extLst>
+            </p:cNvPr>
+            <p:cNvSpPr/>
+            <p:nvPr/>
+          </p:nvSpPr>
+          <p:spPr>
+            <a:xfrm>
+              <a:off x="8109005" y="4096512"/>
+              <a:ext cx="91440" cy="91440"/>
+            </a:xfrm>
+            <a:prstGeom prst="ellipse">
+              <a:avLst/>
+            </a:prstGeom>
+            <a:solidFill>
+              <a:srgbClr val="C9B991"/>
+            </a:solidFill>
+            <a:ln>
+              <a:noFill/>
+            </a:ln>
+          </p:spPr>
+          <p:txBody>
+            <a:bodyPr/>
+            <a:lstStyle/>
+            <a:p>
+              <a:endParaRPr lang="en-US"/>
+            </a:p>
+          </p:txBody>
+        </p:sp>
+        <p:sp>
+          <p:nvSpPr>
+            <p:cNvPr id="16" name="LblTerritory">
+              <a:extLst>
+                <a:ext uri="{FF2B5EF4-FFF2-40B4-BE49-F238E27FC236}">
+                  <a16:creationId xmlns:a16="http://schemas.microsoft.com/office/drawing/2014/main" id="{2A59FBC1-031C-6BC5-A6ED-2D11AE925F0C}"/>
+                </a:ext>
+              </a:extLst>
+            </p:cNvPr>
+            <p:cNvSpPr txBox="1"/>
+            <p:nvPr/>
+          </p:nvSpPr>
+          <p:spPr>
+            <a:xfrm>
+              <a:off x="6760265" y="4699000"/>
+              <a:ext cx="1371600" cy="240000"/>
+            </a:xfrm>
+            <a:prstGeom prst="rect">
+              <a:avLst/>
+            </a:prstGeom>
+            <a:noFill/>
+            <a:ln>
+              <a:noFill/>
+            </a:ln>
+          </p:spPr>
+          <p:txBody>
+            <a:bodyPr wrap="square" lIns="0" tIns="0" rIns="0" bIns="0" anchor="t"/>
+            <a:lstStyle/>
+            <a:p>
+              <a:pPr algn="ctr">
+                <a:spcAft>
+                  <a:spcPts val="0"/>
+                </a:spcAft>
+                <a:buNone/>
+              </a:pPr>
+              <a:r>
+                <a:rPr lang="en-US" sz="1400" b="1" dirty="0">
+                  <a:solidFill>
+                    <a:srgbClr val="8E6F3E"/>
+                  </a:solidFill>
+                </a:rPr>
+                <a:t>TERRITORY</a:t>
+              </a:r>
+            </a:p>
+          </p:txBody>
+        </p:sp>
+      </p:grpSp>
     </p:spTree>
   </p:cSld>
   <p:clrMapOvr>
@@ -6731,7 +6835,7 @@
         <p:spPr/>
         <p:txBody>
           <a:bodyPr>
-            <a:normAutofit/>
+            <a:normAutofit fontScale="90000"/>
           </a:bodyPr>
           <a:lstStyle/>
           <a:p>
@@ -7225,7 +7329,7 @@
         <p:spPr/>
         <p:txBody>
           <a:bodyPr>
-            <a:normAutofit/>
+            <a:normAutofit fontScale="90000"/>
           </a:bodyPr>
           <a:lstStyle/>
           <a:p>
@@ -8740,7 +8844,7 @@
         <p:spPr/>
         <p:txBody>
           <a:bodyPr>
-            <a:normAutofit/>
+            <a:normAutofit fontScale="90000"/>
           </a:bodyPr>
           <a:lstStyle/>
           <a:p>
@@ -9838,7 +9942,7 @@
         </p:spPr>
         <p:txBody>
           <a:bodyPr>
-            <a:normAutofit/>
+            <a:normAutofit fontScale="90000"/>
           </a:bodyPr>
           <a:lstStyle/>
           <a:p>
@@ -10215,7 +10319,7 @@
         <p:spPr/>
         <p:txBody>
           <a:bodyPr>
-            <a:normAutofit/>
+            <a:normAutofit fontScale="90000"/>
           </a:bodyPr>
           <a:lstStyle/>
           <a:p>
@@ -10587,7 +10691,7 @@
         <p:spPr/>
         <p:txBody>
           <a:bodyPr>
-            <a:normAutofit/>
+            <a:normAutofit fontScale="90000"/>
           </a:bodyPr>
           <a:lstStyle/>
           <a:p>
@@ -11309,7 +11413,7 @@
         <p:spPr/>
         <p:txBody>
           <a:bodyPr>
-            <a:normAutofit/>
+            <a:normAutofit fontScale="90000"/>
           </a:bodyPr>
           <a:lstStyle/>
           <a:p>
@@ -12094,7 +12198,7 @@
         <p:spPr/>
         <p:txBody>
           <a:bodyPr>
-            <a:normAutofit/>
+            <a:normAutofit fontScale="90000"/>
           </a:bodyPr>
           <a:lstStyle/>
           <a:p>
@@ -12952,7 +13056,7 @@
         <p:spPr/>
         <p:txBody>
           <a:bodyPr>
-            <a:normAutofit/>
+            <a:normAutofit fontScale="90000"/>
           </a:bodyPr>
           <a:lstStyle/>
           <a:p>
@@ -13768,7 +13872,7 @@
         <p:spPr/>
         <p:txBody>
           <a:bodyPr>
-            <a:normAutofit/>
+            <a:normAutofit fontScale="90000"/>
           </a:bodyPr>
           <a:lstStyle/>
           <a:p>
@@ -14569,7 +14673,7 @@
         <p:spPr/>
         <p:txBody>
           <a:bodyPr>
-            <a:normAutofit/>
+            <a:normAutofit fontScale="90000"/>
           </a:bodyPr>
           <a:lstStyle/>
           <a:p>
@@ -15615,7 +15719,7 @@
         <p:spPr/>
         <p:txBody>
           <a:bodyPr>
-            <a:normAutofit/>
+            <a:normAutofit fontScale="90000"/>
           </a:bodyPr>
           <a:lstStyle/>
           <a:p>
@@ -16170,7 +16274,7 @@
         <p:spPr/>
         <p:txBody>
           <a:bodyPr>
-            <a:normAutofit/>
+            <a:normAutofit fontScale="90000"/>
           </a:bodyPr>
           <a:lstStyle/>
           <a:p>
@@ -16762,7 +16866,7 @@
         <p:spPr/>
         <p:txBody>
           <a:bodyPr>
-            <a:normAutofit/>
+            <a:normAutofit fontScale="90000"/>
           </a:bodyPr>
           <a:lstStyle/>
           <a:p>
@@ -17522,7 +17626,7 @@
         <p:spPr/>
         <p:txBody>
           <a:bodyPr>
-            <a:normAutofit/>
+            <a:normAutofit fontScale="90000"/>
           </a:bodyPr>
           <a:lstStyle/>
           <a:p>
@@ -18078,7 +18182,7 @@
         <p:spPr/>
         <p:txBody>
           <a:bodyPr>
-            <a:normAutofit/>
+            <a:normAutofit fontScale="90000"/>
           </a:bodyPr>
           <a:lstStyle/>
           <a:p>
@@ -18687,7 +18791,7 @@
         <p:spPr/>
         <p:txBody>
           <a:bodyPr>
-            <a:normAutofit/>
+            <a:normAutofit fontScale="90000"/>
           </a:bodyPr>
           <a:lstStyle/>
           <a:p>
@@ -19252,7 +19356,7 @@
         <p:spPr/>
         <p:txBody>
           <a:bodyPr>
-            <a:normAutofit/>
+            <a:normAutofit fontScale="90000"/>
           </a:bodyPr>
           <a:lstStyle/>
           <a:p>
@@ -20092,7 +20196,7 @@
         <p:spPr/>
         <p:txBody>
           <a:bodyPr>
-            <a:normAutofit/>
+            <a:normAutofit fontScale="90000"/>
           </a:bodyPr>
           <a:lstStyle/>
           <a:p>
@@ -20875,7 +20979,7 @@
         <p:spPr/>
         <p:txBody>
           <a:bodyPr>
-            <a:normAutofit/>
+            <a:normAutofit fontScale="90000"/>
           </a:bodyPr>
           <a:lstStyle/>
           <a:p>
@@ -22540,7 +22644,7 @@
         <p:spPr/>
         <p:txBody>
           <a:bodyPr>
-            <a:normAutofit/>
+            <a:normAutofit fontScale="90000"/>
           </a:bodyPr>
           <a:lstStyle/>
           <a:p>
@@ -23088,7 +23192,7 @@
         <p:spPr/>
         <p:txBody>
           <a:bodyPr>
-            <a:normAutofit/>
+            <a:normAutofit fontScale="90000"/>
           </a:bodyPr>
           <a:lstStyle/>
           <a:p>
@@ -23764,7 +23868,7 @@
         <p:spPr/>
         <p:txBody>
           <a:bodyPr>
-            <a:normAutofit/>
+            <a:normAutofit fontScale="90000"/>
           </a:bodyPr>
           <a:lstStyle/>
           <a:p>
@@ -23972,7 +24076,7 @@
         <p:spPr/>
         <p:txBody>
           <a:bodyPr>
-            <a:normAutofit/>
+            <a:normAutofit fontScale="90000"/>
           </a:bodyPr>
           <a:lstStyle/>
           <a:p>
@@ -25748,7 +25852,7 @@
         <p:spPr/>
         <p:txBody>
           <a:bodyPr>
-            <a:normAutofit/>
+            <a:normAutofit fontScale="90000"/>
           </a:bodyPr>
           <a:lstStyle/>
           <a:p>
@@ -26913,7 +27017,7 @@
         <p:spPr/>
         <p:txBody>
           <a:bodyPr>
-            <a:normAutofit/>
+            <a:normAutofit fontScale="90000"/>
           </a:bodyPr>
           <a:lstStyle/>
           <a:p>
@@ -29338,7 +29442,7 @@
         <p:spPr/>
         <p:txBody>
           <a:bodyPr>
-            <a:normAutofit/>
+            <a:normAutofit fontScale="90000"/>
           </a:bodyPr>
           <a:lstStyle/>
           <a:p>
@@ -30589,7 +30693,7 @@
         <p:spPr/>
         <p:txBody>
           <a:bodyPr>
-            <a:normAutofit/>
+            <a:normAutofit fontScale="90000"/>
           </a:bodyPr>
           <a:lstStyle/>
           <a:p>
@@ -31017,46 +31121,6 @@
           </a:ln>
         </p:spPr>
       </p:cxnSp>
-      <p:sp>
-        <p:nvSpPr>
-          <p:cNvPr id="40" name="Ital"/>
-          <p:cNvSpPr/>
-          <p:nvPr/>
-        </p:nvSpPr>
-        <p:spPr>
-          <a:xfrm>
-            <a:off x="274320" y="4297680"/>
-            <a:ext cx="8595360" cy="365760"/>
-          </a:xfrm>
-          <a:prstGeom prst="rect">
-            <a:avLst/>
-          </a:prstGeom>
-          <a:noFill/>
-          <a:ln>
-            <a:noFill/>
-          </a:ln>
-        </p:spPr>
-        <p:txBody>
-          <a:bodyPr wrap="square" lIns="0" tIns="0" rIns="0" bIns="0" anchor="t"/>
-          <a:lstStyle/>
-          <a:p>
-            <a:pPr algn="ctr">
-              <a:spcAft>
-                <a:spcPts val="0"/>
-              </a:spcAft>
-              <a:buNone/>
-            </a:pPr>
-            <a:r>
-              <a:rPr lang="en-US" sz="1700" b="0" i="1" dirty="0">
-                <a:solidFill>
-                  <a:srgbClr val="555960"/>
-                </a:solidFill>
-              </a:rPr>
-              <a:t>They return at every section break in this unit.</a:t>
-            </a:r>
-          </a:p>
-        </p:txBody>
-      </p:sp>
       <p:sp>
         <p:nvSpPr>
           <p:cNvPr id="199" name="FooterBand"/>

</xml_diff>

<commit_message>
slides(2-2-Modeling-1): fix the living-practice slide's wrapping sub-line
Render QA on s12. The sub-line ran 92 characters at 20pt across a box
sized for one line, wrapped, and the overflow ran underneath the BESSER
screenshot. Replaced with a shorter line that makes the same point more
sharply — the practice is decades older than the agents, so it plainly
was not invented for them.

Also framed the screenshot in a hairline tan border. Its page is white
and so is the slide, so the exhibit had no edge and floated.

Neither the schema validator nor the style sweep can see an overflow like
this, because nothing in the XML declares that a box holds one line. A
measuring check now exists beside the build to catch the class.

Co-Authored-By: Claude Opus 5 <noreply@anthropic.com>
</commit_message>
<xml_diff>
--- a/course/lectures/act-2-delegation-and-control/02-modeling/2-2-Modeling-1-Purposeful-Reduction.pptx
+++ b/course/lectures/act-2-delegation-and-control/02-modeling/2-2-Modeling-1-Purposeful-Reduction.pptx
@@ -21980,7 +21980,7 @@
                   <a:srgbClr val="5C4826"/>
                 </a:solidFill>
               </a:rPr>
-              <a:t>An established engineering practice with living tools — not a vocabulary invented for agents.</a:t>
+              <a:t>An engineering practice with living tools, decades older than the agents.</a:t>
             </a:r>
           </a:p>
         </p:txBody>
@@ -22007,6 +22007,11 @@
           <a:prstGeom prst="rect">
             <a:avLst/>
           </a:prstGeom>
+          <a:ln w="12700">
+            <a:solidFill>
+              <a:srgbClr val="C9B991"/>
+            </a:solidFill>
+          </a:ln>
         </p:spPr>
       </p:pic>
       <p:sp>

</xml_diff>

<commit_message>
2-2-Modeling-1: scrub slide-number references the insert made stale
The transplant shifted every position after 1 by one, so the four remaining
"Deck slide N." note leads and the close slide's "earned at slides 15/17/18
and adjudicated at 23" all went wrong by one. Per U-OV-C's own note, delete
the number rather than renumber it: the leads say nothing the title does not,
and the close's reference becomes a section + title reference that survives
the Cabot insert still to come.

Two independent fresh-eyes reviewers flagged the leads on positions 30 and 31
from the renders; this closes all six sites.

Co-Authored-By: Claude Opus 5 <noreply@anthropic.com>
</commit_message>
<xml_diff>
--- a/course/lectures/act-2-delegation-and-control/02-modeling/2-2-Modeling-1-Purposeful-Reduction.pptx
+++ b/course/lectures/act-2-delegation-and-control/02-modeling/2-2-Modeling-1-Purposeful-Reduction.pptx
@@ -1528,7 +1528,7 @@
           <a:p>
             <a:r>
               <a:rPr dirty="0"/>
-              <a:t>Deck slide 29. A diagram is a representation, not a synonym for a model. The same recovery relation renders as a state diagram, a transition table, or structured text; the property — publication precedes the record — is statable whatever the encoding.</a:t>
+              <a:t>A diagram is a representation, not a synonym for a model. The same recovery relation renders as a state diagram, a transition table, or structured text; the property — publication precedes the record — is statable whatever the encoding.</a:t>
             </a:r>
           </a:p>
           <a:p>
@@ -1581,7 +1581,7 @@
           <a:p>
             <a:r>
               <a:rPr dirty="0"/>
-              <a:t>Deck slide 30. Merged R1.s25+s26 — the probabilistic seed motivates the asymmetry in one move. Seed P(agent correctly interprets c | r) and STOP THERE: no expected loss, no utility, no economics. Two representations of the same intended model differ in how reliably the claim is recovered.</a:t>
+              <a:t>Merged R1.s25+s26 — the probabilistic seed motivates the asymmetry in one move. Seed P(agent correctly interprets c | r) and STOP THERE: no expected loss, no utility, no economics. Two representations of the same intended model differ in how reliably the claim is recovered.</a:t>
             </a:r>
           </a:p>
           <a:p>
@@ -1634,7 +1634,7 @@
           <a:p>
             <a:r>
               <a:rPr dirty="0"/>
-              <a:t>Deck slide 31. ~9 minutes. Makes P(interpret) tangible without estimating a number — do not ask students for a number.</a:t>
+              <a:t>~9 minutes. Makes P(interpret) tangible without estimating a number — do not ask students for a number.</a:t>
             </a:r>
           </a:p>
           <a:p>
@@ -1699,7 +1699,7 @@
           <a:p>
             <a:r>
               <a:rPr dirty="0"/>
-              <a:t>Deck slide 32. ~2 minutes; compresses to 1 if needed. Reprise, not new content — the couplet was earned at slides 15/17/18 and adjudicated at 23. Read the couplet, land the ital line, then the teaser names Deck 2's problem in one sentence and stops.</a:t>
+              <a:t>~2 minutes; compresses to 1 if needed. Reprise, not new content — the couplet was earned in Section 2 — top-down, bottom-up, then the worked controller — and adjudicated on “Capability cannot reduce what must be true”. Read the couplet, land the ital line, then the teaser names Deck 2's problem in one sentence and stops.</a:t>
             </a:r>
           </a:p>
           <a:p>

</xml_diff>

<commit_message>
2-2-Modeling-1: slide 29 was crowding the footer band
Render QA on the new Cabot slide: the last line of both columns sat 0.075 in
above the gold band — tighter than the deck's own precedent and visibly cramped.
Lifted the whole lower band by 0.1 in and took the figure down to 7.10 in wide
(from 7.31 in) to pay for it, which leaves 0.175 in of air under the questions.
The figure still holds the brief's proportions — 58% of canvas height above the
citation, 333 ppi, aspect exact.

Also set the apostrophe in "IN CABOT'S PROCESS" to the typographic form the rest
of the deck uses.

Slide 29 is rebuilt from the same generator, so this commit changes only
slide44.xml. Re-verified: 35 slides; pptx_validate 0 OPC / 0 schema; style sweep
11 FAIL == HEAD baseline (0 new); check_wrap 20 == baseline.

Co-Authored-By: Claude Opus 5 <noreply@anthropic.com>
</commit_message>
<xml_diff>
--- a/course/lectures/act-2-delegation-and-control/02-modeling/2-2-Modeling-1-Purposeful-Reduction.pptx
+++ b/course/lectures/act-2-delegation-and-control/02-modeling/2-2-Modeling-1-Purposeful-Reduction.pptx
@@ -24375,8 +24375,8 @@
         </p:blipFill>
         <p:spPr>
           <a:xfrm>
-            <a:off x="1231776" y="868680"/>
-            <a:ext cx="6680447" cy="3200400"/>
+            <a:off x="1327211" y="868680"/>
+            <a:ext cx="6489577" cy="3108960"/>
           </a:xfrm>
           <a:prstGeom prst="rect">
             <a:avLst/>
@@ -24396,8 +24396,8 @@
         </p:nvSpPr>
         <p:spPr>
           <a:xfrm>
-            <a:off x="1231776" y="4114800"/>
-            <a:ext cx="7637904" cy="251460"/>
+            <a:off x="1327211" y="4023360"/>
+            <a:ext cx="7542469" cy="251460"/>
           </a:xfrm>
           <a:prstGeom prst="rect">
             <a:avLst/>
@@ -24445,7 +24445,7 @@
         </p:nvSpPr>
         <p:spPr>
           <a:xfrm>
-            <a:off x="365760" y="4434840"/>
+            <a:off x="365760" y="4343400"/>
             <a:ext cx="3566160" cy="205740"/>
           </a:xfrm>
           <a:prstGeom prst="rect">
@@ -24485,7 +24485,7 @@
         </p:nvSpPr>
         <p:spPr>
           <a:xfrm>
-            <a:off x="365760" y="4686300"/>
+            <a:off x="365760" y="4594860"/>
             <a:ext cx="3566160" cy="320040"/>
           </a:xfrm>
           <a:prstGeom prst="rect">
@@ -24557,7 +24557,7 @@
         </p:nvSpPr>
         <p:spPr>
           <a:xfrm>
-            <a:off x="365760" y="5326380"/>
+            <a:off x="365760" y="5234940"/>
             <a:ext cx="3566160" cy="457200"/>
           </a:xfrm>
           <a:prstGeom prst="rect">
@@ -24662,7 +24662,7 @@
         </p:nvSpPr>
         <p:spPr>
           <a:xfrm>
-            <a:off x="4114800" y="4434840"/>
+            <a:off x="4114800" y="4343400"/>
             <a:ext cx="3017520" cy="548640"/>
           </a:xfrm>
           <a:prstGeom prst="roundRect">
@@ -24735,7 +24735,7 @@
         </p:nvSpPr>
         <p:spPr>
           <a:xfrm>
-            <a:off x="4114800" y="5074920"/>
+            <a:off x="4114800" y="4983480"/>
             <a:ext cx="4754880" cy="205740"/>
           </a:xfrm>
           <a:prstGeom prst="rect">
@@ -24762,7 +24762,7 @@
                   <a:srgbClr val="8E6F3E"/>
                 </a:solidFill>
               </a:rPr>
-              <a:t xml:space="preserve">IN CABOT'S PROCESS</a:t>
+              <a:t xml:space="preserve">IN CABOT’S PROCESS</a:t>
             </a:r>
           </a:p>
         </p:txBody>
@@ -24775,7 +24775,7 @@
         </p:nvSpPr>
         <p:spPr>
           <a:xfrm>
-            <a:off x="4114800" y="5326380"/>
+            <a:off x="4114800" y="5234940"/>
             <a:ext cx="4754880" cy="457200"/>
           </a:xfrm>
           <a:prstGeom prst="rect">

</xml_diff>

<commit_message>
slides(2-2-Modeling-1): N4 opens on its first question, not an empty body
Position 17 previously animated all four beats, so the slide's opening frame
was a title over blank space. Q1 now shows on arrival; the reveal order is
unchanged (Q1 -> Q2 -> encode/interpret figure + claim -> "And does GenAI
change this?"), three clicks instead of four.

Co-Authored-By: Claude Opus 5 <noreply@anthropic.com>
</commit_message>
<xml_diff>
--- a/course/lectures/act-2-delegation-and-control/02-modeling/2-2-Modeling-1-Purposeful-Reduction.pptx
+++ b/course/lectures/act-2-delegation-and-control/02-modeling/2-2-Modeling-1-Purposeful-Reduction.pptx
@@ -18321,7 +18321,7 @@
                                           </p:stCondLst>
                                         </p:cTn>
                                         <p:tgtEl>
-                                          <p:spTgt spid="100"/>
+                                          <p:spTgt spid="101"/>
                                         </p:tgtEl>
                                         <p:attrNameLst>
                                           <p:attrName>style.visibility</p:attrName>
@@ -18335,7 +18335,7 @@
                                       <p:cBhvr>
                                         <p:cTn id="7" dur="500"/>
                                         <p:tgtEl>
-                                          <p:spTgt spid="100"/>
+                                          <p:spTgt spid="101"/>
                                         </p:tgtEl>
                                       </p:cBhvr>
                                     </p:animEffect>
@@ -18374,7 +18374,7 @@
                                           </p:stCondLst>
                                         </p:cTn>
                                         <p:tgtEl>
-                                          <p:spTgt spid="101"/>
+                                          <p:spTgt spid="130"/>
                                         </p:tgtEl>
                                         <p:attrNameLst>
                                           <p:attrName>style.visibility</p:attrName>
@@ -18388,59 +18388,6 @@
                                       <p:cBhvr>
                                         <p:cTn id="12" dur="500"/>
                                         <p:tgtEl>
-                                          <p:spTgt spid="101"/>
-                                        </p:tgtEl>
-                                      </p:cBhvr>
-                                    </p:animEffect>
-                                  </p:childTnLst>
-                                </p:cTn>
-                              </p:par>
-                            </p:childTnLst>
-                          </p:cTn>
-                        </p:par>
-                      </p:childTnLst>
-                    </p:cTn>
-                  </p:par>
-                  <p:par>
-                    <p:cTn id="13" fill="hold">
-                      <p:stCondLst>
-                        <p:cond delay="indefinite"/>
-                      </p:stCondLst>
-                      <p:childTnLst>
-                        <p:par>
-                          <p:cTn id="14" fill="hold">
-                            <p:stCondLst>
-                              <p:cond delay="0"/>
-                            </p:stCondLst>
-                            <p:childTnLst>
-                              <p:par>
-                                <p:cTn id="15" presetID="10" presetClass="entr" presetSubtype="0" fill="hold" nodeType="clickEffect">
-                                  <p:stCondLst>
-                                    <p:cond delay="0"/>
-                                  </p:stCondLst>
-                                  <p:childTnLst>
-                                    <p:set>
-                                      <p:cBhvr>
-                                        <p:cTn id="16" dur="1" fill="hold">
-                                          <p:stCondLst>
-                                            <p:cond delay="0"/>
-                                          </p:stCondLst>
-                                        </p:cTn>
-                                        <p:tgtEl>
-                                          <p:spTgt spid="130"/>
-                                        </p:tgtEl>
-                                        <p:attrNameLst>
-                                          <p:attrName>style.visibility</p:attrName>
-                                        </p:attrNameLst>
-                                      </p:cBhvr>
-                                      <p:to>
-                                        <p:strVal val="visible"/>
-                                      </p:to>
-                                    </p:set>
-                                    <p:animEffect transition="in" filter="fade">
-                                      <p:cBhvr>
-                                        <p:cTn id="17" dur="500"/>
-                                        <p:tgtEl>
                                           <p:spTgt spid="130"/>
                                         </p:tgtEl>
                                       </p:cBhvr>
@@ -18449,14 +18396,14 @@
                                 </p:cTn>
                               </p:par>
                               <p:par>
-                                <p:cTn id="18" presetID="10" presetClass="entr" presetSubtype="0" fill="hold" nodeType="withEffect">
+                                <p:cTn id="13" presetID="10" presetClass="entr" presetSubtype="0" fill="hold" nodeType="withEffect">
                                   <p:stCondLst>
                                     <p:cond delay="0"/>
                                   </p:stCondLst>
                                   <p:childTnLst>
                                     <p:set>
                                       <p:cBhvr>
-                                        <p:cTn id="19" dur="1" fill="hold">
+                                        <p:cTn id="14" dur="1" fill="hold">
                                           <p:stCondLst>
                                             <p:cond delay="0"/>
                                           </p:stCondLst>
@@ -18474,7 +18421,7 @@
                                     </p:set>
                                     <p:animEffect transition="in" filter="fade">
                                       <p:cBhvr>
-                                        <p:cTn id="20" dur="500"/>
+                                        <p:cTn id="15" dur="500"/>
                                         <p:tgtEl>
                                           <p:spTgt spid="110"/>
                                         </p:tgtEl>
@@ -18484,14 +18431,14 @@
                                 </p:cTn>
                               </p:par>
                               <p:par>
-                                <p:cTn id="21" presetID="10" presetClass="entr" presetSubtype="0" fill="hold" nodeType="withEffect">
+                                <p:cTn id="16" presetID="10" presetClass="entr" presetSubtype="0" fill="hold" nodeType="withEffect">
                                   <p:stCondLst>
                                     <p:cond delay="0"/>
                                   </p:stCondLst>
                                   <p:childTnLst>
                                     <p:set>
                                       <p:cBhvr>
-                                        <p:cTn id="22" dur="1" fill="hold">
+                                        <p:cTn id="17" dur="1" fill="hold">
                                           <p:stCondLst>
                                             <p:cond delay="0"/>
                                           </p:stCondLst>
@@ -18509,7 +18456,7 @@
                                     </p:set>
                                     <p:animEffect transition="in" filter="fade">
                                       <p:cBhvr>
-                                        <p:cTn id="23" dur="500"/>
+                                        <p:cTn id="18" dur="500"/>
                                         <p:tgtEl>
                                           <p:spTgt spid="120"/>
                                         </p:tgtEl>
@@ -18519,14 +18466,14 @@
                                 </p:cTn>
                               </p:par>
                               <p:par>
-                                <p:cTn id="24" presetID="10" presetClass="entr" presetSubtype="0" fill="hold" nodeType="withEffect">
+                                <p:cTn id="19" presetID="10" presetClass="entr" presetSubtype="0" fill="hold" nodeType="withEffect">
                                   <p:stCondLst>
                                     <p:cond delay="0"/>
                                   </p:stCondLst>
                                   <p:childTnLst>
                                     <p:set>
                                       <p:cBhvr>
-                                        <p:cTn id="25" dur="1" fill="hold">
+                                        <p:cTn id="20" dur="1" fill="hold">
                                           <p:stCondLst>
                                             <p:cond delay="0"/>
                                           </p:stCondLst>
@@ -18544,7 +18491,7 @@
                                     </p:set>
                                     <p:animEffect transition="in" filter="fade">
                                       <p:cBhvr>
-                                        <p:cTn id="26" dur="500"/>
+                                        <p:cTn id="21" dur="500"/>
                                         <p:tgtEl>
                                           <p:spTgt spid="111"/>
                                         </p:tgtEl>
@@ -18554,14 +18501,14 @@
                                 </p:cTn>
                               </p:par>
                               <p:par>
-                                <p:cTn id="27" presetID="10" presetClass="entr" presetSubtype="0" fill="hold" nodeType="withEffect">
+                                <p:cTn id="22" presetID="10" presetClass="entr" presetSubtype="0" fill="hold" nodeType="withEffect">
                                   <p:stCondLst>
                                     <p:cond delay="0"/>
                                   </p:stCondLst>
                                   <p:childTnLst>
                                     <p:set>
                                       <p:cBhvr>
-                                        <p:cTn id="28" dur="1" fill="hold">
+                                        <p:cTn id="23" dur="1" fill="hold">
                                           <p:stCondLst>
                                             <p:cond delay="0"/>
                                           </p:stCondLst>
@@ -18579,7 +18526,7 @@
                                     </p:set>
                                     <p:animEffect transition="in" filter="fade">
                                       <p:cBhvr>
-                                        <p:cTn id="29" dur="500"/>
+                                        <p:cTn id="24" dur="500"/>
                                         <p:tgtEl>
                                           <p:spTgt spid="121"/>
                                         </p:tgtEl>
@@ -18589,14 +18536,14 @@
                                 </p:cTn>
                               </p:par>
                               <p:par>
-                                <p:cTn id="30" presetID="10" presetClass="entr" presetSubtype="0" fill="hold" nodeType="withEffect">
+                                <p:cTn id="25" presetID="10" presetClass="entr" presetSubtype="0" fill="hold" nodeType="withEffect">
                                   <p:stCondLst>
                                     <p:cond delay="0"/>
                                   </p:stCondLst>
                                   <p:childTnLst>
                                     <p:set>
                                       <p:cBhvr>
-                                        <p:cTn id="31" dur="1" fill="hold">
+                                        <p:cTn id="26" dur="1" fill="hold">
                                           <p:stCondLst>
                                             <p:cond delay="0"/>
                                           </p:stCondLst>
@@ -18614,7 +18561,7 @@
                                     </p:set>
                                     <p:animEffect transition="in" filter="fade">
                                       <p:cBhvr>
-                                        <p:cTn id="32" dur="500"/>
+                                        <p:cTn id="27" dur="500"/>
                                         <p:tgtEl>
                                           <p:spTgt spid="112"/>
                                         </p:tgtEl>
@@ -18624,14 +18571,14 @@
                                 </p:cTn>
                               </p:par>
                               <p:par>
-                                <p:cTn id="33" presetID="10" presetClass="entr" presetSubtype="0" fill="hold" nodeType="withEffect">
+                                <p:cTn id="28" presetID="10" presetClass="entr" presetSubtype="0" fill="hold" nodeType="withEffect">
                                   <p:stCondLst>
                                     <p:cond delay="0"/>
                                   </p:stCondLst>
                                   <p:childTnLst>
                                     <p:set>
                                       <p:cBhvr>
-                                        <p:cTn id="34" dur="1" fill="hold">
+                                        <p:cTn id="29" dur="1" fill="hold">
                                           <p:stCondLst>
                                             <p:cond delay="0"/>
                                           </p:stCondLst>
@@ -18649,7 +18596,7 @@
                                     </p:set>
                                     <p:animEffect transition="in" filter="fade">
                                       <p:cBhvr>
-                                        <p:cTn id="35" dur="500"/>
+                                        <p:cTn id="30" dur="500"/>
                                         <p:tgtEl>
                                           <p:spTgt spid="131"/>
                                         </p:tgtEl>
@@ -18659,14 +18606,14 @@
                                 </p:cTn>
                               </p:par>
                               <p:par>
-                                <p:cTn id="36" presetID="10" presetClass="entr" presetSubtype="0" fill="hold" nodeType="withEffect">
+                                <p:cTn id="31" presetID="10" presetClass="entr" presetSubtype="0" fill="hold" nodeType="withEffect">
                                   <p:stCondLst>
                                     <p:cond delay="0"/>
                                   </p:stCondLst>
                                   <p:childTnLst>
                                     <p:set>
                                       <p:cBhvr>
-                                        <p:cTn id="37" dur="1" fill="hold">
+                                        <p:cTn id="32" dur="1" fill="hold">
                                           <p:stCondLst>
                                             <p:cond delay="0"/>
                                           </p:stCondLst>
@@ -18684,7 +18631,7 @@
                                     </p:set>
                                     <p:animEffect transition="in" filter="fade">
                                       <p:cBhvr>
-                                        <p:cTn id="38" dur="500"/>
+                                        <p:cTn id="33" dur="500"/>
                                         <p:tgtEl>
                                           <p:spTgt spid="140"/>
                                         </p:tgtEl>
@@ -18700,26 +18647,26 @@
                     </p:cTn>
                   </p:par>
                   <p:par>
-                    <p:cTn id="39" fill="hold">
+                    <p:cTn id="34" fill="hold">
                       <p:stCondLst>
                         <p:cond delay="indefinite"/>
                       </p:stCondLst>
                       <p:childTnLst>
                         <p:par>
-                          <p:cTn id="40" fill="hold">
+                          <p:cTn id="35" fill="hold">
                             <p:stCondLst>
                               <p:cond delay="0"/>
                             </p:stCondLst>
                             <p:childTnLst>
                               <p:par>
-                                <p:cTn id="41" presetID="10" presetClass="entr" presetSubtype="0" fill="hold" nodeType="clickEffect">
+                                <p:cTn id="36" presetID="10" presetClass="entr" presetSubtype="0" fill="hold" nodeType="clickEffect">
                                   <p:stCondLst>
                                     <p:cond delay="0"/>
                                   </p:stCondLst>
                                   <p:childTnLst>
                                     <p:set>
                                       <p:cBhvr>
-                                        <p:cTn id="42" dur="1" fill="hold">
+                                        <p:cTn id="37" dur="1" fill="hold">
                                           <p:stCondLst>
                                             <p:cond delay="0"/>
                                           </p:stCondLst>
@@ -18737,7 +18684,7 @@
                                     </p:set>
                                     <p:animEffect transition="in" filter="fade">
                                       <p:cBhvr>
-                                        <p:cTn id="43" dur="500"/>
+                                        <p:cTn id="38" dur="500"/>
                                         <p:tgtEl>
                                           <p:spTgt spid="150"/>
                                         </p:tgtEl>

</xml_diff>

<commit_message>
slides(2-2-Modeling-1): fold the Section 2 confirmation round
Position 16's handoff now quotes position 17's first question word for word
rather than re-leading it ("if this works", not "if the model admits all
three"). Position 17 gained a fifth staging frame when the claim got its own
click, so the notes gained the matching beat and the final bullet names what
the last click reveals.

Co-Authored-By: Claude Opus 5 <noreply@anthropic.com>
</commit_message>
<xml_diff>
--- a/course/lectures/act-2-delegation-and-control/02-modeling/2-2-Modeling-1-Purposeful-Reduction.pptx
+++ b/course/lectures/act-2-delegation-and-control/02-modeling/2-2-Modeling-1-Purposeful-Reduction.pptx
@@ -1623,7 +1623,7 @@
           <a:p>
             <a:r>
               <a:rPr lang="en-US" dirty="0"/>
-              <a:t>Hand off by asking the next slide’s own first question, in its words: if the model admits all three, why do software engineers draw boxes and arrows for a day, then go code for a week? Do not answer it here.</a:t>
+              <a:t>Hand off by asking the next slide’s own first question, in its words: if this works, why do software engineers draw boxes and arrows for a day, then go code for a week? Do not answer it here.</a:t>
             </a:r>
           </a:p>
         </p:txBody>
@@ -1978,7 +1978,13 @@
           <a:p>
             <a:r>
               <a:rPr lang="en-US" dirty="0"/>
-              <a:t>Last click, then STOP. Do not answer “does GenAI change this?” here. The cost discussion and the coda are the answer, and the question earns its weight by staying open for the next half hour. If a student answers it, thank them and write it on the board unresolved.</a:t>
+              <a:t>Then the claim, on its own click, once the figure has been narrated: delegation requires consequential knowledge to survive encoding and interpretation. Read it, do not gloss it — the next two sections are its consequences.</a:t>
+            </a:r>
+          </a:p>
+          <a:p>
+            <a:r>
+              <a:rPr lang="en-US" dirty="0"/>
+              <a:t>Last click brings the GenAI question, and then you STOP. Do not answer “does GenAI change this?” here. The cost discussion and the coda are the answer, and the question earns its weight by staying open for the next half hour. If a student answers it, thank them and write it on the board unresolved.</a:t>
             </a:r>
           </a:p>
           <a:p>

</xml_diff>

<commit_message>
slides(2-2-Modeling-1): build N6 at position 19 — from requirement to specification
Gives the battery slide its provenance. Three staged cards walk customer
requirement -> top-level specification -> engineering question, then the
controller thumbnail. The footer band locates modeling in the pipeline
students already know: REQUIREMENT -> SPECIFICATION -> [ MODELING ] ->
IMPLEMENTATION.

No controller architecture is taught here; the next slide opens the box.

Co-Authored-By: Claude Opus 5 <noreply@anthropic.com>
</commit_message>
<xml_diff>
--- a/course/lectures/act-2-delegation-and-control/02-modeling/2-2-Modeling-1-Purposeful-Reduction.pptx
+++ b/course/lectures/act-2-delegation-and-control/02-modeling/2-2-Modeling-1-Purposeful-Reduction.pptx
@@ -2043,7 +2043,31 @@
           <a:p>
             <a:r>
               <a:rPr dirty="0"/>
-              <a:t>PLACEHOLDER — skeleton only (U-1′). N6: “From requirement to specification”. Content and speaker notes owed by U-3 per restructure plan v2 §2.</a:t>
+              <a:t>Why this slide exists: the next slide drops the room into a controller and an 8-hour question. Without this, that question has no provenance.</a:t>
+            </a:r>
+          </a:p>
+          <a:p>
+            <a:r>
+              <a:rPr dirty="0"/>
+              <a:t>Read the three cards in order. The first sentence is what a customer says. The second is what engineers must be able to check. Only the third one is ours.</a:t>
+            </a:r>
+          </a:p>
+          <a:p>
+            <a:r>
+              <a:rPr dirty="0"/>
+              <a:t>Say it once: V_min is the minimum safe voltage - the phrase the next two slides use.</a:t>
+            </a:r>
+          </a:p>
+          <a:p>
+            <a:r>
+              <a:rPr dirty="0"/>
+              <a:t>The footer is the point: students already know requirement, specification, implementation. Modeling is not a new stage bolted on - it sits between the specification and the design, and it is how the obligation gets answered before anything is built.</a:t>
+            </a:r>
+          </a:p>
+          <a:p>
+            <a:r>
+              <a:rPr dirty="0"/>
+              <a:t>Do NOT teach this controller's architecture here. One click per card, then move on. 90 seconds.</a:t>
             </a:r>
           </a:p>
         </p:txBody>
@@ -18871,11 +18895,878 @@
           </a:p>
         </p:txBody>
       </p:sp>
+      <p:sp>
+        <p:nvSpPr>
+          <p:cNvPr id="110" name="Kicker"/>
+          <p:cNvSpPr txBox="1"/>
+          <p:nvPr/>
+        </p:nvSpPr>
+        <p:spPr>
+          <a:xfrm>
+            <a:off x="365760" y="1097280"/>
+            <a:ext cx="8412480" cy="393192"/>
+          </a:xfrm>
+          <a:prstGeom prst="rect">
+            <a:avLst/>
+          </a:prstGeom>
+          <a:noFill/>
+          <a:ln>
+            <a:noFill/>
+          </a:ln>
+        </p:spPr>
+        <p:txBody>
+          <a:bodyPr wrap="square" lIns="18288" tIns="18288" rIns="18288" bIns="18288" anchor="t"/>
+          <a:lstStyle/>
+          <a:p>
+            <a:pPr algn="l">
+              <a:spcAft>
+                <a:spcPts val="0"/>
+              </a:spcAft>
+              <a:buNone/>
+            </a:pPr>
+            <a:r>
+              <a:rPr lang="en-US" sz="2000" b="1" i="0" dirty="0">
+                <a:solidFill>
+                  <a:srgbClr val="8E6F3E"/>
+                </a:solidFill>
+              </a:rPr>
+              <a:t>BEFORE THE MODEL</a:t>
+            </a:r>
+          </a:p>
+        </p:txBody>
+      </p:sp>
+      <p:sp>
+        <p:nvSpPr>
+          <p:cNvPr id="111" name="C1"/>
+          <p:cNvSpPr/>
+          <p:nvPr/>
+        </p:nvSpPr>
+        <p:spPr>
+          <a:xfrm>
+            <a:off x="685800" y="1554480"/>
+            <a:ext cx="7772400" cy="777240"/>
+          </a:xfrm>
+          <a:prstGeom prst="rect">
+            <a:avLst/>
+          </a:prstGeom>
+          <a:solidFill>
+            <a:srgbClr val="F5F1E8"/>
+          </a:solidFill>
+          <a:ln w="12700">
+            <a:solidFill>
+              <a:srgbClr val="C9B991"/>
+            </a:solidFill>
+          </a:ln>
+        </p:spPr>
+        <p:txBody>
+          <a:bodyPr wrap="square" lIns="27432" tIns="22860" rIns="27432" bIns="22860" anchor="ctr"/>
+          <a:lstStyle/>
+          <a:p>
+            <a:pPr algn="l">
+              <a:spcAft>
+                <a:spcPts val="300"/>
+              </a:spcAft>
+              <a:buNone/>
+            </a:pPr>
+            <a:r>
+              <a:rPr lang="en-US" sz="1300" b="1" i="0" dirty="0">
+                <a:solidFill>
+                  <a:srgbClr val="8E6F3E"/>
+                </a:solidFill>
+              </a:rPr>
+              <a:t>CUSTOMER REQUIREMENT</a:t>
+            </a:r>
+          </a:p>
+          <a:p>
+            <a:pPr algn="l">
+              <a:spcAft>
+                <a:spcPts val="0"/>
+              </a:spcAft>
+              <a:buNone/>
+            </a:pPr>
+            <a:r>
+              <a:rPr lang="en-US" sz="1600" b="0" i="0" dirty="0">
+                <a:solidFill>
+                  <a:srgbClr val="5C4826"/>
+                </a:solidFill>
+              </a:rPr>
+              <a:t>The controller must operate for a full 8-hour shift without battery replacement.</a:t>
+            </a:r>
+          </a:p>
+        </p:txBody>
+      </p:sp>
+      <p:cxnSp>
+        <p:nvCxnSpPr>
+          <p:cNvPr id="112" name="A1"/>
+          <p:cNvCxnSpPr/>
+          <p:nvPr/>
+        </p:nvCxnSpPr>
+        <p:spPr>
+          <a:xfrm>
+            <a:off x="4572000" y="2331720"/>
+            <a:ext cx="0" cy="228600"/>
+          </a:xfrm>
+          <a:prstGeom prst="straightConnector1">
+            <a:avLst/>
+          </a:prstGeom>
+          <a:ln w="28575">
+            <a:solidFill>
+              <a:srgbClr val="8E6F3E"/>
+            </a:solidFill>
+            <a:tailEnd type="triangle" w="med" len="med"/>
+          </a:ln>
+        </p:spPr>
+      </p:cxnSp>
+      <p:sp>
+        <p:nvSpPr>
+          <p:cNvPr id="113" name="C2"/>
+          <p:cNvSpPr/>
+          <p:nvPr/>
+        </p:nvSpPr>
+        <p:spPr>
+          <a:xfrm>
+            <a:off x="685800" y="2560320"/>
+            <a:ext cx="7772400" cy="822960"/>
+          </a:xfrm>
+          <a:prstGeom prst="rect">
+            <a:avLst/>
+          </a:prstGeom>
+          <a:solidFill>
+            <a:srgbClr val="F5F1E8"/>
+          </a:solidFill>
+          <a:ln w="12700">
+            <a:solidFill>
+              <a:srgbClr val="C9B991"/>
+            </a:solidFill>
+          </a:ln>
+        </p:spPr>
+        <p:txBody>
+          <a:bodyPr wrap="square" lIns="27432" tIns="22860" rIns="27432" bIns="22860" anchor="ctr"/>
+          <a:lstStyle/>
+          <a:p>
+            <a:pPr algn="l">
+              <a:spcAft>
+                <a:spcPts val="300"/>
+              </a:spcAft>
+              <a:buNone/>
+            </a:pPr>
+            <a:r>
+              <a:rPr lang="en-US" sz="1300" b="1" i="0" dirty="0">
+                <a:solidFill>
+                  <a:srgbClr val="8E6F3E"/>
+                </a:solidFill>
+              </a:rPr>
+              <a:t>TOP-LEVEL SPECIFICATION</a:t>
+            </a:r>
+          </a:p>
+          <a:p>
+            <a:pPr algn="l">
+              <a:spcAft>
+                <a:spcPts val="0"/>
+              </a:spcAft>
+              <a:buNone/>
+            </a:pPr>
+            <a:r>
+              <a:rPr lang="en-US" sz="1600" b="0" i="0" dirty="0">
+                <a:solidFill>
+                  <a:srgbClr val="5C4826"/>
+                </a:solidFill>
+              </a:rPr>
+              <a:t>Under the specified operating profile, battery voltage shall remain above V_min for at least 8 hours.</a:t>
+            </a:r>
+          </a:p>
+        </p:txBody>
+      </p:sp>
+      <p:cxnSp>
+        <p:nvCxnSpPr>
+          <p:cNvPr id="114" name="A2"/>
+          <p:cNvCxnSpPr/>
+          <p:nvPr/>
+        </p:nvCxnSpPr>
+        <p:spPr>
+          <a:xfrm>
+            <a:off x="4572000" y="3383280"/>
+            <a:ext cx="0" cy="228600"/>
+          </a:xfrm>
+          <a:prstGeom prst="straightConnector1">
+            <a:avLst/>
+          </a:prstGeom>
+          <a:ln w="28575">
+            <a:solidFill>
+              <a:srgbClr val="8E6F3E"/>
+            </a:solidFill>
+            <a:tailEnd type="triangle" w="med" len="med"/>
+          </a:ln>
+        </p:spPr>
+      </p:cxnSp>
+      <p:sp>
+        <p:nvSpPr>
+          <p:cNvPr id="115" name="C3"/>
+          <p:cNvSpPr/>
+          <p:nvPr/>
+        </p:nvSpPr>
+        <p:spPr>
+          <a:xfrm>
+            <a:off x="685800" y="3611880"/>
+            <a:ext cx="5029200" cy="685800"/>
+          </a:xfrm>
+          <a:prstGeom prst="rect">
+            <a:avLst/>
+          </a:prstGeom>
+          <a:solidFill>
+            <a:srgbClr val="8E6F3E"/>
+          </a:solidFill>
+          <a:ln>
+            <a:noFill/>
+          </a:ln>
+        </p:spPr>
+        <p:txBody>
+          <a:bodyPr wrap="square" lIns="27432" tIns="22860" rIns="27432" bIns="22860" anchor="ctr"/>
+          <a:lstStyle/>
+          <a:p>
+            <a:pPr algn="l">
+              <a:spcAft>
+                <a:spcPts val="300"/>
+              </a:spcAft>
+              <a:buNone/>
+            </a:pPr>
+            <a:r>
+              <a:rPr lang="en-US" sz="1300" b="1" i="0" dirty="0">
+                <a:solidFill>
+                  <a:srgbClr val="F5F1E8"/>
+                </a:solidFill>
+              </a:rPr>
+              <a:t>ENGINEERING QUESTION</a:t>
+            </a:r>
+          </a:p>
+          <a:p>
+            <a:pPr algn="l">
+              <a:spcAft>
+                <a:spcPts val="0"/>
+              </a:spcAft>
+              <a:buNone/>
+            </a:pPr>
+            <a:r>
+              <a:rPr lang="en-US" sz="1800" b="1" i="0" dirty="0">
+                <a:solidFill>
+                  <a:srgbClr val="FFFFFF"/>
+                </a:solidFill>
+              </a:rPr>
+              <a:t>Can this design satisfy the 8-hour obligation?</a:t>
+            </a:r>
+          </a:p>
+        </p:txBody>
+      </p:sp>
+      <p:sp>
+        <p:nvSpPr>
+          <p:cNvPr id="116" name="Ctrl"/>
+          <p:cNvSpPr/>
+          <p:nvPr/>
+        </p:nvSpPr>
+        <p:spPr>
+          <a:xfrm>
+            <a:off x="5943600" y="3726180"/>
+            <a:ext cx="1143000" cy="457200"/>
+          </a:xfrm>
+          <a:prstGeom prst="rect">
+            <a:avLst/>
+          </a:prstGeom>
+          <a:solidFill>
+            <a:srgbClr val="5C4826"/>
+          </a:solidFill>
+          <a:ln>
+            <a:noFill/>
+          </a:ln>
+        </p:spPr>
+        <p:txBody>
+          <a:bodyPr wrap="square" lIns="27432" tIns="22860" rIns="27432" bIns="22860" anchor="ctr"/>
+          <a:lstStyle/>
+          <a:p>
+            <a:pPr algn="ctr">
+              <a:spcAft>
+                <a:spcPts val="0"/>
+              </a:spcAft>
+              <a:buNone/>
+            </a:pPr>
+            <a:r>
+              <a:rPr lang="en-US" sz="1200" b="1" i="0" dirty="0">
+                <a:solidFill>
+                  <a:srgbClr val="FFFFFF"/>
+                </a:solidFill>
+              </a:rPr>
+              <a:t>CONTROLLER</a:t>
+            </a:r>
+          </a:p>
+        </p:txBody>
+      </p:sp>
+      <p:cxnSp>
+        <p:nvCxnSpPr>
+          <p:cNvPr id="117" name="CB"/>
+          <p:cNvCxnSpPr/>
+          <p:nvPr/>
+        </p:nvCxnSpPr>
+        <p:spPr>
+          <a:xfrm>
+            <a:off x="7086600" y="3954780"/>
+            <a:ext cx="228600" cy="0"/>
+          </a:xfrm>
+          <a:prstGeom prst="straightConnector1">
+            <a:avLst/>
+          </a:prstGeom>
+          <a:ln w="19050">
+            <a:solidFill>
+              <a:srgbClr val="C9B991"/>
+            </a:solidFill>
+            <a:tailEnd type="triangle" w="med" len="med"/>
+          </a:ln>
+        </p:spPr>
+      </p:cxnSp>
+      <p:sp>
+        <p:nvSpPr>
+          <p:cNvPr id="118" name="Bat"/>
+          <p:cNvSpPr/>
+          <p:nvPr/>
+        </p:nvSpPr>
+        <p:spPr>
+          <a:xfrm>
+            <a:off x="7315200" y="3726180"/>
+            <a:ext cx="1143000" cy="457200"/>
+          </a:xfrm>
+          <a:prstGeom prst="rect">
+            <a:avLst/>
+          </a:prstGeom>
+          <a:solidFill>
+            <a:srgbClr val="F5F1E8"/>
+          </a:solidFill>
+          <a:ln w="12700">
+            <a:solidFill>
+              <a:srgbClr val="C9B991"/>
+            </a:solidFill>
+          </a:ln>
+        </p:spPr>
+        <p:txBody>
+          <a:bodyPr wrap="square" lIns="27432" tIns="22860" rIns="27432" bIns="22860" anchor="ctr"/>
+          <a:lstStyle/>
+          <a:p>
+            <a:pPr algn="ctr">
+              <a:spcAft>
+                <a:spcPts val="0"/>
+              </a:spcAft>
+              <a:buNone/>
+            </a:pPr>
+            <a:r>
+              <a:rPr lang="en-US" sz="1200" b="1" i="0" dirty="0">
+                <a:solidFill>
+                  <a:srgbClr val="5C4826"/>
+                </a:solidFill>
+              </a:rPr>
+              <a:t>BATTERY</a:t>
+            </a:r>
+          </a:p>
+        </p:txBody>
+      </p:sp>
+      <p:sp>
+        <p:nvSpPr>
+          <p:cNvPr id="119" name="Ital"/>
+          <p:cNvSpPr txBox="1"/>
+          <p:nvPr/>
+        </p:nvSpPr>
+        <p:spPr>
+          <a:xfrm>
+            <a:off x="685800" y="4663440"/>
+            <a:ext cx="7772400" cy="594360"/>
+          </a:xfrm>
+          <a:prstGeom prst="rect">
+            <a:avLst/>
+          </a:prstGeom>
+          <a:noFill/>
+          <a:ln>
+            <a:noFill/>
+          </a:ln>
+        </p:spPr>
+        <p:txBody>
+          <a:bodyPr wrap="square" lIns="0" tIns="0" rIns="0" bIns="0" anchor="t"/>
+          <a:lstStyle/>
+          <a:p>
+            <a:pPr algn="ctr">
+              <a:spcAft>
+                <a:spcPts val="0"/>
+              </a:spcAft>
+              <a:buNone/>
+            </a:pPr>
+            <a:r>
+              <a:rPr lang="en-US" sz="1500" b="0" i="1" dirty="0">
+                <a:solidFill>
+                  <a:srgbClr val="555960"/>
+                </a:solidFill>
+              </a:rPr>
+              <a:t>The specification states the obligation. A model is how we find out whether the design meets it.</a:t>
+            </a:r>
+          </a:p>
+        </p:txBody>
+      </p:sp>
+      <p:sp>
+        <p:nvSpPr>
+          <p:cNvPr id="120" name="FooterBand"/>
+          <p:cNvSpPr/>
+          <p:nvPr/>
+        </p:nvSpPr>
+        <p:spPr>
+          <a:xfrm>
+            <a:off x="274320" y="5852160"/>
+            <a:ext cx="8595360" cy="566928"/>
+          </a:xfrm>
+          <a:prstGeom prst="rect">
+            <a:avLst/>
+          </a:prstGeom>
+          <a:solidFill>
+            <a:srgbClr val="8E6F3E"/>
+          </a:solidFill>
+          <a:ln>
+            <a:noFill/>
+          </a:ln>
+        </p:spPr>
+        <p:txBody>
+          <a:bodyPr wrap="square" lIns="27432" tIns="22860" rIns="27432" bIns="22860" anchor="ctr"/>
+          <a:lstStyle/>
+          <a:p>
+            <a:pPr algn="ctr">
+              <a:spcAft>
+                <a:spcPts val="0"/>
+              </a:spcAft>
+              <a:buNone/>
+            </a:pPr>
+            <a:r>
+              <a:rPr lang="en-US" sz="1600" b="1" i="0" dirty="0">
+                <a:solidFill>
+                  <a:srgbClr val="FFFFFF"/>
+                </a:solidFill>
+              </a:rPr>
+              <a:t>REQUIREMENT  →  SPECIFICATION  →  [ </a:t>
+            </a:r>
+            <a:r>
+              <a:rPr lang="en-US" sz="2000" b="1" i="0" dirty="0">
+                <a:solidFill>
+                  <a:srgbClr val="FFFFFF"/>
+                </a:solidFill>
+              </a:rPr>
+              <a:t>MODELING</a:t>
+            </a:r>
+            <a:r>
+              <a:rPr lang="en-US" sz="1600" b="1" i="0" dirty="0">
+                <a:solidFill>
+                  <a:srgbClr val="FFFFFF"/>
+                </a:solidFill>
+              </a:rPr>
+              <a:t> ]  →  IMPLEMENTATION</a:t>
+            </a:r>
+          </a:p>
+        </p:txBody>
+      </p:sp>
     </p:spTree>
   </p:cSld>
   <p:clrMapOvr>
     <a:masterClrMapping/>
   </p:clrMapOvr>
+  <p:timing>
+    <p:tnLst>
+      <p:par>
+        <p:cTn id="1" dur="indefinite" restart="never" nodeType="tmRoot">
+          <p:childTnLst>
+            <p:seq concurrent="1" nextAc="seek">
+              <p:cTn id="2" dur="indefinite" nodeType="mainSeq">
+                <p:childTnLst>
+                  <p:par>
+                    <p:cTn id="3" fill="hold">
+                      <p:stCondLst>
+                        <p:cond delay="indefinite"/>
+                      </p:stCondLst>
+                      <p:childTnLst>
+                        <p:par>
+                          <p:cTn id="4" fill="hold">
+                            <p:stCondLst>
+                              <p:cond delay="0"/>
+                            </p:stCondLst>
+                            <p:childTnLst>
+                              <p:par>
+                                <p:cTn id="5" presetID="10" presetClass="entr" presetSubtype="0" fill="hold" nodeType="clickEffect">
+                                  <p:stCondLst>
+                                    <p:cond delay="0"/>
+                                  </p:stCondLst>
+                                  <p:childTnLst>
+                                    <p:set>
+                                      <p:cBhvr>
+                                        <p:cTn id="6" dur="1" fill="hold">
+                                          <p:stCondLst>
+                                            <p:cond delay="0"/>
+                                          </p:stCondLst>
+                                        </p:cTn>
+                                        <p:tgtEl>
+                                          <p:spTgt spid="112"/>
+                                        </p:tgtEl>
+                                        <p:attrNameLst>
+                                          <p:attrName>style.visibility</p:attrName>
+                                        </p:attrNameLst>
+                                      </p:cBhvr>
+                                      <p:to>
+                                        <p:strVal val="visible"/>
+                                      </p:to>
+                                    </p:set>
+                                    <p:animEffect transition="in" filter="fade">
+                                      <p:cBhvr>
+                                        <p:cTn id="7" dur="500"/>
+                                        <p:tgtEl>
+                                          <p:spTgt spid="112"/>
+                                        </p:tgtEl>
+                                      </p:cBhvr>
+                                    </p:animEffect>
+                                  </p:childTnLst>
+                                </p:cTn>
+                              </p:par>
+                              <p:par>
+                                <p:cTn id="8" presetID="10" presetClass="entr" presetSubtype="0" fill="hold" nodeType="withEffect">
+                                  <p:stCondLst>
+                                    <p:cond delay="0"/>
+                                  </p:stCondLst>
+                                  <p:childTnLst>
+                                    <p:set>
+                                      <p:cBhvr>
+                                        <p:cTn id="9" dur="1" fill="hold">
+                                          <p:stCondLst>
+                                            <p:cond delay="0"/>
+                                          </p:stCondLst>
+                                        </p:cTn>
+                                        <p:tgtEl>
+                                          <p:spTgt spid="113"/>
+                                        </p:tgtEl>
+                                        <p:attrNameLst>
+                                          <p:attrName>style.visibility</p:attrName>
+                                        </p:attrNameLst>
+                                      </p:cBhvr>
+                                      <p:to>
+                                        <p:strVal val="visible"/>
+                                      </p:to>
+                                    </p:set>
+                                    <p:animEffect transition="in" filter="fade">
+                                      <p:cBhvr>
+                                        <p:cTn id="10" dur="500"/>
+                                        <p:tgtEl>
+                                          <p:spTgt spid="113"/>
+                                        </p:tgtEl>
+                                      </p:cBhvr>
+                                    </p:animEffect>
+                                  </p:childTnLst>
+                                </p:cTn>
+                              </p:par>
+                            </p:childTnLst>
+                          </p:cTn>
+                        </p:par>
+                      </p:childTnLst>
+                    </p:cTn>
+                  </p:par>
+                  <p:par>
+                    <p:cTn id="11" fill="hold">
+                      <p:stCondLst>
+                        <p:cond delay="indefinite"/>
+                      </p:stCondLst>
+                      <p:childTnLst>
+                        <p:par>
+                          <p:cTn id="12" fill="hold">
+                            <p:stCondLst>
+                              <p:cond delay="0"/>
+                            </p:stCondLst>
+                            <p:childTnLst>
+                              <p:par>
+                                <p:cTn id="13" presetID="10" presetClass="entr" presetSubtype="0" fill="hold" nodeType="clickEffect">
+                                  <p:stCondLst>
+                                    <p:cond delay="0"/>
+                                  </p:stCondLst>
+                                  <p:childTnLst>
+                                    <p:set>
+                                      <p:cBhvr>
+                                        <p:cTn id="14" dur="1" fill="hold">
+                                          <p:stCondLst>
+                                            <p:cond delay="0"/>
+                                          </p:stCondLst>
+                                        </p:cTn>
+                                        <p:tgtEl>
+                                          <p:spTgt spid="114"/>
+                                        </p:tgtEl>
+                                        <p:attrNameLst>
+                                          <p:attrName>style.visibility</p:attrName>
+                                        </p:attrNameLst>
+                                      </p:cBhvr>
+                                      <p:to>
+                                        <p:strVal val="visible"/>
+                                      </p:to>
+                                    </p:set>
+                                    <p:animEffect transition="in" filter="fade">
+                                      <p:cBhvr>
+                                        <p:cTn id="15" dur="500"/>
+                                        <p:tgtEl>
+                                          <p:spTgt spid="114"/>
+                                        </p:tgtEl>
+                                      </p:cBhvr>
+                                    </p:animEffect>
+                                  </p:childTnLst>
+                                </p:cTn>
+                              </p:par>
+                              <p:par>
+                                <p:cTn id="16" presetID="10" presetClass="entr" presetSubtype="0" fill="hold" nodeType="withEffect">
+                                  <p:stCondLst>
+                                    <p:cond delay="0"/>
+                                  </p:stCondLst>
+                                  <p:childTnLst>
+                                    <p:set>
+                                      <p:cBhvr>
+                                        <p:cTn id="17" dur="1" fill="hold">
+                                          <p:stCondLst>
+                                            <p:cond delay="0"/>
+                                          </p:stCondLst>
+                                        </p:cTn>
+                                        <p:tgtEl>
+                                          <p:spTgt spid="115"/>
+                                        </p:tgtEl>
+                                        <p:attrNameLst>
+                                          <p:attrName>style.visibility</p:attrName>
+                                        </p:attrNameLst>
+                                      </p:cBhvr>
+                                      <p:to>
+                                        <p:strVal val="visible"/>
+                                      </p:to>
+                                    </p:set>
+                                    <p:animEffect transition="in" filter="fade">
+                                      <p:cBhvr>
+                                        <p:cTn id="18" dur="500"/>
+                                        <p:tgtEl>
+                                          <p:spTgt spid="115"/>
+                                        </p:tgtEl>
+                                      </p:cBhvr>
+                                    </p:animEffect>
+                                  </p:childTnLst>
+                                </p:cTn>
+                              </p:par>
+                              <p:par>
+                                <p:cTn id="19" presetID="10" presetClass="entr" presetSubtype="0" fill="hold" nodeType="withEffect">
+                                  <p:stCondLst>
+                                    <p:cond delay="0"/>
+                                  </p:stCondLst>
+                                  <p:childTnLst>
+                                    <p:set>
+                                      <p:cBhvr>
+                                        <p:cTn id="20" dur="1" fill="hold">
+                                          <p:stCondLst>
+                                            <p:cond delay="0"/>
+                                          </p:stCondLst>
+                                        </p:cTn>
+                                        <p:tgtEl>
+                                          <p:spTgt spid="116"/>
+                                        </p:tgtEl>
+                                        <p:attrNameLst>
+                                          <p:attrName>style.visibility</p:attrName>
+                                        </p:attrNameLst>
+                                      </p:cBhvr>
+                                      <p:to>
+                                        <p:strVal val="visible"/>
+                                      </p:to>
+                                    </p:set>
+                                    <p:animEffect transition="in" filter="fade">
+                                      <p:cBhvr>
+                                        <p:cTn id="21" dur="500"/>
+                                        <p:tgtEl>
+                                          <p:spTgt spid="116"/>
+                                        </p:tgtEl>
+                                      </p:cBhvr>
+                                    </p:animEffect>
+                                  </p:childTnLst>
+                                </p:cTn>
+                              </p:par>
+                              <p:par>
+                                <p:cTn id="22" presetID="10" presetClass="entr" presetSubtype="0" fill="hold" nodeType="withEffect">
+                                  <p:stCondLst>
+                                    <p:cond delay="0"/>
+                                  </p:stCondLst>
+                                  <p:childTnLst>
+                                    <p:set>
+                                      <p:cBhvr>
+                                        <p:cTn id="23" dur="1" fill="hold">
+                                          <p:stCondLst>
+                                            <p:cond delay="0"/>
+                                          </p:stCondLst>
+                                        </p:cTn>
+                                        <p:tgtEl>
+                                          <p:spTgt spid="117"/>
+                                        </p:tgtEl>
+                                        <p:attrNameLst>
+                                          <p:attrName>style.visibility</p:attrName>
+                                        </p:attrNameLst>
+                                      </p:cBhvr>
+                                      <p:to>
+                                        <p:strVal val="visible"/>
+                                      </p:to>
+                                    </p:set>
+                                    <p:animEffect transition="in" filter="fade">
+                                      <p:cBhvr>
+                                        <p:cTn id="24" dur="500"/>
+                                        <p:tgtEl>
+                                          <p:spTgt spid="117"/>
+                                        </p:tgtEl>
+                                      </p:cBhvr>
+                                    </p:animEffect>
+                                  </p:childTnLst>
+                                </p:cTn>
+                              </p:par>
+                              <p:par>
+                                <p:cTn id="25" presetID="10" presetClass="entr" presetSubtype="0" fill="hold" nodeType="withEffect">
+                                  <p:stCondLst>
+                                    <p:cond delay="0"/>
+                                  </p:stCondLst>
+                                  <p:childTnLst>
+                                    <p:set>
+                                      <p:cBhvr>
+                                        <p:cTn id="26" dur="1" fill="hold">
+                                          <p:stCondLst>
+                                            <p:cond delay="0"/>
+                                          </p:stCondLst>
+                                        </p:cTn>
+                                        <p:tgtEl>
+                                          <p:spTgt spid="118"/>
+                                        </p:tgtEl>
+                                        <p:attrNameLst>
+                                          <p:attrName>style.visibility</p:attrName>
+                                        </p:attrNameLst>
+                                      </p:cBhvr>
+                                      <p:to>
+                                        <p:strVal val="visible"/>
+                                      </p:to>
+                                    </p:set>
+                                    <p:animEffect transition="in" filter="fade">
+                                      <p:cBhvr>
+                                        <p:cTn id="27" dur="500"/>
+                                        <p:tgtEl>
+                                          <p:spTgt spid="118"/>
+                                        </p:tgtEl>
+                                      </p:cBhvr>
+                                    </p:animEffect>
+                                  </p:childTnLst>
+                                </p:cTn>
+                              </p:par>
+                            </p:childTnLst>
+                          </p:cTn>
+                        </p:par>
+                      </p:childTnLst>
+                    </p:cTn>
+                  </p:par>
+                  <p:par>
+                    <p:cTn id="28" fill="hold">
+                      <p:stCondLst>
+                        <p:cond delay="indefinite"/>
+                      </p:stCondLst>
+                      <p:childTnLst>
+                        <p:par>
+                          <p:cTn id="29" fill="hold">
+                            <p:stCondLst>
+                              <p:cond delay="0"/>
+                            </p:stCondLst>
+                            <p:childTnLst>
+                              <p:par>
+                                <p:cTn id="30" presetID="10" presetClass="entr" presetSubtype="0" fill="hold" nodeType="clickEffect">
+                                  <p:stCondLst>
+                                    <p:cond delay="0"/>
+                                  </p:stCondLst>
+                                  <p:childTnLst>
+                                    <p:set>
+                                      <p:cBhvr>
+                                        <p:cTn id="31" dur="1" fill="hold">
+                                          <p:stCondLst>
+                                            <p:cond delay="0"/>
+                                          </p:stCondLst>
+                                        </p:cTn>
+                                        <p:tgtEl>
+                                          <p:spTgt spid="119"/>
+                                        </p:tgtEl>
+                                        <p:attrNameLst>
+                                          <p:attrName>style.visibility</p:attrName>
+                                        </p:attrNameLst>
+                                      </p:cBhvr>
+                                      <p:to>
+                                        <p:strVal val="visible"/>
+                                      </p:to>
+                                    </p:set>
+                                    <p:animEffect transition="in" filter="fade">
+                                      <p:cBhvr>
+                                        <p:cTn id="32" dur="500"/>
+                                        <p:tgtEl>
+                                          <p:spTgt spid="119"/>
+                                        </p:tgtEl>
+                                      </p:cBhvr>
+                                    </p:animEffect>
+                                  </p:childTnLst>
+                                </p:cTn>
+                              </p:par>
+                              <p:par>
+                                <p:cTn id="33" presetID="10" presetClass="entr" presetSubtype="0" fill="hold" nodeType="withEffect">
+                                  <p:stCondLst>
+                                    <p:cond delay="0"/>
+                                  </p:stCondLst>
+                                  <p:childTnLst>
+                                    <p:set>
+                                      <p:cBhvr>
+                                        <p:cTn id="34" dur="1" fill="hold">
+                                          <p:stCondLst>
+                                            <p:cond delay="0"/>
+                                          </p:stCondLst>
+                                        </p:cTn>
+                                        <p:tgtEl>
+                                          <p:spTgt spid="120"/>
+                                        </p:tgtEl>
+                                        <p:attrNameLst>
+                                          <p:attrName>style.visibility</p:attrName>
+                                        </p:attrNameLst>
+                                      </p:cBhvr>
+                                      <p:to>
+                                        <p:strVal val="visible"/>
+                                      </p:to>
+                                    </p:set>
+                                    <p:animEffect transition="in" filter="fade">
+                                      <p:cBhvr>
+                                        <p:cTn id="35" dur="500"/>
+                                        <p:tgtEl>
+                                          <p:spTgt spid="120"/>
+                                        </p:tgtEl>
+                                      </p:cBhvr>
+                                    </p:animEffect>
+                                  </p:childTnLst>
+                                </p:cTn>
+                              </p:par>
+                            </p:childTnLst>
+                          </p:cTn>
+                        </p:par>
+                      </p:childTnLst>
+                    </p:cTn>
+                  </p:par>
+                </p:childTnLst>
+              </p:cTn>
+              <p:prevCondLst>
+                <p:cond evt="onPrev" delay="0">
+                  <p:tgtEl>
+                    <p:sldTgt/>
+                  </p:tgtEl>
+                </p:cond>
+              </p:prevCondLst>
+              <p:nextCondLst>
+                <p:cond evt="onNext" delay="0">
+                  <p:tgtEl>
+                    <p:sldTgt/>
+                  </p:tgtEl>
+                </p:cond>
+              </p:nextCondLst>
+            </p:seq>
+          </p:childTnLst>
+        </p:cTn>
+      </p:par>
+    </p:tnLst>
+  </p:timing>
 </p:sld>
 </file>
 

</xml_diff>

<commit_message>
slides(2-2-Modeling-1): re-kick position 20 to follow 19
"THE METHOD, WORKED" promised a method the lecture has not taught yet and
opened the slide cold. It now reads "THE DESIGN, BEFORE ANY MODEL" — which
picks up 19's closing question ("Can this design satisfy the 8-hour
obligation?") and states the territory-before-model discipline its own notes
already carry. Slide body unchanged.

Notes: hand off from 19 rather than re-posing the question; the stale
verbatim-question note, which no longer matched 19's wording, is replaced by
one explaining the footer's informal restatement.

Co-Authored-By: Claude Opus 5 <noreply@anthropic.com>
</commit_message>
<xml_diff>
--- a/course/lectures/act-2-delegation-and-control/02-modeling/2-2-Modeling-1-Purposeful-Reduction.pptx
+++ b/course/lectures/act-2-delegation-and-control/02-modeling/2-2-Modeling-1-Purposeful-Reduction.pptx
@@ -975,6 +975,12 @@
           <a:p>
             <a:r>
               <a:rPr dirty="0"/>
+              <a:t>The previous slide posed the question. This slide answers 'of what?' - here is the design the 8-hour obligation is about.</a:t>
+            </a:r>
+          </a:p>
+          <a:p>
+            <a:r>
+              <a:rPr dirty="0"/>
               <a:t>Territory an ECE student grasps in thirty seconds - that is why it, and not a software system, carries the method.</a:t>
             </a:r>
           </a:p>
@@ -987,7 +993,7 @@
           <a:p>
             <a:r>
               <a:rPr dirty="0"/>
-              <a:t>Exactly one engineering question (verbatim): can the controller exhaust the battery before completing an 8-hour operating period?</a:t>
+              <a:t>The footer restates the specification in the room's own words: can the battery run out before the 8 hours end? Same obligation, informal register.</a:t>
             </a:r>
           </a:p>
         </p:txBody>
@@ -9156,7 +9162,7 @@
                   <a:srgbClr val="8E6F3E"/>
                 </a:solidFill>
               </a:rPr>
-              <a:t>THE METHOD, WORKED</a:t>
+              <a:t>THE DESIGN, BEFORE ANY MODEL</a:t>
             </a:r>
           </a:p>
         </p:txBody>

</xml_diff>

<commit_message>
slides(2-2-Modeling-1): redesign position 21 to show the reasoning
The slide stated the top-down pattern propositionally — three boxes and a
caption. It now performs it. Left ~65%: a four-row vertical flow,
ENGINEERING OBLIGATION -> REQUIRED DISTINCTIONS -> MODEL -> LEGITIMATE
FREEDOM (the MODEL row is new). Right ~30%: a rail carrying one example all
the way down — the battery, whose context position 19 now supplies —
"≥ 8 h above V_min" / "operating mode · power · duration · usable energy" /
"Σ P(m)·t(m) ≤ E_usable" / "packet format · task names · PWM internals ·
display contents".

Staged four clicks, pattern and instance together on each, so the derivation
is walked rather than displayed. The italic "Degrees of freedom are known
freedom, not ignorance." and the footer band are kept verbatim.

No bottom-up twin is built here; the coda replaces that framing.

Co-Authored-By: Claude Opus 5 <noreply@anthropic.com>
</commit_message>
<xml_diff>
--- a/course/lectures/act-2-delegation-and-control/02-modeling/2-2-Modeling-1-Purposeful-Reduction.pptx
+++ b/course/lectures/act-2-delegation-and-control/02-modeling/2-2-Modeling-1-Purposeful-Reduction.pptx
@@ -916,7 +916,19 @@
           <a:p>
             <a:r>
               <a:rPr dirty="0"/>
+              <a:t>This slide teaches the general pattern; the next one instantiates it. Walk the left column and the right rail together, one click at a time - the pattern, then its instance.</a:t>
+            </a:r>
+          </a:p>
+          <a:p>
+            <a:r>
+              <a:rPr dirty="0"/>
               <a:t>Question to ask of every model: what must this model preserve?</a:t>
+            </a:r>
+          </a:p>
+          <a:p>
+            <a:r>
+              <a:rPr dirty="0"/>
+              <a:t>The MODEL row is the one to dwell on: the obligation picks the distinctions, and the distinctions decide what the model has to say. Nothing is in the model because it happened to be available. The rail compresses the property to fit the column; the next slide writes it out in full.</a:t>
             </a:r>
           </a:p>
           <a:p>
@@ -8755,14 +8767,129 @@
       </p:sp>
       <p:sp>
         <p:nvSpPr>
-          <p:cNvPr id="101" name="B0"/>
+          <p:cNvPr id="100" name="HeadL"/>
+          <p:cNvSpPr txBox="1"/>
+          <p:nvPr/>
+        </p:nvSpPr>
+        <p:spPr>
+          <a:xfrm>
+            <a:off x="685800" y="1188720"/>
+            <a:ext cx="4983480" cy="251460"/>
+          </a:xfrm>
+          <a:prstGeom prst="rect">
+            <a:avLst/>
+          </a:prstGeom>
+          <a:noFill/>
+          <a:ln>
+            <a:noFill/>
+          </a:ln>
+        </p:spPr>
+        <p:txBody>
+          <a:bodyPr wrap="square" lIns="0" tIns="0" rIns="0" bIns="0" anchor="t"/>
+          <a:lstStyle/>
+          <a:p>
+            <a:pPr algn="l">
+              <a:spcAft>
+                <a:spcPts val="0"/>
+              </a:spcAft>
+              <a:buNone/>
+            </a:pPr>
+            <a:r>
+              <a:rPr lang="en-US" sz="1300" b="1" i="0" dirty="0">
+                <a:solidFill>
+                  <a:srgbClr val="8E6F3E"/>
+                </a:solidFill>
+              </a:rPr>
+              <a:t>THE PATTERN</a:t>
+            </a:r>
+          </a:p>
+        </p:txBody>
+      </p:sp>
+      <p:sp>
+        <p:nvSpPr>
+          <p:cNvPr id="101" name="HeadR"/>
+          <p:cNvSpPr txBox="1"/>
+          <p:nvPr/>
+        </p:nvSpPr>
+        <p:spPr>
+          <a:xfrm>
+            <a:off x="5852160" y="1188720"/>
+            <a:ext cx="2606040" cy="251460"/>
+          </a:xfrm>
+          <a:prstGeom prst="rect">
+            <a:avLst/>
+          </a:prstGeom>
+          <a:noFill/>
+          <a:ln>
+            <a:noFill/>
+          </a:ln>
+        </p:spPr>
+        <p:txBody>
+          <a:bodyPr wrap="square" lIns="0" tIns="0" rIns="0" bIns="0" anchor="t"/>
+          <a:lstStyle/>
+          <a:p>
+            <a:pPr algn="l">
+              <a:spcAft>
+                <a:spcPts val="0"/>
+              </a:spcAft>
+              <a:buNone/>
+            </a:pPr>
+            <a:r>
+              <a:rPr lang="en-US" sz="1300" b="1" i="0" dirty="0">
+                <a:solidFill>
+                  <a:srgbClr val="8E6F3E"/>
+                </a:solidFill>
+              </a:rPr>
+              <a:t>THE BATTERY</a:t>
+            </a:r>
+          </a:p>
+        </p:txBody>
+      </p:sp>
+      <p:sp>
+        <p:nvSpPr>
+          <p:cNvPr id="105" name="Rail"/>
           <p:cNvSpPr/>
           <p:nvPr/>
         </p:nvSpPr>
         <p:spPr>
           <a:xfrm>
-            <a:off x="914400" y="1143000"/>
-            <a:ext cx="7315200" cy="822960"/>
+            <a:off x="5749290" y="1188720"/>
+            <a:ext cx="22860" cy="3726180"/>
+          </a:xfrm>
+          <a:prstGeom prst="rect">
+            <a:avLst/>
+          </a:prstGeom>
+          <a:solidFill>
+            <a:srgbClr val="C9B991"/>
+          </a:solidFill>
+          <a:ln>
+            <a:noFill/>
+          </a:ln>
+        </p:spPr>
+        <p:txBody>
+          <a:bodyPr wrap="square" lIns="27432" tIns="22860" rIns="27432" bIns="22860" anchor="ctr"/>
+          <a:lstStyle/>
+          <a:p>
+            <a:pPr algn="l">
+              <a:spcAft>
+                <a:spcPts val="0"/>
+              </a:spcAft>
+              <a:buNone/>
+            </a:pPr>
+            <a:endParaRPr lang="en-US"/>
+          </a:p>
+        </p:txBody>
+      </p:sp>
+      <p:sp>
+        <p:nvSpPr>
+          <p:cNvPr id="110" name="B110"/>
+          <p:cNvSpPr/>
+          <p:nvPr/>
+        </p:nvSpPr>
+        <p:spPr>
+          <a:xfrm>
+            <a:off x="685800" y="1508760"/>
+            <a:ext cx="4983480" cy="731520"/>
           </a:xfrm>
           <a:prstGeom prst="rect">
             <a:avLst/>
@@ -8780,12 +8907,12 @@
           <a:p>
             <a:pPr algn="ctr">
               <a:spcAft>
-                <a:spcPts val="400"/>
+                <a:spcPts val="300"/>
               </a:spcAft>
               <a:buNone/>
             </a:pPr>
             <a:r>
-              <a:rPr lang="en-US" sz="2000" b="1" dirty="0">
+              <a:rPr lang="en-US" sz="1800" b="1" i="0" dirty="0">
                 <a:solidFill>
                   <a:srgbClr val="FFFFFF"/>
                 </a:solidFill>
@@ -8801,26 +8928,376 @@
               <a:buNone/>
             </a:pPr>
             <a:r>
-              <a:rPr lang="en-US" sz="1600" b="0" dirty="0">
+              <a:rPr lang="en-US" sz="1300" b="0" i="0" dirty="0">
                 <a:solidFill>
                   <a:srgbClr val="FFFFFF"/>
                 </a:solidFill>
               </a:rPr>
               <a:t>what the system must guarantee</a:t>
+            </a:r>
+          </a:p>
+        </p:txBody>
+      </p:sp>
+      <p:sp>
+        <p:nvSpPr>
+          <p:cNvPr id="111" name="R111"/>
+          <p:cNvSpPr/>
+          <p:nvPr/>
+        </p:nvSpPr>
+        <p:spPr>
+          <a:xfrm>
+            <a:off x="5852160" y="1508760"/>
+            <a:ext cx="2606040" cy="731520"/>
+          </a:xfrm>
+          <a:prstGeom prst="rect">
+            <a:avLst/>
+          </a:prstGeom>
+          <a:solidFill>
+            <a:srgbClr val="FBF8F2"/>
+          </a:solidFill>
+          <a:ln w="12700">
+            <a:solidFill>
+              <a:srgbClr val="C9B991"/>
+            </a:solidFill>
+          </a:ln>
+        </p:spPr>
+        <p:txBody>
+          <a:bodyPr wrap="square" lIns="27432" tIns="22860" rIns="27432" bIns="22860" anchor="ctr"/>
+          <a:lstStyle/>
+          <a:p>
+            <a:pPr algn="ctr">
+              <a:spcAft>
+                <a:spcPts val="0"/>
+              </a:spcAft>
+              <a:buNone/>
+            </a:pPr>
+            <a:r>
+              <a:rPr lang="en-US" sz="1400" b="1" i="0" dirty="0">
+                <a:solidFill>
+                  <a:srgbClr val="5C4826"/>
+                </a:solidFill>
+              </a:rPr>
+              <a:t>≥ 8 h above V_min</a:t>
+            </a:r>
+          </a:p>
+        </p:txBody>
+      </p:sp>
+      <p:sp>
+        <p:nvSpPr>
+          <p:cNvPr id="112" name="B112"/>
+          <p:cNvSpPr/>
+          <p:nvPr/>
+        </p:nvSpPr>
+        <p:spPr>
+          <a:xfrm>
+            <a:off x="685800" y="2400300"/>
+            <a:ext cx="4983480" cy="731520"/>
+          </a:xfrm>
+          <a:prstGeom prst="rect">
+            <a:avLst/>
+          </a:prstGeom>
+          <a:solidFill>
+            <a:srgbClr val="555960"/>
+          </a:solidFill>
+          <a:ln>
+            <a:noFill/>
+          </a:ln>
+        </p:spPr>
+        <p:txBody>
+          <a:bodyPr wrap="square" lIns="27432" tIns="22860" rIns="27432" bIns="22860" anchor="ctr"/>
+          <a:lstStyle/>
+          <a:p>
+            <a:pPr algn="ctr">
+              <a:spcAft>
+                <a:spcPts val="300"/>
+              </a:spcAft>
+              <a:buNone/>
+            </a:pPr>
+            <a:r>
+              <a:rPr lang="en-US" sz="1800" b="1" i="0" dirty="0">
+                <a:solidFill>
+                  <a:srgbClr val="FFFFFF"/>
+                </a:solidFill>
+              </a:rPr>
+              <a:t>REQUIRED DISTINCTIONS</a:t>
+            </a:r>
+          </a:p>
+          <a:p>
+            <a:pPr algn="ctr">
+              <a:spcAft>
+                <a:spcPts val="0"/>
+              </a:spcAft>
+              <a:buNone/>
+            </a:pPr>
+            <a:r>
+              <a:rPr lang="en-US" sz="1300" b="0" i="0" dirty="0">
+                <a:solidFill>
+                  <a:srgbClr val="FFFFFF"/>
+                </a:solidFill>
+              </a:rPr>
+              <a:t>what the model must preserve</a:t>
+            </a:r>
+          </a:p>
+        </p:txBody>
+      </p:sp>
+      <p:sp>
+        <p:nvSpPr>
+          <p:cNvPr id="113" name="R113"/>
+          <p:cNvSpPr/>
+          <p:nvPr/>
+        </p:nvSpPr>
+        <p:spPr>
+          <a:xfrm>
+            <a:off x="5852160" y="2400300"/>
+            <a:ext cx="2606040" cy="731520"/>
+          </a:xfrm>
+          <a:prstGeom prst="rect">
+            <a:avLst/>
+          </a:prstGeom>
+          <a:solidFill>
+            <a:srgbClr val="FBF8F2"/>
+          </a:solidFill>
+          <a:ln w="12700">
+            <a:solidFill>
+              <a:srgbClr val="C9B991"/>
+            </a:solidFill>
+          </a:ln>
+        </p:spPr>
+        <p:txBody>
+          <a:bodyPr wrap="square" lIns="27432" tIns="22860" rIns="27432" bIns="22860" anchor="ctr"/>
+          <a:lstStyle/>
+          <a:p>
+            <a:pPr algn="ctr">
+              <a:spcAft>
+                <a:spcPts val="0"/>
+              </a:spcAft>
+              <a:buNone/>
+            </a:pPr>
+            <a:r>
+              <a:rPr lang="en-US" sz="1200" b="0" i="0" dirty="0">
+                <a:solidFill>
+                  <a:srgbClr val="5C4826"/>
+                </a:solidFill>
+              </a:rPr>
+              <a:t>operating mode · power · duration · usable energy</a:t>
+            </a:r>
+          </a:p>
+        </p:txBody>
+      </p:sp>
+      <p:sp>
+        <p:nvSpPr>
+          <p:cNvPr id="114" name="B114"/>
+          <p:cNvSpPr/>
+          <p:nvPr/>
+        </p:nvSpPr>
+        <p:spPr>
+          <a:xfrm>
+            <a:off x="685800" y="3291840"/>
+            <a:ext cx="4983480" cy="731520"/>
+          </a:xfrm>
+          <a:prstGeom prst="rect">
+            <a:avLst/>
+          </a:prstGeom>
+          <a:solidFill>
+            <a:srgbClr val="8E6F3E"/>
+          </a:solidFill>
+          <a:ln>
+            <a:noFill/>
+          </a:ln>
+        </p:spPr>
+        <p:txBody>
+          <a:bodyPr wrap="square" lIns="27432" tIns="22860" rIns="27432" bIns="22860" anchor="ctr"/>
+          <a:lstStyle/>
+          <a:p>
+            <a:pPr algn="ctr">
+              <a:spcAft>
+                <a:spcPts val="300"/>
+              </a:spcAft>
+              <a:buNone/>
+            </a:pPr>
+            <a:r>
+              <a:rPr lang="en-US" sz="1800" b="1" i="0" dirty="0">
+                <a:solidFill>
+                  <a:srgbClr val="FFFFFF"/>
+                </a:solidFill>
+              </a:rPr>
+              <a:t>MODEL</a:t>
+            </a:r>
+          </a:p>
+          <a:p>
+            <a:pPr algn="ctr">
+              <a:spcAft>
+                <a:spcPts val="0"/>
+              </a:spcAft>
+              <a:buNone/>
+            </a:pPr>
+            <a:r>
+              <a:rPr lang="en-US" sz="1300" b="0" i="0" dirty="0">
+                <a:solidFill>
+                  <a:srgbClr val="FFFFFF"/>
+                </a:solidFill>
+              </a:rPr>
+              <a:t>the smallest statement that answers the question</a:t>
+            </a:r>
+          </a:p>
+        </p:txBody>
+      </p:sp>
+      <p:sp>
+        <p:nvSpPr>
+          <p:cNvPr id="115" name="R115"/>
+          <p:cNvSpPr/>
+          <p:nvPr/>
+        </p:nvSpPr>
+        <p:spPr>
+          <a:xfrm>
+            <a:off x="5852160" y="3291840"/>
+            <a:ext cx="2606040" cy="731520"/>
+          </a:xfrm>
+          <a:prstGeom prst="rect">
+            <a:avLst/>
+          </a:prstGeom>
+          <a:solidFill>
+            <a:srgbClr val="FBF8F2"/>
+          </a:solidFill>
+          <a:ln w="12700">
+            <a:solidFill>
+              <a:srgbClr val="C9B991"/>
+            </a:solidFill>
+          </a:ln>
+        </p:spPr>
+        <p:txBody>
+          <a:bodyPr wrap="square" lIns="27432" tIns="22860" rIns="27432" bIns="22860" anchor="ctr"/>
+          <a:lstStyle/>
+          <a:p>
+            <a:pPr algn="ctr">
+              <a:spcAft>
+                <a:spcPts val="0"/>
+              </a:spcAft>
+              <a:buNone/>
+            </a:pPr>
+            <a:r>
+              <a:rPr lang="en-US" sz="1300" b="1" i="0" dirty="0">
+                <a:solidFill>
+                  <a:srgbClr val="5C4826"/>
+                </a:solidFill>
+              </a:rPr>
+              <a:t>Σ P(m)·t(m)  ≤  E_usable</a:t>
+            </a:r>
+          </a:p>
+        </p:txBody>
+      </p:sp>
+      <p:sp>
+        <p:nvSpPr>
+          <p:cNvPr id="116" name="B116"/>
+          <p:cNvSpPr/>
+          <p:nvPr/>
+        </p:nvSpPr>
+        <p:spPr>
+          <a:xfrm>
+            <a:off x="685800" y="4183380"/>
+            <a:ext cx="4983480" cy="731520"/>
+          </a:xfrm>
+          <a:prstGeom prst="rect">
+            <a:avLst/>
+          </a:prstGeom>
+          <a:solidFill>
+            <a:srgbClr val="C9B991"/>
+          </a:solidFill>
+          <a:ln>
+            <a:noFill/>
+          </a:ln>
+        </p:spPr>
+        <p:txBody>
+          <a:bodyPr wrap="square" lIns="27432" tIns="22860" rIns="27432" bIns="22860" anchor="ctr"/>
+          <a:lstStyle/>
+          <a:p>
+            <a:pPr algn="ctr">
+              <a:spcAft>
+                <a:spcPts val="300"/>
+              </a:spcAft>
+              <a:buNone/>
+            </a:pPr>
+            <a:r>
+              <a:rPr lang="en-US" sz="1800" b="1" i="0" dirty="0">
+                <a:solidFill>
+                  <a:srgbClr val="5C4826"/>
+                </a:solidFill>
+              </a:rPr>
+              <a:t>LEGITIMATE FREEDOM</a:t>
+            </a:r>
+          </a:p>
+          <a:p>
+            <a:pPr algn="ctr">
+              <a:spcAft>
+                <a:spcPts val="0"/>
+              </a:spcAft>
+              <a:buNone/>
+            </a:pPr>
+            <a:r>
+              <a:rPr lang="en-US" sz="1300" b="0" i="0" dirty="0">
+                <a:solidFill>
+                  <a:srgbClr val="353638"/>
+                </a:solidFill>
+              </a:rPr>
+              <a:t>everything else: the agent’s degrees of freedom</a:t>
+            </a:r>
+          </a:p>
+        </p:txBody>
+      </p:sp>
+      <p:sp>
+        <p:nvSpPr>
+          <p:cNvPr id="117" name="R117"/>
+          <p:cNvSpPr/>
+          <p:nvPr/>
+        </p:nvSpPr>
+        <p:spPr>
+          <a:xfrm>
+            <a:off x="5852160" y="4183380"/>
+            <a:ext cx="2606040" cy="731520"/>
+          </a:xfrm>
+          <a:prstGeom prst="rect">
+            <a:avLst/>
+          </a:prstGeom>
+          <a:solidFill>
+            <a:srgbClr val="FBF8F2"/>
+          </a:solidFill>
+          <a:ln w="12700">
+            <a:solidFill>
+              <a:srgbClr val="C9B991"/>
+            </a:solidFill>
+          </a:ln>
+        </p:spPr>
+        <p:txBody>
+          <a:bodyPr wrap="square" lIns="27432" tIns="22860" rIns="27432" bIns="22860" anchor="ctr"/>
+          <a:lstStyle/>
+          <a:p>
+            <a:pPr algn="ctr">
+              <a:spcAft>
+                <a:spcPts val="0"/>
+              </a:spcAft>
+              <a:buNone/>
+            </a:pPr>
+            <a:r>
+              <a:rPr lang="en-US" sz="1200" b="0" i="0" dirty="0">
+                <a:solidFill>
+                  <a:srgbClr val="5C4826"/>
+                </a:solidFill>
+              </a:rPr>
+              <a:t>packet format · task names · PWM internals · display contents</a:t>
             </a:r>
           </a:p>
         </p:txBody>
       </p:sp>
       <p:cxnSp>
         <p:nvCxnSpPr>
-          <p:cNvPr id="102" name="AR0"/>
+          <p:cNvPr id="120" name="A0"/>
           <p:cNvCxnSpPr/>
           <p:nvPr/>
         </p:nvCxnSpPr>
         <p:spPr>
           <a:xfrm>
-            <a:off x="4572000" y="1965960"/>
-            <a:ext cx="0" cy="320040"/>
+            <a:off x="3177540" y="2240280"/>
+            <a:ext cx="0" cy="160020"/>
           </a:xfrm>
           <a:prstGeom prst="straightConnector1">
             <a:avLst/>
@@ -8833,74 +9310,16 @@
           </a:ln>
         </p:spPr>
       </p:cxnSp>
-      <p:sp>
-        <p:nvSpPr>
-          <p:cNvPr id="103" name="B1"/>
-          <p:cNvSpPr/>
-          <p:nvPr/>
-        </p:nvSpPr>
-        <p:spPr>
-          <a:xfrm>
-            <a:off x="914400" y="2286000"/>
-            <a:ext cx="7315200" cy="822960"/>
-          </a:xfrm>
-          <a:prstGeom prst="rect">
-            <a:avLst/>
-          </a:prstGeom>
-          <a:solidFill>
-            <a:srgbClr val="555960"/>
-          </a:solidFill>
-          <a:ln>
-            <a:noFill/>
-          </a:ln>
-        </p:spPr>
-        <p:txBody>
-          <a:bodyPr wrap="square" lIns="27432" tIns="22860" rIns="27432" bIns="22860" anchor="ctr"/>
-          <a:lstStyle/>
-          <a:p>
-            <a:pPr algn="ctr">
-              <a:spcAft>
-                <a:spcPts val="400"/>
-              </a:spcAft>
-              <a:buNone/>
-            </a:pPr>
-            <a:r>
-              <a:rPr lang="en-US" sz="2000" b="1" dirty="0">
-                <a:solidFill>
-                  <a:srgbClr val="FFFFFF"/>
-                </a:solidFill>
-              </a:rPr>
-              <a:t>REQUIRED DISTINCTIONS</a:t>
-            </a:r>
-          </a:p>
-          <a:p>
-            <a:pPr algn="ctr">
-              <a:spcAft>
-                <a:spcPts val="0"/>
-              </a:spcAft>
-              <a:buNone/>
-            </a:pPr>
-            <a:r>
-              <a:rPr lang="en-US" sz="1600" b="0" dirty="0">
-                <a:solidFill>
-                  <a:srgbClr val="FFFFFF"/>
-                </a:solidFill>
-              </a:rPr>
-              <a:t>what the model must preserve</a:t>
-            </a:r>
-          </a:p>
-        </p:txBody>
-      </p:sp>
       <p:cxnSp>
         <p:nvCxnSpPr>
-          <p:cNvPr id="104" name="AR1"/>
+          <p:cNvPr id="121" name="A1"/>
           <p:cNvCxnSpPr/>
           <p:nvPr/>
         </p:nvCxnSpPr>
         <p:spPr>
           <a:xfrm>
-            <a:off x="4572000" y="3108960"/>
-            <a:ext cx="0" cy="320040"/>
+            <a:off x="3177540" y="3131820"/>
+            <a:ext cx="0" cy="160020"/>
           </a:xfrm>
           <a:prstGeom prst="straightConnector1">
             <a:avLst/>
@@ -8913,46 +9332,50 @@
           </a:ln>
         </p:spPr>
       </p:cxnSp>
-      <p:sp>
-        <p:nvSpPr>
-          <p:cNvPr id="105" name="B2"/>
-          <p:cNvSpPr/>
-          <p:nvPr/>
-        </p:nvSpPr>
-        <p:spPr>
-          <a:xfrm>
-            <a:off x="914400" y="3429000"/>
-            <a:ext cx="7315200" cy="822960"/>
-          </a:xfrm>
-          <a:prstGeom prst="rect">
-            <a:avLst/>
-          </a:prstGeom>
-          <a:solidFill>
-            <a:srgbClr val="C9B991"/>
-          </a:solidFill>
+      <p:cxnSp>
+        <p:nvCxnSpPr>
+          <p:cNvPr id="122" name="A2"/>
+          <p:cNvCxnSpPr/>
+          <p:nvPr/>
+        </p:nvCxnSpPr>
+        <p:spPr>
+          <a:xfrm>
+            <a:off x="3177540" y="4023360"/>
+            <a:ext cx="0" cy="160020"/>
+          </a:xfrm>
+          <a:prstGeom prst="straightConnector1">
+            <a:avLst/>
+          </a:prstGeom>
+          <a:ln w="28575">
+            <a:solidFill>
+              <a:srgbClr val="8E6F3E"/>
+            </a:solidFill>
+            <a:tailEnd type="triangle" w="med" len="med"/>
+          </a:ln>
+        </p:spPr>
+      </p:cxnSp>
+      <p:sp>
+        <p:nvSpPr>
+          <p:cNvPr id="130" name="Ital"/>
+          <p:cNvSpPr txBox="1"/>
+          <p:nvPr/>
+        </p:nvSpPr>
+        <p:spPr>
+          <a:xfrm>
+            <a:off x="685800" y="5120640"/>
+            <a:ext cx="7772400" cy="365760"/>
+          </a:xfrm>
+          <a:prstGeom prst="rect">
+            <a:avLst/>
+          </a:prstGeom>
+          <a:noFill/>
           <a:ln>
             <a:noFill/>
           </a:ln>
         </p:spPr>
         <p:txBody>
-          <a:bodyPr wrap="square" lIns="27432" tIns="22860" rIns="27432" bIns="22860" anchor="ctr"/>
-          <a:lstStyle/>
-          <a:p>
-            <a:pPr algn="ctr">
-              <a:spcAft>
-                <a:spcPts val="400"/>
-              </a:spcAft>
-              <a:buNone/>
-            </a:pPr>
-            <a:r>
-              <a:rPr lang="en-US" sz="2000" b="1" dirty="0">
-                <a:solidFill>
-                  <a:srgbClr val="5C4826"/>
-                </a:solidFill>
-              </a:rPr>
-              <a:t>LEGITIMATE FREEDOM</a:t>
-            </a:r>
-          </a:p>
+          <a:bodyPr wrap="square" lIns="0" tIns="0" rIns="0" bIns="0" anchor="t"/>
+          <a:lstStyle/>
           <a:p>
             <a:pPr algn="ctr">
               <a:spcAft>
@@ -8961,46 +9384,6 @@
               <a:buNone/>
             </a:pPr>
             <a:r>
-              <a:rPr lang="en-US" sz="1600" dirty="0">
-                <a:solidFill>
-                  <a:srgbClr val="353638"/>
-                </a:solidFill>
-              </a:rPr>
-              <a:t>everything else: the agent’s degrees of freedom</a:t>
-            </a:r>
-          </a:p>
-        </p:txBody>
-      </p:sp>
-      <p:sp>
-        <p:nvSpPr>
-          <p:cNvPr id="106" name="Ital"/>
-          <p:cNvSpPr txBox="1"/>
-          <p:nvPr/>
-        </p:nvSpPr>
-        <p:spPr>
-          <a:xfrm>
-            <a:off x="685800" y="4526280"/>
-            <a:ext cx="7772400" cy="411480"/>
-          </a:xfrm>
-          <a:prstGeom prst="rect">
-            <a:avLst/>
-          </a:prstGeom>
-          <a:noFill/>
-          <a:ln>
-            <a:noFill/>
-          </a:ln>
-        </p:spPr>
-        <p:txBody>
-          <a:bodyPr wrap="square" lIns="0" tIns="0" rIns="0" bIns="0" anchor="t"/>
-          <a:lstStyle/>
-          <a:p>
-            <a:pPr algn="ctr">
-              <a:spcAft>
-                <a:spcPts val="0"/>
-              </a:spcAft>
-              <a:buNone/>
-            </a:pPr>
-            <a:r>
               <a:rPr lang="en-US" sz="1700" b="0" i="1" dirty="0">
                 <a:solidFill>
                   <a:srgbClr val="555960"/>
@@ -9013,7 +9396,7 @@
       </p:sp>
       <p:sp>
         <p:nvSpPr>
-          <p:cNvPr id="107" name="FooterBand"/>
+          <p:cNvPr id="131" name="FooterBand"/>
           <p:cNvSpPr/>
           <p:nvPr/>
         </p:nvSpPr>
@@ -9043,7 +9426,7 @@
               <a:buNone/>
             </a:pPr>
             <a:r>
-              <a:rPr lang="en-US" sz="2000" b="1" dirty="0">
+              <a:rPr lang="en-US" sz="2000" b="1" i="0" dirty="0">
                 <a:solidFill>
                   <a:srgbClr val="FFFFFF"/>
                 </a:solidFill>
@@ -9058,6 +9441,458 @@
   <p:clrMapOvr>
     <a:masterClrMapping/>
   </p:clrMapOvr>
+  <p:timing>
+    <p:tnLst>
+      <p:par>
+        <p:cTn id="1" dur="indefinite" restart="never" nodeType="tmRoot">
+          <p:childTnLst>
+            <p:seq concurrent="1" nextAc="seek">
+              <p:cTn id="2" dur="indefinite" nodeType="mainSeq">
+                <p:childTnLst>
+                  <p:par>
+                    <p:cTn id="3" fill="hold">
+                      <p:stCondLst>
+                        <p:cond delay="indefinite"/>
+                      </p:stCondLst>
+                      <p:childTnLst>
+                        <p:par>
+                          <p:cTn id="4" fill="hold">
+                            <p:stCondLst>
+                              <p:cond delay="0"/>
+                            </p:stCondLst>
+                            <p:childTnLst>
+                              <p:par>
+                                <p:cTn id="5" presetID="10" presetClass="entr" presetSubtype="0" fill="hold" nodeType="clickEffect">
+                                  <p:stCondLst>
+                                    <p:cond delay="0"/>
+                                  </p:stCondLst>
+                                  <p:childTnLst>
+                                    <p:set>
+                                      <p:cBhvr>
+                                        <p:cTn id="6" dur="1" fill="hold">
+                                          <p:stCondLst>
+                                            <p:cond delay="0"/>
+                                          </p:stCondLst>
+                                        </p:cTn>
+                                        <p:tgtEl>
+                                          <p:spTgt spid="120"/>
+                                        </p:tgtEl>
+                                        <p:attrNameLst>
+                                          <p:attrName>style.visibility</p:attrName>
+                                        </p:attrNameLst>
+                                      </p:cBhvr>
+                                      <p:to>
+                                        <p:strVal val="visible"/>
+                                      </p:to>
+                                    </p:set>
+                                    <p:animEffect transition="in" filter="fade">
+                                      <p:cBhvr>
+                                        <p:cTn id="7" dur="500"/>
+                                        <p:tgtEl>
+                                          <p:spTgt spid="120"/>
+                                        </p:tgtEl>
+                                      </p:cBhvr>
+                                    </p:animEffect>
+                                  </p:childTnLst>
+                                </p:cTn>
+                              </p:par>
+                              <p:par>
+                                <p:cTn id="8" presetID="10" presetClass="entr" presetSubtype="0" fill="hold" nodeType="withEffect">
+                                  <p:stCondLst>
+                                    <p:cond delay="0"/>
+                                  </p:stCondLst>
+                                  <p:childTnLst>
+                                    <p:set>
+                                      <p:cBhvr>
+                                        <p:cTn id="9" dur="1" fill="hold">
+                                          <p:stCondLst>
+                                            <p:cond delay="0"/>
+                                          </p:stCondLst>
+                                        </p:cTn>
+                                        <p:tgtEl>
+                                          <p:spTgt spid="112"/>
+                                        </p:tgtEl>
+                                        <p:attrNameLst>
+                                          <p:attrName>style.visibility</p:attrName>
+                                        </p:attrNameLst>
+                                      </p:cBhvr>
+                                      <p:to>
+                                        <p:strVal val="visible"/>
+                                      </p:to>
+                                    </p:set>
+                                    <p:animEffect transition="in" filter="fade">
+                                      <p:cBhvr>
+                                        <p:cTn id="10" dur="500"/>
+                                        <p:tgtEl>
+                                          <p:spTgt spid="112"/>
+                                        </p:tgtEl>
+                                      </p:cBhvr>
+                                    </p:animEffect>
+                                  </p:childTnLst>
+                                </p:cTn>
+                              </p:par>
+                              <p:par>
+                                <p:cTn id="11" presetID="10" presetClass="entr" presetSubtype="0" fill="hold" nodeType="withEffect">
+                                  <p:stCondLst>
+                                    <p:cond delay="0"/>
+                                  </p:stCondLst>
+                                  <p:childTnLst>
+                                    <p:set>
+                                      <p:cBhvr>
+                                        <p:cTn id="12" dur="1" fill="hold">
+                                          <p:stCondLst>
+                                            <p:cond delay="0"/>
+                                          </p:stCondLst>
+                                        </p:cTn>
+                                        <p:tgtEl>
+                                          <p:spTgt spid="113"/>
+                                        </p:tgtEl>
+                                        <p:attrNameLst>
+                                          <p:attrName>style.visibility</p:attrName>
+                                        </p:attrNameLst>
+                                      </p:cBhvr>
+                                      <p:to>
+                                        <p:strVal val="visible"/>
+                                      </p:to>
+                                    </p:set>
+                                    <p:animEffect transition="in" filter="fade">
+                                      <p:cBhvr>
+                                        <p:cTn id="13" dur="500"/>
+                                        <p:tgtEl>
+                                          <p:spTgt spid="113"/>
+                                        </p:tgtEl>
+                                      </p:cBhvr>
+                                    </p:animEffect>
+                                  </p:childTnLst>
+                                </p:cTn>
+                              </p:par>
+                            </p:childTnLst>
+                          </p:cTn>
+                        </p:par>
+                      </p:childTnLst>
+                    </p:cTn>
+                  </p:par>
+                  <p:par>
+                    <p:cTn id="14" fill="hold">
+                      <p:stCondLst>
+                        <p:cond delay="indefinite"/>
+                      </p:stCondLst>
+                      <p:childTnLst>
+                        <p:par>
+                          <p:cTn id="15" fill="hold">
+                            <p:stCondLst>
+                              <p:cond delay="0"/>
+                            </p:stCondLst>
+                            <p:childTnLst>
+                              <p:par>
+                                <p:cTn id="16" presetID="10" presetClass="entr" presetSubtype="0" fill="hold" nodeType="clickEffect">
+                                  <p:stCondLst>
+                                    <p:cond delay="0"/>
+                                  </p:stCondLst>
+                                  <p:childTnLst>
+                                    <p:set>
+                                      <p:cBhvr>
+                                        <p:cTn id="17" dur="1" fill="hold">
+                                          <p:stCondLst>
+                                            <p:cond delay="0"/>
+                                          </p:stCondLst>
+                                        </p:cTn>
+                                        <p:tgtEl>
+                                          <p:spTgt spid="121"/>
+                                        </p:tgtEl>
+                                        <p:attrNameLst>
+                                          <p:attrName>style.visibility</p:attrName>
+                                        </p:attrNameLst>
+                                      </p:cBhvr>
+                                      <p:to>
+                                        <p:strVal val="visible"/>
+                                      </p:to>
+                                    </p:set>
+                                    <p:animEffect transition="in" filter="fade">
+                                      <p:cBhvr>
+                                        <p:cTn id="18" dur="500"/>
+                                        <p:tgtEl>
+                                          <p:spTgt spid="121"/>
+                                        </p:tgtEl>
+                                      </p:cBhvr>
+                                    </p:animEffect>
+                                  </p:childTnLst>
+                                </p:cTn>
+                              </p:par>
+                              <p:par>
+                                <p:cTn id="19" presetID="10" presetClass="entr" presetSubtype="0" fill="hold" nodeType="withEffect">
+                                  <p:stCondLst>
+                                    <p:cond delay="0"/>
+                                  </p:stCondLst>
+                                  <p:childTnLst>
+                                    <p:set>
+                                      <p:cBhvr>
+                                        <p:cTn id="20" dur="1" fill="hold">
+                                          <p:stCondLst>
+                                            <p:cond delay="0"/>
+                                          </p:stCondLst>
+                                        </p:cTn>
+                                        <p:tgtEl>
+                                          <p:spTgt spid="114"/>
+                                        </p:tgtEl>
+                                        <p:attrNameLst>
+                                          <p:attrName>style.visibility</p:attrName>
+                                        </p:attrNameLst>
+                                      </p:cBhvr>
+                                      <p:to>
+                                        <p:strVal val="visible"/>
+                                      </p:to>
+                                    </p:set>
+                                    <p:animEffect transition="in" filter="fade">
+                                      <p:cBhvr>
+                                        <p:cTn id="21" dur="500"/>
+                                        <p:tgtEl>
+                                          <p:spTgt spid="114"/>
+                                        </p:tgtEl>
+                                      </p:cBhvr>
+                                    </p:animEffect>
+                                  </p:childTnLst>
+                                </p:cTn>
+                              </p:par>
+                              <p:par>
+                                <p:cTn id="22" presetID="10" presetClass="entr" presetSubtype="0" fill="hold" nodeType="withEffect">
+                                  <p:stCondLst>
+                                    <p:cond delay="0"/>
+                                  </p:stCondLst>
+                                  <p:childTnLst>
+                                    <p:set>
+                                      <p:cBhvr>
+                                        <p:cTn id="23" dur="1" fill="hold">
+                                          <p:stCondLst>
+                                            <p:cond delay="0"/>
+                                          </p:stCondLst>
+                                        </p:cTn>
+                                        <p:tgtEl>
+                                          <p:spTgt spid="115"/>
+                                        </p:tgtEl>
+                                        <p:attrNameLst>
+                                          <p:attrName>style.visibility</p:attrName>
+                                        </p:attrNameLst>
+                                      </p:cBhvr>
+                                      <p:to>
+                                        <p:strVal val="visible"/>
+                                      </p:to>
+                                    </p:set>
+                                    <p:animEffect transition="in" filter="fade">
+                                      <p:cBhvr>
+                                        <p:cTn id="24" dur="500"/>
+                                        <p:tgtEl>
+                                          <p:spTgt spid="115"/>
+                                        </p:tgtEl>
+                                      </p:cBhvr>
+                                    </p:animEffect>
+                                  </p:childTnLst>
+                                </p:cTn>
+                              </p:par>
+                            </p:childTnLst>
+                          </p:cTn>
+                        </p:par>
+                      </p:childTnLst>
+                    </p:cTn>
+                  </p:par>
+                  <p:par>
+                    <p:cTn id="25" fill="hold">
+                      <p:stCondLst>
+                        <p:cond delay="indefinite"/>
+                      </p:stCondLst>
+                      <p:childTnLst>
+                        <p:par>
+                          <p:cTn id="26" fill="hold">
+                            <p:stCondLst>
+                              <p:cond delay="0"/>
+                            </p:stCondLst>
+                            <p:childTnLst>
+                              <p:par>
+                                <p:cTn id="27" presetID="10" presetClass="entr" presetSubtype="0" fill="hold" nodeType="clickEffect">
+                                  <p:stCondLst>
+                                    <p:cond delay="0"/>
+                                  </p:stCondLst>
+                                  <p:childTnLst>
+                                    <p:set>
+                                      <p:cBhvr>
+                                        <p:cTn id="28" dur="1" fill="hold">
+                                          <p:stCondLst>
+                                            <p:cond delay="0"/>
+                                          </p:stCondLst>
+                                        </p:cTn>
+                                        <p:tgtEl>
+                                          <p:spTgt spid="122"/>
+                                        </p:tgtEl>
+                                        <p:attrNameLst>
+                                          <p:attrName>style.visibility</p:attrName>
+                                        </p:attrNameLst>
+                                      </p:cBhvr>
+                                      <p:to>
+                                        <p:strVal val="visible"/>
+                                      </p:to>
+                                    </p:set>
+                                    <p:animEffect transition="in" filter="fade">
+                                      <p:cBhvr>
+                                        <p:cTn id="29" dur="500"/>
+                                        <p:tgtEl>
+                                          <p:spTgt spid="122"/>
+                                        </p:tgtEl>
+                                      </p:cBhvr>
+                                    </p:animEffect>
+                                  </p:childTnLst>
+                                </p:cTn>
+                              </p:par>
+                              <p:par>
+                                <p:cTn id="30" presetID="10" presetClass="entr" presetSubtype="0" fill="hold" nodeType="withEffect">
+                                  <p:stCondLst>
+                                    <p:cond delay="0"/>
+                                  </p:stCondLst>
+                                  <p:childTnLst>
+                                    <p:set>
+                                      <p:cBhvr>
+                                        <p:cTn id="31" dur="1" fill="hold">
+                                          <p:stCondLst>
+                                            <p:cond delay="0"/>
+                                          </p:stCondLst>
+                                        </p:cTn>
+                                        <p:tgtEl>
+                                          <p:spTgt spid="116"/>
+                                        </p:tgtEl>
+                                        <p:attrNameLst>
+                                          <p:attrName>style.visibility</p:attrName>
+                                        </p:attrNameLst>
+                                      </p:cBhvr>
+                                      <p:to>
+                                        <p:strVal val="visible"/>
+                                      </p:to>
+                                    </p:set>
+                                    <p:animEffect transition="in" filter="fade">
+                                      <p:cBhvr>
+                                        <p:cTn id="32" dur="500"/>
+                                        <p:tgtEl>
+                                          <p:spTgt spid="116"/>
+                                        </p:tgtEl>
+                                      </p:cBhvr>
+                                    </p:animEffect>
+                                  </p:childTnLst>
+                                </p:cTn>
+                              </p:par>
+                              <p:par>
+                                <p:cTn id="33" presetID="10" presetClass="entr" presetSubtype="0" fill="hold" nodeType="withEffect">
+                                  <p:stCondLst>
+                                    <p:cond delay="0"/>
+                                  </p:stCondLst>
+                                  <p:childTnLst>
+                                    <p:set>
+                                      <p:cBhvr>
+                                        <p:cTn id="34" dur="1" fill="hold">
+                                          <p:stCondLst>
+                                            <p:cond delay="0"/>
+                                          </p:stCondLst>
+                                        </p:cTn>
+                                        <p:tgtEl>
+                                          <p:spTgt spid="117"/>
+                                        </p:tgtEl>
+                                        <p:attrNameLst>
+                                          <p:attrName>style.visibility</p:attrName>
+                                        </p:attrNameLst>
+                                      </p:cBhvr>
+                                      <p:to>
+                                        <p:strVal val="visible"/>
+                                      </p:to>
+                                    </p:set>
+                                    <p:animEffect transition="in" filter="fade">
+                                      <p:cBhvr>
+                                        <p:cTn id="35" dur="500"/>
+                                        <p:tgtEl>
+                                          <p:spTgt spid="117"/>
+                                        </p:tgtEl>
+                                      </p:cBhvr>
+                                    </p:animEffect>
+                                  </p:childTnLst>
+                                </p:cTn>
+                              </p:par>
+                            </p:childTnLst>
+                          </p:cTn>
+                        </p:par>
+                      </p:childTnLst>
+                    </p:cTn>
+                  </p:par>
+                  <p:par>
+                    <p:cTn id="36" fill="hold">
+                      <p:stCondLst>
+                        <p:cond delay="indefinite"/>
+                      </p:stCondLst>
+                      <p:childTnLst>
+                        <p:par>
+                          <p:cTn id="37" fill="hold">
+                            <p:stCondLst>
+                              <p:cond delay="0"/>
+                            </p:stCondLst>
+                            <p:childTnLst>
+                              <p:par>
+                                <p:cTn id="38" presetID="10" presetClass="entr" presetSubtype="0" fill="hold" nodeType="clickEffect">
+                                  <p:stCondLst>
+                                    <p:cond delay="0"/>
+                                  </p:stCondLst>
+                                  <p:childTnLst>
+                                    <p:set>
+                                      <p:cBhvr>
+                                        <p:cTn id="39" dur="1" fill="hold">
+                                          <p:stCondLst>
+                                            <p:cond delay="0"/>
+                                          </p:stCondLst>
+                                        </p:cTn>
+                                        <p:tgtEl>
+                                          <p:spTgt spid="130"/>
+                                        </p:tgtEl>
+                                        <p:attrNameLst>
+                                          <p:attrName>style.visibility</p:attrName>
+                                        </p:attrNameLst>
+                                      </p:cBhvr>
+                                      <p:to>
+                                        <p:strVal val="visible"/>
+                                      </p:to>
+                                    </p:set>
+                                    <p:animEffect transition="in" filter="fade">
+                                      <p:cBhvr>
+                                        <p:cTn id="40" dur="500"/>
+                                        <p:tgtEl>
+                                          <p:spTgt spid="130"/>
+                                        </p:tgtEl>
+                                      </p:cBhvr>
+                                    </p:animEffect>
+                                  </p:childTnLst>
+                                </p:cTn>
+                              </p:par>
+                            </p:childTnLst>
+                          </p:cTn>
+                        </p:par>
+                      </p:childTnLst>
+                    </p:cTn>
+                  </p:par>
+                </p:childTnLst>
+              </p:cTn>
+              <p:prevCondLst>
+                <p:cond evt="onPrev" delay="0">
+                  <p:tgtEl>
+                    <p:sldTgt/>
+                  </p:tgtEl>
+                </p:cond>
+              </p:prevCondLst>
+              <p:nextCondLst>
+                <p:cond evt="onNext" delay="0">
+                  <p:tgtEl>
+                    <p:sldTgt/>
+                  </p:tgtEl>
+                </p:cond>
+              </p:nextCondLst>
+            </p:seq>
+          </p:childTnLst>
+        </p:cTn>
+      </p:par>
+    </p:tnLst>
+  </p:timing>
 </p:sld>
 </file>
 

</xml_diff>

<commit_message>
slides(2-2-Modeling-1): retire the bottom-up framing from position 18's notes
The SECTION 3 header still briefed "two directions of reasoning — top-down
…, bottom-up …, then both worked live". There is no bottom-up section; its
successor question lands in the coda. The notes now say so explicitly, so a
later reader does not restore the missing half.

Also repointed: the spine note claimed the four-question discipline was
"named on 'Modeling is purposeful reduction'". That slide moved to position
26, after this one — the note no longer promises it here. Slide face
untouched.

Co-Authored-By: Claude Opus 5 <noreply@anthropic.com>
</commit_message>
<xml_diff>
--- a/course/lectures/act-2-delegation-and-control/02-modeling/2-2-Modeling-1-Purposeful-Reduction.pptx
+++ b/course/lectures/act-2-delegation-and-control/02-modeling/2-2-Modeling-1-Purposeful-Reduction.pptx
@@ -857,13 +857,19 @@
           <a:p>
             <a:r>
               <a:rPr dirty="0"/>
-              <a:t>The conceptual center of the lecture. Two directions of reasoning - top-down from the obligation, bottom-up from the proposed model - then both worked live on one embedded system.</a:t>
+              <a:t>The conceptual center of the lecture. One direction of reasoning, worked live on one embedded system: start from the engineering obligation, and let it decide what the model must preserve.</a:t>
             </a:r>
           </a:p>
           <a:p>
             <a:r>
               <a:rPr dirty="0"/>
-              <a:t>Spine strip: MODEL stage highlighted (stage 2 of the four-question discipline named on “Modeling is purposeful reduction”).</a:t>
+              <a:t>There is no bottom-up section. The question it used to ask - does every distinction we kept earn its place? - returns at the end of the lecture, as the economics of delegation.</a:t>
+            </a:r>
+          </a:p>
+          <a:p>
+            <a:r>
+              <a:rPr dirty="0"/>
+              <a:t>Spine strip: MODEL stage highlighted, stage 2 of the four-question discipline. The synthesis slide near the end of the lecture names all four; do not promise it here.</a:t>
             </a:r>
           </a:p>
           <a:p>

</xml_diff>

<commit_message>
slides(2-2-Modeling-1): name position 22 as 21's pattern instantiated
One added note line makes the pair's division of labour explicit — 21 teaches
the general pattern, 22 applies it to the battery — and one existing line now
records that the property here is the same one 21's rail compresses to fit
its column. Slide face untouched.

Co-Authored-By: Claude Opus 5 <noreply@anthropic.com>
</commit_message>
<xml_diff>
--- a/course/lectures/act-2-delegation-and-control/02-modeling/2-2-Modeling-1-Purposeful-Reduction.pptx
+++ b/course/lectures/act-2-delegation-and-control/02-modeling/2-2-Modeling-1-Purposeful-Reduction.pptx
@@ -1064,13 +1064,19 @@
           <a:p>
             <a:r>
               <a:rPr dirty="0"/>
+              <a:t>This is the previous slide's pattern instantiated - obligation, required distinctions, model, and an explicit list of what stayed free. Point back at the four-box flow once, then stay here.</a:t>
+            </a:r>
+          </a:p>
+          <a:p>
+            <a:r>
+              <a:rPr dirty="0"/>
               <a:t>The obligation (8+ hours above minimum safe voltage) demands: battery usable energy, power by operating mode, time in each mode, the safety threshold. Nothing else.</a:t>
             </a:r>
           </a:p>
           <a:p>
             <a:r>
               <a:rPr dirty="0"/>
-              <a:t>The system has become a small quantitative model; keep the math no harder than the sum. The PROPERTY beat of the spine happens here - point at it.</a:t>
+              <a:t>The system has become a small quantitative model; keep the math no harder than the sum. The PROPERTY beat of the spine happens here - point at it. It is the same property the previous slide's rail compressed.</a:t>
             </a:r>
           </a:p>
         </p:txBody>

</xml_diff>

<commit_message>
slides(2-2-Modeling-1): fold the review round into position 19
Four findings, all measured:

- the controller/battery thumbnail drew power CONTROLLER -> BATTERY, the
  opposite of the arrow on position 20 one slide later. Arrowhead moved to
  the controller.
- the arrow into the ENGINEERING QUESTION band still sat at the old
  full-width centre after that band was narrowed, so it pointed 1.25in right
  of the band's middle, at the thumbnail. Re-centred.
- the three card labels ran 13pt at 4.15:1 contrast — below the small-text
  floor for a lecture hall. 14pt bold clears it without touching the palette.
- the footer band was withheld until the last click, leaving the arrival
  frame 82% white; positions 20, 21 and 22 all show their footer on arrival.
  It now does too, and it is the band that carries this slide's whole point.

Co-Authored-By: Claude Opus 5 <noreply@anthropic.com>
</commit_message>
<xml_diff>
--- a/course/lectures/act-2-delegation-and-control/02-modeling/2-2-Modeling-1-Purposeful-Reduction.pptx
+++ b/course/lectures/act-2-delegation-and-control/02-modeling/2-2-Modeling-1-Purposeful-Reduction.pptx
@@ -19822,7 +19822,7 @@
               <a:buNone/>
             </a:pPr>
             <a:r>
-              <a:rPr lang="en-US" sz="1300" b="1" i="0" dirty="0">
+              <a:rPr lang="en-US" sz="1400" b="1" i="0" dirty="0">
                 <a:solidFill>
                   <a:srgbClr val="8E6F3E"/>
                 </a:solidFill>
@@ -19904,7 +19904,7 @@
               <a:buNone/>
             </a:pPr>
             <a:r>
-              <a:rPr lang="en-US" sz="1300" b="1" i="0" dirty="0">
+              <a:rPr lang="en-US" sz="1400" b="1" i="0" dirty="0">
                 <a:solidFill>
                   <a:srgbClr val="8E6F3E"/>
                 </a:solidFill>
@@ -19938,7 +19938,7 @@
         </p:nvCxnSpPr>
         <p:spPr>
           <a:xfrm>
-            <a:off x="4572000" y="3383280"/>
+            <a:off x="3200400" y="3383280"/>
             <a:ext cx="0" cy="228600"/>
           </a:xfrm>
           <a:prstGeom prst="straightConnector1">
@@ -19984,7 +19984,7 @@
               <a:buNone/>
             </a:pPr>
             <a:r>
-              <a:rPr lang="en-US" sz="1300" b="1" i="0" dirty="0">
+              <a:rPr lang="en-US" sz="1400" b="1" i="0" dirty="0">
                 <a:solidFill>
                   <a:srgbClr val="F5F1E8"/>
                 </a:solidFill>
@@ -20070,7 +20070,7 @@
             <a:solidFill>
               <a:srgbClr val="C9B991"/>
             </a:solidFill>
-            <a:tailEnd type="triangle" w="med" len="med"/>
+            <a:headEnd type="triangle" w="med" len="med"/>
           </a:ln>
         </p:spPr>
       </p:cxnSp>
@@ -20551,41 +20551,6 @@
                                         <p:cTn id="32" dur="500"/>
                                         <p:tgtEl>
                                           <p:spTgt spid="119"/>
-                                        </p:tgtEl>
-                                      </p:cBhvr>
-                                    </p:animEffect>
-                                  </p:childTnLst>
-                                </p:cTn>
-                              </p:par>
-                              <p:par>
-                                <p:cTn id="33" presetID="10" presetClass="entr" presetSubtype="0" fill="hold" nodeType="withEffect">
-                                  <p:stCondLst>
-                                    <p:cond delay="0"/>
-                                  </p:stCondLst>
-                                  <p:childTnLst>
-                                    <p:set>
-                                      <p:cBhvr>
-                                        <p:cTn id="34" dur="1" fill="hold">
-                                          <p:stCondLst>
-                                            <p:cond delay="0"/>
-                                          </p:stCondLst>
-                                        </p:cTn>
-                                        <p:tgtEl>
-                                          <p:spTgt spid="120"/>
-                                        </p:tgtEl>
-                                        <p:attrNameLst>
-                                          <p:attrName>style.visibility</p:attrName>
-                                        </p:attrNameLst>
-                                      </p:cBhvr>
-                                      <p:to>
-                                        <p:strVal val="visible"/>
-                                      </p:to>
-                                    </p:set>
-                                    <p:animEffect transition="in" filter="fade">
-                                      <p:cBhvr>
-                                        <p:cTn id="35" dur="500"/>
-                                        <p:tgtEl>
-                                          <p:spTgt spid="120"/>
                                         </p:tgtEl>
                                       </p:cBhvr>
                                     </p:animEffect>

</xml_diff>

<commit_message>
slides(2-2-Modeling-1): position 22's notes stop promising a reveal
The opening note told the lecturer to ask the room "what do we need to reason
about that? BEFORE revealing the model card." Position 22 has no animation at
all and never has — the ENERGY MODEL card is on screen from the first instant,
so the question was dead on arrival. Position 21's rail now names the four
quantities a slide earlier besides, which spoils the guess outright.

The note says so plainly and gives the lecturer a question that still works:
how did six components become four numbers? That is what the fan-in on this
slide actually shows, and 21 does not show it.

Last write of this unit. Notes only; slide face untouched.

Co-Authored-By: Claude Opus 5 <noreply@anthropic.com>
</commit_message>
<xml_diff>
--- a/course/lectures/act-2-delegation-and-control/02-modeling/2-2-Modeling-1-Purposeful-Reduction.pptx
+++ b/course/lectures/act-2-delegation-and-control/02-modeling/2-2-Modeling-1-Purposeful-Reduction.pptx
@@ -1058,7 +1058,7 @@
           <a:p>
             <a:r>
               <a:rPr dirty="0"/>
-              <a:t>Ask the room: what do we need to reason about that? BEFORE revealing the model card.</a:t>
+              <a:t>Everything on this slide is visible on arrival; there is no reveal. The previous slide's rail already named the four quantities, so do not ask the room to guess them - ask how six components became four numbers, and walk the fan-in.</a:t>
             </a:r>
           </a:p>
           <a:p>
@@ -1076,7 +1076,7 @@
           <a:p>
             <a:r>
               <a:rPr dirty="0"/>
-              <a:t>The system has become a small quantitative model; keep the math no harder than the sum. The PROPERTY beat of the spine happens here - point at it. It is the same property the previous slide's rail compressed.</a:t>
+              <a:t>The system has become a small quantitative model; keep the math no harder than the sum. The PROPERTY beat of the spine happens here - point at it. Same property, same notation, as the previous slide's rail.</a:t>
             </a:r>
           </a:p>
         </p:txBody>

</xml_diff>

<commit_message>
slides(2-2-Modeling-1): point position 23 at the two cases that exist
The CORRESPONDENCE header advertised a three-beat strip on its face, and the
middle beat -- MODEL -> MODEL, "refinement into a system of models" -- is the
material round 3 cut to Lecture 2. Students were being promised a beat the deck
no longer delivers (U-1' F1, re-confirmed by U-3).

The strip now carries the two cases the section actually contains, one failure
and one success: "x TOO MUCH REDUCTION / a required distinction, erased" and
"v GOOD REDUCTION / a free choice, safely changed". Notes replace the dead
three-beat preview with the two-case frame, renumber the back-reference from
Section 2 to Section 3, drop the provenance claim that both cases come from a
production system, and keep a terminology guard pointing model refinement at
Lecture 2.

Question line, sub-line, rule and spine strip are untouched.

Co-Authored-By: Claude Opus 5 <noreply@anthropic.com>
</commit_message>
<xml_diff>
--- a/course/lectures/act-2-delegation-and-control/02-modeling/2-2-Modeling-1-Purposeful-Reduction.pptx
+++ b/course/lectures/act-2-delegation-and-control/02-modeling/2-2-Modeling-1-Purposeful-Reduction.pptx
@@ -1292,25 +1292,31 @@
           <a:p>
             <a:r>
               <a:rPr lang="en-US" dirty="0"/>
-              <a:t>ROLE CHANGE, stated aloud: Section 2 taught how to reason about a reduction. This section asks what connects a model to the things it deliberately left free, and how you find out whether that connection holds.</a:t>
+              <a:t>ROLE CHANGE, stated aloud: Section 3 taught how to reason about a reduction. This section asks how you find out whether you reduced the right things.</a:t>
             </a:r>
           </a:p>
           <a:p>
             <a:r>
               <a:rPr lang="en-US" dirty="0"/>
-              <a:t>Three beats, in this order: one model with several legitimate implementations; models that refine into other models; then two production cases that graded a correspondence claim. The section is named for the claim, not for the evidence.</a:t>
+              <a:t>The frame: we have spent this lecture telling you to leave things out. Correspondence is the test of whether you left out the right ones. Two cases — one failure, one success.</a:t>
             </a:r>
           </a:p>
           <a:p>
             <a:r>
               <a:rPr lang="en-US" dirty="0"/>
-              <a:t>Both production cases come from the instructor's production system. The lease's omission was vindicated; the account quota's was refuted. A hypothetical can teach judgment; only production can grade it.</a:t>
+              <a:t>Both cases use the same three tiers: the facts, then the model itself, then the consequence. The models are deliberately different kinds — a data schema and a behavioural model — so nobody leaves thinking "model" means boxes and arrows.</a:t>
             </a:r>
           </a:p>
           <a:p>
             <a:r>
               <a:rPr lang="en-US" dirty="0"/>
-              <a:t>TERMINOLOGY GUARD, for your own speech as much as for the slides: model refinement, or a system of models. Never use the meta- prefix here — a model of a modeling language is a different idea and not what this section is about.</a:t>
+              <a:t>Both cases are self-contained. Neither needs any project background to tell; if you find yourself explaining where they came from, you have added something the case does not need.</a:t>
+            </a:r>
+          </a:p>
+          <a:p>
+            <a:r>
+              <a:rPr lang="en-US" dirty="0"/>
+              <a:t>TERMINOLOGY GUARD, for your own speech as much as for the slides: this section is about correspondence between a model and whatever realizes it. Model refinement — one model inducing others — is Lecture 2, and this deck no longer promises it. Never use the meta- prefix here.</a:t>
             </a:r>
           </a:p>
         </p:txBody>
@@ -13922,8 +13928,8 @@
         </p:nvSpPr>
         <p:spPr>
           <a:xfrm>
-            <a:off x="274320" y="3977640"/>
-            <a:ext cx="2743200" cy="640080"/>
+            <a:off x="1143000" y="3977640"/>
+            <a:ext cx="3200400" cy="640080"/>
           </a:xfrm>
           <a:prstGeom prst="rect">
             <a:avLst/>
@@ -13949,7 +13955,7 @@
                   <a:srgbClr val="8E6F3E"/>
                 </a:solidFill>
               </a:rPr>
-              <a:t xml:space="preserve">MODEL → IMPLEMENTATIONS</a:t>
+              <a:t xml:space="preserve">✗  TOO MUCH REDUCTION</a:t>
             </a:r>
           </a:p>
           <a:p>
@@ -13965,21 +13971,21 @@
                   <a:srgbClr val="555960"/>
                 </a:solidFill>
               </a:rPr>
-              <a:t xml:space="preserve">one model, many implementations</a:t>
-            </a:r>
-          </a:p>
-        </p:txBody>
-      </p:sp>
-      <p:sp>
-        <p:nvSpPr>
-          <p:cNvPr id="132" name="VTag2"/>
+              <a:t xml:space="preserve">a required distinction, erased</a:t>
+            </a:r>
+          </a:p>
+        </p:txBody>
+      </p:sp>
+      <p:sp>
+        <p:nvSpPr>
+          <p:cNvPr id="133" name="VTag3"/>
           <p:cNvSpPr txBox="1"/>
           <p:nvPr/>
         </p:nvSpPr>
         <p:spPr>
           <a:xfrm>
-            <a:off x="3200400" y="3977640"/>
-            <a:ext cx="2743200" cy="640080"/>
+            <a:off x="4800600" y="3977640"/>
+            <a:ext cx="3200400" cy="640080"/>
           </a:xfrm>
           <a:prstGeom prst="rect">
             <a:avLst/>
@@ -14005,7 +14011,7 @@
                   <a:srgbClr val="8E6F3E"/>
                 </a:solidFill>
               </a:rPr>
-              <a:t xml:space="preserve">MODEL → MODEL</a:t>
+              <a:t xml:space="preserve">✓  GOOD REDUCTION</a:t>
             </a:r>
           </a:p>
           <a:p>
@@ -14021,63 +14027,7 @@
                   <a:srgbClr val="555960"/>
                 </a:solidFill>
               </a:rPr>
-              <a:t xml:space="preserve">refinement into a system of models</a:t>
-            </a:r>
-          </a:p>
-        </p:txBody>
-      </p:sp>
-      <p:sp>
-        <p:nvSpPr>
-          <p:cNvPr id="133" name="VTag3"/>
-          <p:cNvSpPr txBox="1"/>
-          <p:nvPr/>
-        </p:nvSpPr>
-        <p:spPr>
-          <a:xfrm>
-            <a:off x="6126480" y="3977640"/>
-            <a:ext cx="2743200" cy="640080"/>
-          </a:xfrm>
-          <a:prstGeom prst="rect">
-            <a:avLst/>
-          </a:prstGeom>
-          <a:noFill/>
-          <a:ln>
-            <a:noFill/>
-          </a:ln>
-        </p:spPr>
-        <p:txBody>
-          <a:bodyPr wrap="square" lIns="0" tIns="0" rIns="0" bIns="0" anchor="ctr"/>
-          <a:lstStyle/>
-          <a:p>
-            <a:pPr algn="ctr">
-              <a:spcAft>
-                <a:spcPts val="0"/>
-              </a:spcAft>
-              <a:buNone/>
-            </a:pPr>
-            <a:r>
-              <a:rPr lang="en-US" sz="1600" b="1" i="0" dirty="0">
-                <a:solidFill>
-                  <a:srgbClr val="8E6F3E"/>
-                </a:solidFill>
-              </a:rPr>
-              <a:t xml:space="preserve">MODEL → EVIDENCE</a:t>
-            </a:r>
-          </a:p>
-          <a:p>
-            <a:pPr algn="ctr">
-              <a:spcAft>
-                <a:spcPts val="0"/>
-              </a:spcAft>
-              <a:buNone/>
-            </a:pPr>
-            <a:r>
-              <a:rPr lang="en-US" sz="1400" b="0" i="0" dirty="0">
-                <a:solidFill>
-                  <a:srgbClr val="555960"/>
-                </a:solidFill>
-              </a:rPr>
-              <a:t xml:space="preserve">✗ the quota  ·  ✓ the lease</a:t>
+              <a:t xml:space="preserve">a free choice, safely changed</a:t>
             </a:r>
           </a:p>
         </p:txBody>

</xml_diff>